<commit_message>
EDA, agregar dispersion y tablas pivote
</commit_message>
<xml_diff>
--- a/PRESENTACION.pptx
+++ b/PRESENTACION.pptx
@@ -207,7 +207,7 @@
             </c:spPr>
             <c:extLst>
               <c:ext xmlns:c16="http://schemas.microsoft.com/office/drawing/2014/chart" uri="{C3380CC4-5D6E-409C-BE32-E72D297353CC}">
-                <c16:uniqueId val="{00000001-2A58-4B65-9023-DC9A707F2F27}"/>
+                <c16:uniqueId val="{00000001-D9A9-43B9-99B2-1E42F13B03AE}"/>
               </c:ext>
             </c:extLst>
           </c:dPt>
@@ -222,7 +222,7 @@
             </c:spPr>
             <c:extLst>
               <c:ext xmlns:c16="http://schemas.microsoft.com/office/drawing/2014/chart" uri="{C3380CC4-5D6E-409C-BE32-E72D297353CC}">
-                <c16:uniqueId val="{00000003-2A58-4B65-9023-DC9A707F2F27}"/>
+                <c16:uniqueId val="{00000003-D9A9-43B9-99B2-1E42F13B03AE}"/>
               </c:ext>
             </c:extLst>
           </c:dPt>
@@ -255,7 +255,7 @@
               <c:extLst>
                 <c:ext xmlns:c15="http://schemas.microsoft.com/office/drawing/2012/chart" uri="{CE6537A1-D6FC-4f65-9D91-7224C49458BB}"/>
                 <c:ext xmlns:c16="http://schemas.microsoft.com/office/drawing/2014/chart" uri="{C3380CC4-5D6E-409C-BE32-E72D297353CC}">
-                  <c16:uniqueId val="{00000001-2A58-4B65-9023-DC9A707F2F27}"/>
+                  <c16:uniqueId val="{00000001-D9A9-43B9-99B2-1E42F13B03AE}"/>
                 </c:ext>
               </c:extLst>
             </c:dLbl>
@@ -287,7 +287,7 @@
               <c:extLst>
                 <c:ext xmlns:c15="http://schemas.microsoft.com/office/drawing/2012/chart" uri="{CE6537A1-D6FC-4f65-9D91-7224C49458BB}"/>
                 <c:ext xmlns:c16="http://schemas.microsoft.com/office/drawing/2014/chart" uri="{C3380CC4-5D6E-409C-BE32-E72D297353CC}">
-                  <c16:uniqueId val="{00000003-2A58-4B65-9023-DC9A707F2F27}"/>
+                  <c16:uniqueId val="{00000003-D9A9-43B9-99B2-1E42F13B03AE}"/>
                 </c:ext>
               </c:extLst>
             </c:dLbl>
@@ -357,7 +357,7 @@
           </c:val>
           <c:extLst>
             <c:ext xmlns:c16="http://schemas.microsoft.com/office/drawing/2014/chart" uri="{C3380CC4-5D6E-409C-BE32-E72D297353CC}">
-              <c16:uniqueId val="{00000004-2A58-4B65-9023-DC9A707F2F27}"/>
+              <c16:uniqueId val="{00000004-D9A9-43B9-99B2-1E42F13B03AE}"/>
             </c:ext>
           </c:extLst>
         </c:ser>
@@ -455,7 +455,7 @@
             <c:bubble3D val="0"/>
             <c:extLst>
               <c:ext xmlns:c16="http://schemas.microsoft.com/office/drawing/2014/chart" uri="{C3380CC4-5D6E-409C-BE32-E72D297353CC}">
-                <c16:uniqueId val="{00000001-C7EA-4A60-8A44-719B1FCC74AD}"/>
+                <c16:uniqueId val="{00000001-6CFE-44F6-8626-33ADD0173059}"/>
               </c:ext>
             </c:extLst>
           </c:dPt>
@@ -471,7 +471,7 @@
             </c:spPr>
             <c:extLst>
               <c:ext xmlns:c16="http://schemas.microsoft.com/office/drawing/2014/chart" uri="{C3380CC4-5D6E-409C-BE32-E72D297353CC}">
-                <c16:uniqueId val="{00000003-C7EA-4A60-8A44-719B1FCC74AD}"/>
+                <c16:uniqueId val="{00000003-6CFE-44F6-8626-33ADD0173059}"/>
               </c:ext>
             </c:extLst>
           </c:dPt>
@@ -545,7 +545,7 @@
           </c:val>
           <c:extLst>
             <c:ext xmlns:c16="http://schemas.microsoft.com/office/drawing/2014/chart" uri="{C3380CC4-5D6E-409C-BE32-E72D297353CC}">
-              <c16:uniqueId val="{00000004-C7EA-4A60-8A44-719B1FCC74AD}"/>
+              <c16:uniqueId val="{00000004-6CFE-44F6-8626-33ADD0173059}"/>
             </c:ext>
           </c:extLst>
         </c:ser>
@@ -713,7 +713,7 @@
             <c:bubble3D val="0"/>
             <c:extLst>
               <c:ext xmlns:c16="http://schemas.microsoft.com/office/drawing/2014/chart" uri="{C3380CC4-5D6E-409C-BE32-E72D297353CC}">
-                <c16:uniqueId val="{00000001-1951-4F8A-9560-E27C3F002B3B}"/>
+                <c16:uniqueId val="{00000001-39F2-4A5A-92F3-5EC0E0FFBEAC}"/>
               </c:ext>
             </c:extLst>
           </c:dPt>
@@ -729,7 +729,7 @@
             </c:spPr>
             <c:extLst>
               <c:ext xmlns:c16="http://schemas.microsoft.com/office/drawing/2014/chart" uri="{C3380CC4-5D6E-409C-BE32-E72D297353CC}">
-                <c16:uniqueId val="{00000003-1951-4F8A-9560-E27C3F002B3B}"/>
+                <c16:uniqueId val="{00000003-39F2-4A5A-92F3-5EC0E0FFBEAC}"/>
               </c:ext>
             </c:extLst>
           </c:dPt>
@@ -745,7 +745,7 @@
             </c:spPr>
             <c:extLst>
               <c:ext xmlns:c16="http://schemas.microsoft.com/office/drawing/2014/chart" uri="{C3380CC4-5D6E-409C-BE32-E72D297353CC}">
-                <c16:uniqueId val="{00000005-1951-4F8A-9560-E27C3F002B3B}"/>
+                <c16:uniqueId val="{00000005-39F2-4A5A-92F3-5EC0E0FFBEAC}"/>
               </c:ext>
             </c:extLst>
           </c:dPt>
@@ -761,7 +761,7 @@
             </c:spPr>
             <c:extLst>
               <c:ext xmlns:c16="http://schemas.microsoft.com/office/drawing/2014/chart" uri="{C3380CC4-5D6E-409C-BE32-E72D297353CC}">
-                <c16:uniqueId val="{00000007-1951-4F8A-9560-E27C3F002B3B}"/>
+                <c16:uniqueId val="{00000007-39F2-4A5A-92F3-5EC0E0FFBEAC}"/>
               </c:ext>
             </c:extLst>
           </c:dPt>
@@ -849,7 +849,7 @@
           </c:val>
           <c:extLst>
             <c:ext xmlns:c16="http://schemas.microsoft.com/office/drawing/2014/chart" uri="{C3380CC4-5D6E-409C-BE32-E72D297353CC}">
-              <c16:uniqueId val="{00000008-1951-4F8A-9560-E27C3F002B3B}"/>
+              <c16:uniqueId val="{00000008-39F2-4A5A-92F3-5EC0E0FFBEAC}"/>
             </c:ext>
           </c:extLst>
         </c:ser>
@@ -988,7 +988,7 @@
             <c:bubble3D val="0"/>
             <c:extLst>
               <c:ext xmlns:c16="http://schemas.microsoft.com/office/drawing/2014/chart" uri="{C3380CC4-5D6E-409C-BE32-E72D297353CC}">
-                <c16:uniqueId val="{00000001-B85E-42BC-87A7-574C5FBD7F09}"/>
+                <c16:uniqueId val="{00000001-8CAB-4BDD-A07D-7DD100802456}"/>
               </c:ext>
             </c:extLst>
           </c:dPt>
@@ -998,7 +998,7 @@
             <c:bubble3D val="0"/>
             <c:extLst>
               <c:ext xmlns:c16="http://schemas.microsoft.com/office/drawing/2014/chart" uri="{C3380CC4-5D6E-409C-BE32-E72D297353CC}">
-                <c16:uniqueId val="{00000003-B85E-42BC-87A7-574C5FBD7F09}"/>
+                <c16:uniqueId val="{00000003-8CAB-4BDD-A07D-7DD100802456}"/>
               </c:ext>
             </c:extLst>
           </c:dPt>
@@ -1008,7 +1008,7 @@
             <c:bubble3D val="0"/>
             <c:extLst>
               <c:ext xmlns:c16="http://schemas.microsoft.com/office/drawing/2014/chart" uri="{C3380CC4-5D6E-409C-BE32-E72D297353CC}">
-                <c16:uniqueId val="{00000005-B85E-42BC-87A7-574C5FBD7F09}"/>
+                <c16:uniqueId val="{00000005-8CAB-4BDD-A07D-7DD100802456}"/>
               </c:ext>
             </c:extLst>
           </c:dPt>
@@ -1024,7 +1024,7 @@
             </c:spPr>
             <c:extLst>
               <c:ext xmlns:c16="http://schemas.microsoft.com/office/drawing/2014/chart" uri="{C3380CC4-5D6E-409C-BE32-E72D297353CC}">
-                <c16:uniqueId val="{00000007-B85E-42BC-87A7-574C5FBD7F09}"/>
+                <c16:uniqueId val="{00000007-8CAB-4BDD-A07D-7DD100802456}"/>
               </c:ext>
             </c:extLst>
           </c:dPt>
@@ -1040,7 +1040,7 @@
             </c:spPr>
             <c:extLst>
               <c:ext xmlns:c16="http://schemas.microsoft.com/office/drawing/2014/chart" uri="{C3380CC4-5D6E-409C-BE32-E72D297353CC}">
-                <c16:uniqueId val="{00000009-B85E-42BC-87A7-574C5FBD7F09}"/>
+                <c16:uniqueId val="{00000009-8CAB-4BDD-A07D-7DD100802456}"/>
               </c:ext>
             </c:extLst>
           </c:dPt>
@@ -1056,7 +1056,7 @@
             </c:spPr>
             <c:extLst>
               <c:ext xmlns:c16="http://schemas.microsoft.com/office/drawing/2014/chart" uri="{C3380CC4-5D6E-409C-BE32-E72D297353CC}">
-                <c16:uniqueId val="{0000000B-B85E-42BC-87A7-574C5FBD7F09}"/>
+                <c16:uniqueId val="{0000000B-8CAB-4BDD-A07D-7DD100802456}"/>
               </c:ext>
             </c:extLst>
           </c:dPt>
@@ -1072,7 +1072,7 @@
             </c:spPr>
             <c:extLst>
               <c:ext xmlns:c16="http://schemas.microsoft.com/office/drawing/2014/chart" uri="{C3380CC4-5D6E-409C-BE32-E72D297353CC}">
-                <c16:uniqueId val="{0000000D-B85E-42BC-87A7-574C5FBD7F09}"/>
+                <c16:uniqueId val="{0000000D-8CAB-4BDD-A07D-7DD100802456}"/>
               </c:ext>
             </c:extLst>
           </c:dPt>
@@ -1088,7 +1088,7 @@
             </c:spPr>
             <c:extLst>
               <c:ext xmlns:c16="http://schemas.microsoft.com/office/drawing/2014/chart" uri="{C3380CC4-5D6E-409C-BE32-E72D297353CC}">
-                <c16:uniqueId val="{0000000F-B85E-42BC-87A7-574C5FBD7F09}"/>
+                <c16:uniqueId val="{0000000F-8CAB-4BDD-A07D-7DD100802456}"/>
               </c:ext>
             </c:extLst>
           </c:dPt>
@@ -1196,7 +1196,7 @@
           </c:val>
           <c:extLst>
             <c:ext xmlns:c16="http://schemas.microsoft.com/office/drawing/2014/chart" uri="{C3380CC4-5D6E-409C-BE32-E72D297353CC}">
-              <c16:uniqueId val="{00000010-B85E-42BC-87A7-574C5FBD7F09}"/>
+              <c16:uniqueId val="{00000010-8CAB-4BDD-A07D-7DD100802456}"/>
             </c:ext>
           </c:extLst>
         </c:ser>
@@ -1295,304 +1295,6 @@
 </file>
 
 <file path=ppt/charts/chart5.xml><?xml version="1.0" encoding="utf-8"?>
-<c:chartSpace xmlns:c="http://schemas.openxmlformats.org/drawingml/2006/chart" xmlns:a="http://schemas.openxmlformats.org/drawingml/2006/main" xmlns:r="http://schemas.openxmlformats.org/officeDocument/2006/relationships" xmlns:c16r2="http://schemas.microsoft.com/office/drawing/2015/06/chart">
-  <c:date1904 val="0"/>
-  <c:lang val="es-ES"/>
-  <c:roundedCorners val="1"/>
-  <c:style val="2"/>
-  <c:chart>
-    <c:title>
-      <c:tx>
-        <c:rich>
-          <a:bodyPr/>
-          <a:lstStyle/>
-          <a:p>
-            <a:pPr>
-              <a:defRPr sz="1300" b="0" i="0" u="none" strike="noStrike">
-                <a:solidFill>
-                  <a:srgbClr val="1E2761"/>
-                </a:solidFill>
-                <a:latin typeface="Calibri"/>
-              </a:defRPr>
-            </a:pPr>
-            <a:r>
-              <a:rPr lang="es-CO" sz="1300" b="0" i="0" u="none" strike="noStrike">
-                <a:solidFill>
-                  <a:srgbClr val="1E2761"/>
-                </a:solidFill>
-                <a:latin typeface="Calibri"/>
-              </a:rPr>
-              <a:t>PCA — varianza acumulada por componente</a:t>
-            </a:r>
-          </a:p>
-        </c:rich>
-      </c:tx>
-      <c:overlay val="0"/>
-    </c:title>
-    <c:autoTitleDeleted val="0"/>
-    <c:plotArea>
-      <c:layout/>
-      <c:lineChart>
-        <c:grouping val="standard"/>
-        <c:varyColors val="0"/>
-        <c:ser>
-          <c:idx val="0"/>
-          <c:order val="0"/>
-          <c:tx>
-            <c:strRef>
-              <c:f>Sheet1!$B$1</c:f>
-              <c:strCache>
-                <c:ptCount val="1"/>
-                <c:pt idx="0">
-                  <c:v>Varianza acumulada (%)</c:v>
-                </c:pt>
-              </c:strCache>
-            </c:strRef>
-          </c:tx>
-          <c:spPr>
-            <a:ln w="38100" cap="flat">
-              <a:solidFill>
-                <a:srgbClr val="1E2761"/>
-              </a:solidFill>
-              <a:prstDash val="solid"/>
-              <a:round/>
-            </a:ln>
-            <a:effectLst/>
-          </c:spPr>
-          <c:marker>
-            <c:symbol val="circle"/>
-            <c:size val="6"/>
-            <c:spPr>
-              <a:solidFill>
-                <a:srgbClr val="1E2761"/>
-              </a:solidFill>
-              <a:ln w="9525" cap="flat">
-                <a:solidFill>
-                  <a:srgbClr val="1E2761"/>
-                </a:solidFill>
-                <a:prstDash val="solid"/>
-                <a:round/>
-              </a:ln>
-              <a:effectLst/>
-            </c:spPr>
-          </c:marker>
-          <c:cat>
-            <c:strRef>
-              <c:f>Sheet1!$A$2:$A$11</c:f>
-              <c:strCache>
-                <c:ptCount val="10"/>
-                <c:pt idx="0">
-                  <c:v>PC1</c:v>
-                </c:pt>
-                <c:pt idx="1">
-                  <c:v>PC2</c:v>
-                </c:pt>
-                <c:pt idx="2">
-                  <c:v>PC3</c:v>
-                </c:pt>
-                <c:pt idx="3">
-                  <c:v>PC4</c:v>
-                </c:pt>
-                <c:pt idx="4">
-                  <c:v>PC5</c:v>
-                </c:pt>
-                <c:pt idx="5">
-                  <c:v>PC6</c:v>
-                </c:pt>
-                <c:pt idx="6">
-                  <c:v>PC7</c:v>
-                </c:pt>
-                <c:pt idx="7">
-                  <c:v>PC8</c:v>
-                </c:pt>
-                <c:pt idx="8">
-                  <c:v>PC9</c:v>
-                </c:pt>
-                <c:pt idx="9">
-                  <c:v>PC10</c:v>
-                </c:pt>
-              </c:strCache>
-            </c:strRef>
-          </c:cat>
-          <c:val>
-            <c:numRef>
-              <c:f>Sheet1!$B$2:$B$11</c:f>
-              <c:numCache>
-                <c:formatCode>General</c:formatCode>
-                <c:ptCount val="10"/>
-                <c:pt idx="0">
-                  <c:v>20.100000000000001</c:v>
-                </c:pt>
-                <c:pt idx="1">
-                  <c:v>31.8</c:v>
-                </c:pt>
-                <c:pt idx="2">
-                  <c:v>41.1</c:v>
-                </c:pt>
-                <c:pt idx="3">
-                  <c:v>48</c:v>
-                </c:pt>
-                <c:pt idx="4">
-                  <c:v>54.7</c:v>
-                </c:pt>
-                <c:pt idx="5">
-                  <c:v>60.8</c:v>
-                </c:pt>
-                <c:pt idx="6">
-                  <c:v>66.7</c:v>
-                </c:pt>
-                <c:pt idx="7">
-                  <c:v>72.5</c:v>
-                </c:pt>
-                <c:pt idx="8">
-                  <c:v>77</c:v>
-                </c:pt>
-                <c:pt idx="9">
-                  <c:v>81.2</c:v>
-                </c:pt>
-              </c:numCache>
-            </c:numRef>
-          </c:val>
-          <c:smooth val="0"/>
-          <c:extLst>
-            <c:ext xmlns:c16="http://schemas.microsoft.com/office/drawing/2014/chart" uri="{C3380CC4-5D6E-409C-BE32-E72D297353CC}">
-              <c16:uniqueId val="{00000000-3E6D-4810-AA29-5FBBAB2CFD27}"/>
-            </c:ext>
-          </c:extLst>
-        </c:ser>
-        <c:dLbls>
-          <c:showLegendKey val="0"/>
-          <c:showVal val="0"/>
-          <c:showCatName val="0"/>
-          <c:showSerName val="0"/>
-          <c:showPercent val="0"/>
-          <c:showBubbleSize val="0"/>
-        </c:dLbls>
-        <c:marker val="1"/>
-        <c:smooth val="0"/>
-        <c:axId val="2094734554"/>
-        <c:axId val="2094734552"/>
-      </c:lineChart>
-      <c:catAx>
-        <c:axId val="2094734554"/>
-        <c:scaling>
-          <c:orientation val="minMax"/>
-        </c:scaling>
-        <c:delete val="0"/>
-        <c:axPos val="b"/>
-        <c:numFmt formatCode="General" sourceLinked="1"/>
-        <c:majorTickMark val="out"/>
-        <c:minorTickMark val="none"/>
-        <c:tickLblPos val="low"/>
-        <c:spPr>
-          <a:ln w="12700" cap="flat">
-            <a:solidFill>
-              <a:srgbClr val="888888"/>
-            </a:solidFill>
-            <a:prstDash val="solid"/>
-            <a:round/>
-          </a:ln>
-        </c:spPr>
-        <c:txPr>
-          <a:bodyPr/>
-          <a:lstStyle/>
-          <a:p>
-            <a:pPr>
-              <a:defRPr sz="1000" b="0" i="0" u="none" strike="noStrike">
-                <a:solidFill>
-                  <a:srgbClr val="5A5F73"/>
-                </a:solidFill>
-                <a:latin typeface="Calibri"/>
-              </a:defRPr>
-            </a:pPr>
-            <a:endParaRPr lang="en-US"/>
-          </a:p>
-        </c:txPr>
-        <c:crossAx val="2094734552"/>
-        <c:crosses val="autoZero"/>
-        <c:auto val="1"/>
-        <c:lblAlgn val="ctr"/>
-        <c:lblOffset val="100"/>
-        <c:noMultiLvlLbl val="1"/>
-      </c:catAx>
-      <c:valAx>
-        <c:axId val="2094734552"/>
-        <c:scaling>
-          <c:orientation val="minMax"/>
-          <c:max val="100"/>
-          <c:min val="0"/>
-        </c:scaling>
-        <c:delete val="0"/>
-        <c:axPos val="l"/>
-        <c:majorGridlines>
-          <c:spPr>
-            <a:ln w="12700" cap="flat">
-              <a:solidFill>
-                <a:srgbClr val="888888"/>
-              </a:solidFill>
-              <a:prstDash val="solid"/>
-              <a:round/>
-            </a:ln>
-          </c:spPr>
-        </c:majorGridlines>
-        <c:numFmt formatCode="General" sourceLinked="0"/>
-        <c:majorTickMark val="out"/>
-        <c:minorTickMark val="none"/>
-        <c:tickLblPos val="nextTo"/>
-        <c:spPr>
-          <a:ln w="12700" cap="flat">
-            <a:solidFill>
-              <a:srgbClr val="888888"/>
-            </a:solidFill>
-            <a:prstDash val="solid"/>
-            <a:round/>
-          </a:ln>
-        </c:spPr>
-        <c:txPr>
-          <a:bodyPr/>
-          <a:lstStyle/>
-          <a:p>
-            <a:pPr>
-              <a:defRPr sz="1000" b="0" i="0" u="none" strike="noStrike">
-                <a:solidFill>
-                  <a:srgbClr val="5A5F73"/>
-                </a:solidFill>
-                <a:latin typeface="Calibri"/>
-              </a:defRPr>
-            </a:pPr>
-            <a:endParaRPr lang="en-US"/>
-          </a:p>
-        </c:txPr>
-        <c:crossAx val="2094734554"/>
-        <c:crosses val="autoZero"/>
-        <c:crossBetween val="between"/>
-      </c:valAx>
-      <c:spPr>
-        <a:noFill/>
-        <a:ln>
-          <a:noFill/>
-        </a:ln>
-        <a:effectLst/>
-      </c:spPr>
-    </c:plotArea>
-    <c:plotVisOnly val="1"/>
-    <c:dispBlanksAs val="span"/>
-    <c:showDLblsOverMax val="1"/>
-  </c:chart>
-  <c:spPr>
-    <a:noFill/>
-    <a:ln>
-      <a:noFill/>
-    </a:ln>
-    <a:effectLst/>
-  </c:spPr>
-  <c:externalData r:id="rId1">
-    <c:autoUpdate val="0"/>
-  </c:externalData>
-</c:chartSpace>
-</file>
-
-<file path=ppt/charts/chart6.xml><?xml version="1.0" encoding="utf-8"?>
 <c:chartSpace xmlns:c="http://schemas.openxmlformats.org/drawingml/2006/chart" xmlns:a="http://schemas.openxmlformats.org/drawingml/2006/main" xmlns:r="http://schemas.openxmlformats.org/officeDocument/2006/relationships" xmlns:c16r2="http://schemas.microsoft.com/office/drawing/2015/06/chart">
   <c:date1904 val="0"/>
   <c:lang val="es-ES"/>
@@ -1661,7 +1363,7 @@
             <c:bubble3D val="0"/>
             <c:extLst>
               <c:ext xmlns:c16="http://schemas.microsoft.com/office/drawing/2014/chart" uri="{C3380CC4-5D6E-409C-BE32-E72D297353CC}">
-                <c16:uniqueId val="{00000001-8200-4837-83A0-E49E9D63A97E}"/>
+                <c16:uniqueId val="{00000001-02EC-40B8-A8D6-5D239C87059B}"/>
               </c:ext>
             </c:extLst>
           </c:dPt>
@@ -1677,7 +1379,7 @@
             </c:spPr>
             <c:extLst>
               <c:ext xmlns:c16="http://schemas.microsoft.com/office/drawing/2014/chart" uri="{C3380CC4-5D6E-409C-BE32-E72D297353CC}">
-                <c16:uniqueId val="{00000003-8200-4837-83A0-E49E9D63A97E}"/>
+                <c16:uniqueId val="{00000003-02EC-40B8-A8D6-5D239C87059B}"/>
               </c:ext>
             </c:extLst>
           </c:dPt>
@@ -1749,7 +1451,7 @@
           </c:val>
           <c:extLst>
             <c:ext xmlns:c16="http://schemas.microsoft.com/office/drawing/2014/chart" uri="{C3380CC4-5D6E-409C-BE32-E72D297353CC}">
-              <c16:uniqueId val="{00000004-8200-4837-83A0-E49E9D63A97E}"/>
+              <c16:uniqueId val="{00000004-02EC-40B8-A8D6-5D239C87059B}"/>
             </c:ext>
           </c:extLst>
         </c:ser>
@@ -1872,7 +1574,7 @@
     </p:spTree>
     <p:extLst>
       <p:ext uri="{BB962C8B-B14F-4D97-AF65-F5344CB8AC3E}">
-        <p14:creationId xmlns:p14="http://schemas.microsoft.com/office/powerpoint/2010/main" val="3400754728"/>
+        <p14:creationId xmlns:p14="http://schemas.microsoft.com/office/powerpoint/2010/main" val="4157034081"/>
       </p:ext>
     </p:extLst>
   </p:cSld>
@@ -2000,13 +1702,6 @@
           </p:nvPr>
         </p:nvSpPr>
         <p:spPr/>
-        <p:txBody>
-          <a:bodyPr/>
-          <a:lstStyle/>
-          <a:p>
-            <a:endParaRPr lang="es-CO"/>
-          </a:p>
-        </p:txBody>
       </p:sp>
       <p:sp>
         <p:nvSpPr>
@@ -2094,13 +1789,6 @@
           </p:nvPr>
         </p:nvSpPr>
         <p:spPr/>
-        <p:txBody>
-          <a:bodyPr/>
-          <a:lstStyle/>
-          <a:p>
-            <a:endParaRPr lang="es-CO"/>
-          </a:p>
-        </p:txBody>
       </p:sp>
       <p:sp>
         <p:nvSpPr>
@@ -2188,13 +1876,6 @@
           </p:nvPr>
         </p:nvSpPr>
         <p:spPr/>
-        <p:txBody>
-          <a:bodyPr/>
-          <a:lstStyle/>
-          <a:p>
-            <a:endParaRPr lang="es-CO"/>
-          </a:p>
-        </p:txBody>
       </p:sp>
       <p:sp>
         <p:nvSpPr>
@@ -2282,13 +1963,6 @@
           </p:nvPr>
         </p:nvSpPr>
         <p:spPr/>
-        <p:txBody>
-          <a:bodyPr/>
-          <a:lstStyle/>
-          <a:p>
-            <a:endParaRPr lang="es-CO"/>
-          </a:p>
-        </p:txBody>
       </p:sp>
       <p:sp>
         <p:nvSpPr>
@@ -2376,13 +2050,6 @@
           </p:nvPr>
         </p:nvSpPr>
         <p:spPr/>
-        <p:txBody>
-          <a:bodyPr/>
-          <a:lstStyle/>
-          <a:p>
-            <a:endParaRPr lang="es-CO"/>
-          </a:p>
-        </p:txBody>
       </p:sp>
       <p:sp>
         <p:nvSpPr>
@@ -2401,7 +2068,7 @@
           <a:p>
             <a:r>
               <a:rPr lang="en-US" dirty="0"/>
-              <a:t>El PCA aquí tiene valor diagnóstico, no operativo: confirma que no existe estructura lineal simple que separe a los clientes en mora.</a:t>
+              <a:t>El análisis multivariado usa las técnicas pedidas: matriz de correlación, pairplot con hue, dispersión entre numéricas y tablas cruzadas. No se aplicó reducción de dimensionalidad porque corresponde a la fase de Feature Engineering.</a:t>
             </a:r>
           </a:p>
         </p:txBody>
@@ -2470,13 +2137,6 @@
           </p:nvPr>
         </p:nvSpPr>
         <p:spPr/>
-        <p:txBody>
-          <a:bodyPr/>
-          <a:lstStyle/>
-          <a:p>
-            <a:endParaRPr lang="es-CO"/>
-          </a:p>
-        </p:txBody>
       </p:sp>
       <p:sp>
         <p:nvSpPr>
@@ -2564,13 +2224,6 @@
           </p:nvPr>
         </p:nvSpPr>
         <p:spPr/>
-        <p:txBody>
-          <a:bodyPr/>
-          <a:lstStyle/>
-          <a:p>
-            <a:endParaRPr lang="es-CO"/>
-          </a:p>
-        </p:txBody>
       </p:sp>
       <p:sp>
         <p:nvSpPr>
@@ -2658,13 +2311,6 @@
           </p:nvPr>
         </p:nvSpPr>
         <p:spPr/>
-        <p:txBody>
-          <a:bodyPr/>
-          <a:lstStyle/>
-          <a:p>
-            <a:endParaRPr lang="es-CO"/>
-          </a:p>
-        </p:txBody>
       </p:sp>
       <p:sp>
         <p:nvSpPr>
@@ -2752,13 +2398,6 @@
           </p:nvPr>
         </p:nvSpPr>
         <p:spPr/>
-        <p:txBody>
-          <a:bodyPr/>
-          <a:lstStyle/>
-          <a:p>
-            <a:endParaRPr lang="es-CO"/>
-          </a:p>
-        </p:txBody>
       </p:sp>
       <p:sp>
         <p:nvSpPr>
@@ -2846,13 +2485,6 @@
           </p:nvPr>
         </p:nvSpPr>
         <p:spPr/>
-        <p:txBody>
-          <a:bodyPr/>
-          <a:lstStyle/>
-          <a:p>
-            <a:endParaRPr lang="es-CO"/>
-          </a:p>
-        </p:txBody>
       </p:sp>
       <p:sp>
         <p:nvSpPr>
@@ -2940,13 +2572,6 @@
           </p:nvPr>
         </p:nvSpPr>
         <p:spPr/>
-        <p:txBody>
-          <a:bodyPr/>
-          <a:lstStyle/>
-          <a:p>
-            <a:endParaRPr lang="es-CO"/>
-          </a:p>
-        </p:txBody>
       </p:sp>
       <p:sp>
         <p:nvSpPr>
@@ -3034,13 +2659,6 @@
           </p:nvPr>
         </p:nvSpPr>
         <p:spPr/>
-        <p:txBody>
-          <a:bodyPr/>
-          <a:lstStyle/>
-          <a:p>
-            <a:endParaRPr lang="es-CO"/>
-          </a:p>
-        </p:txBody>
       </p:sp>
       <p:sp>
         <p:nvSpPr>
@@ -3128,13 +2746,6 @@
           </p:nvPr>
         </p:nvSpPr>
         <p:spPr/>
-        <p:txBody>
-          <a:bodyPr/>
-          <a:lstStyle/>
-          <a:p>
-            <a:endParaRPr lang="es-CO"/>
-          </a:p>
-        </p:txBody>
       </p:sp>
       <p:sp>
         <p:nvSpPr>
@@ -3222,13 +2833,6 @@
           </p:nvPr>
         </p:nvSpPr>
         <p:spPr/>
-        <p:txBody>
-          <a:bodyPr/>
-          <a:lstStyle/>
-          <a:p>
-            <a:endParaRPr lang="es-CO"/>
-          </a:p>
-        </p:txBody>
       </p:sp>
       <p:sp>
         <p:nvSpPr>
@@ -3316,13 +2920,6 @@
           </p:nvPr>
         </p:nvSpPr>
         <p:spPr/>
-        <p:txBody>
-          <a:bodyPr/>
-          <a:lstStyle/>
-          <a:p>
-            <a:endParaRPr lang="es-CO"/>
-          </a:p>
-        </p:txBody>
       </p:sp>
       <p:sp>
         <p:nvSpPr>
@@ -3410,13 +3007,6 @@
           </p:nvPr>
         </p:nvSpPr>
         <p:spPr/>
-        <p:txBody>
-          <a:bodyPr/>
-          <a:lstStyle/>
-          <a:p>
-            <a:endParaRPr lang="es-CO"/>
-          </a:p>
-        </p:txBody>
       </p:sp>
       <p:sp>
         <p:nvSpPr>
@@ -3504,13 +3094,6 @@
           </p:nvPr>
         </p:nvSpPr>
         <p:spPr/>
-        <p:txBody>
-          <a:bodyPr/>
-          <a:lstStyle/>
-          <a:p>
-            <a:endParaRPr lang="es-CO"/>
-          </a:p>
-        </p:txBody>
       </p:sp>
       <p:sp>
         <p:nvSpPr>
@@ -3598,13 +3181,6 @@
           </p:nvPr>
         </p:nvSpPr>
         <p:spPr/>
-        <p:txBody>
-          <a:bodyPr/>
-          <a:lstStyle/>
-          <a:p>
-            <a:endParaRPr lang="es-CO"/>
-          </a:p>
-        </p:txBody>
       </p:sp>
       <p:sp>
         <p:nvSpPr>
@@ -4156,7 +3732,7 @@
         </p:nvSpPr>
         <p:spPr>
           <a:xfrm>
-            <a:off x="735874" y="4343400"/>
+            <a:off x="822960" y="4343401"/>
             <a:ext cx="8229600" cy="365760"/>
           </a:xfrm>
           <a:prstGeom prst="rect">
@@ -4953,7 +4529,7 @@
                 <a:ea typeface="Cambria" pitchFamily="34" charset="-122"/>
                 <a:cs typeface="Cambria" pitchFamily="34" charset="-120"/>
               </a:rPr>
-              <a:t>Los atributos derivados superan a los originales</a:t>
+              <a:t>Atributos derivados: propuestas de alto valor</a:t>
             </a:r>
             <a:endParaRPr lang="en-US" sz="3000" dirty="0"/>
           </a:p>
@@ -5714,7 +5290,7 @@
               <a:buNone/>
             </a:pPr>
             <a:r>
-              <a:rPr lang="en-US" sz="2600" b="1" dirty="0">
+              <a:rPr lang="en-US" sz="2300" b="1" dirty="0">
                 <a:solidFill>
                   <a:srgbClr val="FFFFFF"/>
                 </a:solidFill>
@@ -5722,9 +5298,9 @@
                 <a:ea typeface="Cambria" pitchFamily="34" charset="-122"/>
                 <a:cs typeface="Cambria" pitchFamily="34" charset="-120"/>
               </a:rPr>
-              <a:t>2 de 2</a:t>
-            </a:r>
-            <a:endParaRPr lang="en-US" sz="2600" dirty="0"/>
+              <a:t>Propuestas</a:t>
+            </a:r>
+            <a:endParaRPr lang="en-US" sz="2300" dirty="0"/>
           </a:p>
         </p:txBody>
       </p:sp>
@@ -5736,8 +5312,8 @@
         </p:nvSpPr>
         <p:spPr>
           <a:xfrm>
-            <a:off x="7863840" y="2880360"/>
-            <a:ext cx="3474720" cy="914400"/>
+            <a:off x="7863840" y="2834640"/>
+            <a:ext cx="3474720" cy="1143000"/>
           </a:xfrm>
           <a:prstGeom prst="rect">
             <a:avLst/>
@@ -5756,7 +5332,7 @@
               <a:buNone/>
             </a:pPr>
             <a:r>
-              <a:rPr lang="en-US" sz="1300" dirty="0">
+              <a:rPr lang="en-US" sz="1200" dirty="0">
                 <a:solidFill>
                   <a:srgbClr val="CADCFC"/>
                 </a:solidFill>
@@ -5764,9 +5340,9 @@
                 <a:ea typeface="Calibri" pitchFamily="34" charset="-122"/>
                 <a:cs typeface="Calibri" pitchFamily="34" charset="-120"/>
               </a:rPr>
-              <a:t>los dos mejores predictores del dataset son variables construidas, no originales</a:t>
-            </a:r>
-            <a:endParaRPr lang="en-US" sz="1300" dirty="0"/>
+              <a:t>Identificadas y evaluadas durante el EDA. Se implementarán en la Fase 2; ninguna se incorporó al dataset limpio.</a:t>
+            </a:r>
+            <a:endParaRPr lang="en-US" sz="1200" dirty="0"/>
           </a:p>
         </p:txBody>
       </p:sp>
@@ -5778,8 +5354,8 @@
         </p:nvSpPr>
         <p:spPr>
           <a:xfrm>
-            <a:off x="7863840" y="3977640"/>
-            <a:ext cx="3474720" cy="2011680"/>
+            <a:off x="7863840" y="4069080"/>
+            <a:ext cx="3474720" cy="1874520"/>
           </a:xfrm>
           <a:prstGeom prst="rect">
             <a:avLst/>
@@ -5987,86 +5563,99 @@
                 <a:ea typeface="Cambria" pitchFamily="34" charset="-122"/>
                 <a:cs typeface="Cambria" pitchFamily="34" charset="-120"/>
               </a:rPr>
-              <a:t>¿Se separan las clases en el espacio multivariado?</a:t>
+              <a:t>Relaciones entre variables</a:t>
             </a:r>
             <a:endParaRPr lang="en-US" sz="3000" dirty="0"/>
           </a:p>
         </p:txBody>
       </p:sp>
-      <p:graphicFrame>
-        <p:nvGraphicFramePr>
-          <p:cNvPr id="4" name="Chart 0"/>
-          <p:cNvGraphicFramePr/>
-          <p:nvPr/>
-        </p:nvGraphicFramePr>
-        <p:xfrm>
-          <a:off x="548640" y="1920240"/>
-          <a:ext cx="6035040" cy="4023360"/>
-        </p:xfrm>
-        <a:graphic>
-          <a:graphicData uri="http://schemas.openxmlformats.org/drawingml/2006/chart">
-            <c:chart xmlns:c="http://schemas.openxmlformats.org/drawingml/2006/chart" xmlns:r="http://schemas.openxmlformats.org/officeDocument/2006/relationships" r:id="rId3"/>
-          </a:graphicData>
-        </a:graphic>
-      </p:graphicFrame>
-      <p:sp>
-        <p:nvSpPr>
-          <p:cNvPr id="5" name="Text 2"/>
-          <p:cNvSpPr/>
-          <p:nvPr/>
-        </p:nvSpPr>
-        <p:spPr>
-          <a:xfrm>
-            <a:off x="6949440" y="2103120"/>
-            <a:ext cx="4663440" cy="822960"/>
-          </a:xfrm>
-          <a:prstGeom prst="rect">
-            <a:avLst/>
-          </a:prstGeom>
-          <a:noFill/>
-          <a:ln/>
-        </p:spPr>
-        <p:txBody>
-          <a:bodyPr wrap="square" lIns="0" tIns="0" rIns="0" bIns="0" rtlCol="0" anchor="ctr"/>
-          <a:lstStyle/>
-          <a:p>
-            <a:pPr marL="0" indent="0">
-              <a:buNone/>
-            </a:pPr>
-            <a:r>
-              <a:rPr lang="en-US" sz="4000" b="1" dirty="0">
-                <a:solidFill>
-                  <a:srgbClr val="1E2761"/>
-                </a:solidFill>
-                <a:latin typeface="Cambria" pitchFamily="34" charset="0"/>
-                <a:ea typeface="Cambria" pitchFamily="34" charset="-122"/>
-                <a:cs typeface="Cambria" pitchFamily="34" charset="-120"/>
-              </a:rPr>
-              <a:t>10 de 17</a:t>
-            </a:r>
-            <a:endParaRPr lang="en-US" sz="4000" dirty="0"/>
-          </a:p>
-        </p:txBody>
-      </p:sp>
-      <p:sp>
-        <p:nvSpPr>
-          <p:cNvPr id="6" name="Text 3"/>
-          <p:cNvSpPr/>
-          <p:nvPr/>
-        </p:nvSpPr>
-        <p:spPr>
-          <a:xfrm>
-            <a:off x="6949440" y="2926080"/>
-            <a:ext cx="4663440" cy="731520"/>
-          </a:xfrm>
-          <a:prstGeom prst="rect">
-            <a:avLst/>
-          </a:prstGeom>
-          <a:noFill/>
-          <a:ln/>
-        </p:spPr>
-        <p:txBody>
-          <a:bodyPr wrap="square" lIns="0" tIns="0" rIns="0" bIns="0" rtlCol="0" anchor="ctr"/>
+      <p:sp>
+        <p:nvSpPr>
+          <p:cNvPr id="4" name="Shape 2"/>
+          <p:cNvSpPr/>
+          <p:nvPr/>
+        </p:nvSpPr>
+        <p:spPr>
+          <a:xfrm>
+            <a:off x="548640" y="1965960"/>
+            <a:ext cx="2670048" cy="1920240"/>
+          </a:xfrm>
+          <a:prstGeom prst="roundRect">
+            <a:avLst>
+              <a:gd name="adj" fmla="val 3810"/>
+            </a:avLst>
+          </a:prstGeom>
+          <a:solidFill>
+            <a:srgbClr val="1E2761"/>
+          </a:solidFill>
+          <a:ln/>
+        </p:spPr>
+        <p:txBody>
+          <a:bodyPr/>
+          <a:lstStyle/>
+          <a:p>
+            <a:endParaRPr lang="es-CO"/>
+          </a:p>
+        </p:txBody>
+      </p:sp>
+      <p:sp>
+        <p:nvSpPr>
+          <p:cNvPr id="5" name="Text 3"/>
+          <p:cNvSpPr/>
+          <p:nvPr/>
+        </p:nvSpPr>
+        <p:spPr>
+          <a:xfrm>
+            <a:off x="804672" y="2221992"/>
+            <a:ext cx="2157984" cy="685800"/>
+          </a:xfrm>
+          <a:prstGeom prst="rect">
+            <a:avLst/>
+          </a:prstGeom>
+          <a:noFill/>
+          <a:ln/>
+        </p:spPr>
+        <p:txBody>
+          <a:bodyPr wrap="square" lIns="0" tIns="0" rIns="0" bIns="0" rtlCol="0" anchor="t"/>
+          <a:lstStyle/>
+          <a:p>
+            <a:pPr marL="0" indent="0">
+              <a:buNone/>
+            </a:pPr>
+            <a:r>
+              <a:rPr lang="en-US" sz="1400" b="1" dirty="0">
+                <a:solidFill>
+                  <a:srgbClr val="FFFFFF"/>
+                </a:solidFill>
+                <a:latin typeface="Calibri" pitchFamily="34" charset="0"/>
+                <a:ea typeface="Calibri" pitchFamily="34" charset="-122"/>
+                <a:cs typeface="Calibri" pitchFamily="34" charset="-120"/>
+              </a:rPr>
+              <a:t>Matriz de correlación</a:t>
+            </a:r>
+            <a:endParaRPr lang="en-US" sz="1400" dirty="0"/>
+          </a:p>
+        </p:txBody>
+      </p:sp>
+      <p:sp>
+        <p:nvSpPr>
+          <p:cNvPr id="6" name="Text 4"/>
+          <p:cNvSpPr/>
+          <p:nvPr/>
+        </p:nvSpPr>
+        <p:spPr>
+          <a:xfrm>
+            <a:off x="804672" y="2880360"/>
+            <a:ext cx="2157984" cy="914400"/>
+          </a:xfrm>
+          <a:prstGeom prst="rect">
+            <a:avLst/>
+          </a:prstGeom>
+          <a:noFill/>
+          <a:ln/>
+        </p:spPr>
+        <p:txBody>
+          <a:bodyPr wrap="square" lIns="0" tIns="0" rIns="0" bIns="0" rtlCol="0" anchor="t"/>
           <a:lstStyle/>
           <a:p>
             <a:pPr marL="0" indent="0">
@@ -6076,34 +5665,74 @@
               <a:buNone/>
             </a:pPr>
             <a:r>
-              <a:rPr lang="en-US" sz="1350" dirty="0">
-                <a:solidFill>
-                  <a:srgbClr val="5A5F73"/>
-                </a:solidFill>
-                <a:latin typeface="Calibri" pitchFamily="34" charset="0"/>
-                <a:ea typeface="Calibri" pitchFamily="34" charset="-122"/>
-                <a:cs typeface="Calibri" pitchFamily="34" charset="-120"/>
-              </a:rPr>
-              <a:t>componentes hacen falta para explicar el 80% de la varianza</a:t>
-            </a:r>
-            <a:endParaRPr lang="en-US" sz="1350" dirty="0"/>
-          </a:p>
-        </p:txBody>
-      </p:sp>
-      <p:sp>
-        <p:nvSpPr>
-          <p:cNvPr id="7" name="Shape 4"/>
-          <p:cNvSpPr/>
-          <p:nvPr/>
-        </p:nvSpPr>
-        <p:spPr>
-          <a:xfrm>
-            <a:off x="6949440" y="3794760"/>
-            <a:ext cx="4663440" cy="2148840"/>
+              <a:rPr lang="en-US" sz="1100" dirty="0">
+                <a:solidFill>
+                  <a:srgbClr val="CADCFC"/>
+                </a:solidFill>
+                <a:latin typeface="Calibri" pitchFamily="34" charset="0"/>
+                <a:ea typeface="Calibri" pitchFamily="34" charset="-122"/>
+                <a:cs typeface="Calibri" pitchFamily="34" charset="-120"/>
+              </a:rPr>
+              <a:t>Sobre variables cuantitativas.</a:t>
+            </a:r>
+            <a:endParaRPr lang="en-US" sz="1100" dirty="0"/>
+          </a:p>
+          <a:p>
+            <a:pPr marL="0" indent="0">
+              <a:lnSpc>
+                <a:spcPct val="120000"/>
+              </a:lnSpc>
+              <a:buNone/>
+            </a:pPr>
+            <a:r>
+              <a:rPr lang="en-US" sz="1100" dirty="0">
+                <a:solidFill>
+                  <a:srgbClr val="CADCFC"/>
+                </a:solidFill>
+                <a:latin typeface="Calibri" pitchFamily="34" charset="0"/>
+                <a:ea typeface="Calibri" pitchFamily="34" charset="-122"/>
+                <a:cs typeface="Calibri" pitchFamily="34" charset="-120"/>
+              </a:rPr>
+              <a:t>Detecta multicolinealidad:</a:t>
+            </a:r>
+            <a:endParaRPr lang="en-US" sz="1100" dirty="0"/>
+          </a:p>
+          <a:p>
+            <a:pPr marL="0" indent="0">
+              <a:lnSpc>
+                <a:spcPct val="120000"/>
+              </a:lnSpc>
+              <a:buNone/>
+            </a:pPr>
+            <a:r>
+              <a:rPr lang="en-US" sz="1100" dirty="0">
+                <a:solidFill>
+                  <a:srgbClr val="CADCFC"/>
+                </a:solidFill>
+                <a:latin typeface="Calibri" pitchFamily="34" charset="0"/>
+                <a:ea typeface="Calibri" pitchFamily="34" charset="-122"/>
+                <a:cs typeface="Calibri" pitchFamily="34" charset="-120"/>
+              </a:rPr>
+              <a:t>capital vs cuota (r = 0.764)</a:t>
+            </a:r>
+            <a:endParaRPr lang="en-US" sz="1100" dirty="0"/>
+          </a:p>
+        </p:txBody>
+      </p:sp>
+      <p:sp>
+        <p:nvSpPr>
+          <p:cNvPr id="7" name="Shape 5"/>
+          <p:cNvSpPr/>
+          <p:nvPr/>
+        </p:nvSpPr>
+        <p:spPr>
+          <a:xfrm>
+            <a:off x="3438144" y="1965960"/>
+            <a:ext cx="2670048" cy="1920240"/>
           </a:xfrm>
           <a:prstGeom prst="roundRect">
             <a:avLst>
-              <a:gd name="adj" fmla="val 3404"/>
+              <a:gd name="adj" fmla="val 3810"/>
             </a:avLst>
           </a:prstGeom>
           <a:solidFill>
@@ -6121,14 +5750,53 @@
       </p:sp>
       <p:sp>
         <p:nvSpPr>
-          <p:cNvPr id="8" name="Text 5"/>
-          <p:cNvSpPr/>
-          <p:nvPr/>
-        </p:nvSpPr>
-        <p:spPr>
-          <a:xfrm>
-            <a:off x="7178040" y="3931920"/>
-            <a:ext cx="4206240" cy="1874520"/>
+          <p:cNvPr id="8" name="Text 6"/>
+          <p:cNvSpPr/>
+          <p:nvPr/>
+        </p:nvSpPr>
+        <p:spPr>
+          <a:xfrm>
+            <a:off x="3694176" y="2221992"/>
+            <a:ext cx="2157984" cy="685800"/>
+          </a:xfrm>
+          <a:prstGeom prst="rect">
+            <a:avLst/>
+          </a:prstGeom>
+          <a:noFill/>
+          <a:ln/>
+        </p:spPr>
+        <p:txBody>
+          <a:bodyPr wrap="square" lIns="0" tIns="0" rIns="0" bIns="0" rtlCol="0" anchor="t"/>
+          <a:lstStyle/>
+          <a:p>
+            <a:pPr marL="0" indent="0">
+              <a:buNone/>
+            </a:pPr>
+            <a:r>
+              <a:rPr lang="en-US" sz="1400" b="1" dirty="0">
+                <a:solidFill>
+                  <a:srgbClr val="1E2761"/>
+                </a:solidFill>
+                <a:latin typeface="Calibri" pitchFamily="34" charset="0"/>
+                <a:ea typeface="Calibri" pitchFamily="34" charset="-122"/>
+                <a:cs typeface="Calibri" pitchFamily="34" charset="-120"/>
+              </a:rPr>
+              <a:t>Pairplot con hue</a:t>
+            </a:r>
+            <a:endParaRPr lang="en-US" sz="1400" dirty="0"/>
+          </a:p>
+        </p:txBody>
+      </p:sp>
+      <p:sp>
+        <p:nvSpPr>
+          <p:cNvPr id="9" name="Text 7"/>
+          <p:cNvSpPr/>
+          <p:nvPr/>
+        </p:nvSpPr>
+        <p:spPr>
+          <a:xfrm>
+            <a:off x="3694176" y="2880360"/>
+            <a:ext cx="2157984" cy="914400"/>
           </a:xfrm>
           <a:prstGeom prst="rect">
             <a:avLst/>
@@ -6147,18 +5815,17 @@
               <a:buNone/>
             </a:pPr>
             <a:r>
-              <a:rPr lang="en-US" sz="1150" b="1" dirty="0">
-                <a:solidFill>
-                  <a:srgbClr val="1E2761"/>
-                </a:solidFill>
-                <a:latin typeface="Calibri" pitchFamily="34" charset="0"/>
-                <a:ea typeface="Calibri" pitchFamily="34" charset="-122"/>
-                <a:cs typeface="Calibri" pitchFamily="34" charset="-120"/>
-              </a:rPr>
-              <a:t>No hay redundancia aprovechable.
-</a:t>
-            </a:r>
-            <a:endParaRPr lang="en-US" sz="1150" dirty="0"/>
+              <a:rPr lang="en-US" sz="1100" dirty="0">
+                <a:solidFill>
+                  <a:srgbClr val="5A5F73"/>
+                </a:solidFill>
+                <a:latin typeface="Calibri" pitchFamily="34" charset="0"/>
+                <a:ea typeface="Calibri" pitchFamily="34" charset="-122"/>
+                <a:cs typeface="Calibri" pitchFamily="34" charset="-120"/>
+              </a:rPr>
+              <a:t>Muestra de 1.500 registros</a:t>
+            </a:r>
+            <a:endParaRPr lang="en-US" sz="1100" dirty="0"/>
           </a:p>
           <a:p>
             <a:pPr marL="0" indent="0">
@@ -6168,7 +5835,7 @@
               <a:buNone/>
             </a:pPr>
             <a:r>
-              <a:rPr lang="en-US" sz="1150" dirty="0">
+              <a:rPr lang="en-US" sz="1100" dirty="0">
                 <a:solidFill>
                   <a:srgbClr val="5A5F73"/>
                 </a:solidFill>
@@ -6176,11 +5843,100 @@
                 <a:ea typeface="Calibri" pitchFamily="34" charset="-122"/>
                 <a:cs typeface="Calibri" pitchFamily="34" charset="-120"/>
               </a:rPr>
-              <a:t>La proyección sobre PC1-PC2 no separa clientes en mora de los que pagan.
-</a:t>
-            </a:r>
-            <a:endParaRPr lang="en-US" sz="1150" dirty="0"/>
-          </a:p>
+              <a:t>coloreada por resultado de pago</a:t>
+            </a:r>
+            <a:endParaRPr lang="en-US" sz="1100" dirty="0"/>
+          </a:p>
+        </p:txBody>
+      </p:sp>
+      <p:sp>
+        <p:nvSpPr>
+          <p:cNvPr id="10" name="Shape 8"/>
+          <p:cNvSpPr/>
+          <p:nvPr/>
+        </p:nvSpPr>
+        <p:spPr>
+          <a:xfrm>
+            <a:off x="6327648" y="1965960"/>
+            <a:ext cx="2670048" cy="1920240"/>
+          </a:xfrm>
+          <a:prstGeom prst="roundRect">
+            <a:avLst>
+              <a:gd name="adj" fmla="val 3810"/>
+            </a:avLst>
+          </a:prstGeom>
+          <a:solidFill>
+            <a:srgbClr val="F4F7FC"/>
+          </a:solidFill>
+          <a:ln/>
+        </p:spPr>
+        <p:txBody>
+          <a:bodyPr/>
+          <a:lstStyle/>
+          <a:p>
+            <a:endParaRPr lang="es-CO"/>
+          </a:p>
+        </p:txBody>
+      </p:sp>
+      <p:sp>
+        <p:nvSpPr>
+          <p:cNvPr id="11" name="Text 9"/>
+          <p:cNvSpPr/>
+          <p:nvPr/>
+        </p:nvSpPr>
+        <p:spPr>
+          <a:xfrm>
+            <a:off x="6583680" y="2221992"/>
+            <a:ext cx="2157984" cy="685800"/>
+          </a:xfrm>
+          <a:prstGeom prst="rect">
+            <a:avLst/>
+          </a:prstGeom>
+          <a:noFill/>
+          <a:ln/>
+        </p:spPr>
+        <p:txBody>
+          <a:bodyPr wrap="square" lIns="0" tIns="0" rIns="0" bIns="0" rtlCol="0" anchor="t"/>
+          <a:lstStyle/>
+          <a:p>
+            <a:pPr marL="0" indent="0">
+              <a:buNone/>
+            </a:pPr>
+            <a:r>
+              <a:rPr lang="en-US" sz="1400" b="1" dirty="0">
+                <a:solidFill>
+                  <a:srgbClr val="1E2761"/>
+                </a:solidFill>
+                <a:latin typeface="Calibri" pitchFamily="34" charset="0"/>
+                <a:ea typeface="Calibri" pitchFamily="34" charset="-122"/>
+                <a:cs typeface="Calibri" pitchFamily="34" charset="-120"/>
+              </a:rPr>
+              <a:t>Dispersión entre numéricas</a:t>
+            </a:r>
+            <a:endParaRPr lang="en-US" sz="1400" dirty="0"/>
+          </a:p>
+        </p:txBody>
+      </p:sp>
+      <p:sp>
+        <p:nvSpPr>
+          <p:cNvPr id="12" name="Text 10"/>
+          <p:cNvSpPr/>
+          <p:nvPr/>
+        </p:nvSpPr>
+        <p:spPr>
+          <a:xfrm>
+            <a:off x="6583680" y="2880360"/>
+            <a:ext cx="2157984" cy="914400"/>
+          </a:xfrm>
+          <a:prstGeom prst="rect">
+            <a:avLst/>
+          </a:prstGeom>
+          <a:noFill/>
+          <a:ln/>
+        </p:spPr>
+        <p:txBody>
+          <a:bodyPr wrap="square" lIns="0" tIns="0" rIns="0" bIns="0" rtlCol="0" anchor="t"/>
+          <a:lstStyle/>
           <a:p>
             <a:pPr marL="0" indent="0">
               <a:lnSpc>
@@ -6189,18 +5945,7 @@
               <a:buNone/>
             </a:pPr>
             <a:r>
-              <a:rPr lang="en-US" sz="1150" b="1" dirty="0">
-                <a:solidFill>
-                  <a:srgbClr val="B33A3A"/>
-                </a:solidFill>
-                <a:latin typeface="Calibri" pitchFamily="34" charset="0"/>
-                <a:ea typeface="Calibri" pitchFamily="34" charset="-122"/>
-                <a:cs typeface="Calibri" pitchFamily="34" charset="-120"/>
-              </a:rPr>
-              <a:t>Decisión: </a:t>
-            </a:r>
-            <a:r>
-              <a:rPr lang="en-US" sz="1150" dirty="0">
+              <a:rPr lang="en-US" sz="1100" dirty="0">
                 <a:solidFill>
                   <a:srgbClr val="5A5F73"/>
                 </a:solidFill>
@@ -6208,15 +5953,257 @@
                 <a:ea typeface="Calibri" pitchFamily="34" charset="-122"/>
                 <a:cs typeface="Calibri" pitchFamily="34" charset="-120"/>
               </a:rPr>
-              <a:t>no usar PCA en el modelado. Reduciría la interpretabilidad — crítica para explicar por qué se niega un crédito — sin aportar separabilidad.</a:t>
-            </a:r>
-            <a:endParaRPr lang="en-US" sz="1150" dirty="0"/>
-          </a:p>
-        </p:txBody>
-      </p:sp>
-      <p:sp>
-        <p:nvSpPr>
-          <p:cNvPr id="9" name="Text 6"/>
+              <a:t>Cuatro pares clave,</a:t>
+            </a:r>
+            <a:endParaRPr lang="en-US" sz="1100" dirty="0"/>
+          </a:p>
+          <a:p>
+            <a:pPr marL="0" indent="0">
+              <a:lnSpc>
+                <a:spcPct val="120000"/>
+              </a:lnSpc>
+              <a:buNone/>
+            </a:pPr>
+            <a:r>
+              <a:rPr lang="en-US" sz="1100" dirty="0">
+                <a:solidFill>
+                  <a:srgbClr val="5A5F73"/>
+                </a:solidFill>
+                <a:latin typeface="Calibri" pitchFamily="34" charset="0"/>
+                <a:ea typeface="Calibri" pitchFamily="34" charset="-122"/>
+                <a:cs typeface="Calibri" pitchFamily="34" charset="-120"/>
+              </a:rPr>
+              <a:t>diferenciando mora y al día</a:t>
+            </a:r>
+            <a:endParaRPr lang="en-US" sz="1100" dirty="0"/>
+          </a:p>
+        </p:txBody>
+      </p:sp>
+      <p:sp>
+        <p:nvSpPr>
+          <p:cNvPr id="13" name="Shape 11"/>
+          <p:cNvSpPr/>
+          <p:nvPr/>
+        </p:nvSpPr>
+        <p:spPr>
+          <a:xfrm>
+            <a:off x="9217152" y="1965960"/>
+            <a:ext cx="2670048" cy="1920240"/>
+          </a:xfrm>
+          <a:prstGeom prst="roundRect">
+            <a:avLst>
+              <a:gd name="adj" fmla="val 3810"/>
+            </a:avLst>
+          </a:prstGeom>
+          <a:solidFill>
+            <a:srgbClr val="F4F7FC"/>
+          </a:solidFill>
+          <a:ln/>
+        </p:spPr>
+        <p:txBody>
+          <a:bodyPr/>
+          <a:lstStyle/>
+          <a:p>
+            <a:endParaRPr lang="es-CO"/>
+          </a:p>
+        </p:txBody>
+      </p:sp>
+      <p:sp>
+        <p:nvSpPr>
+          <p:cNvPr id="14" name="Text 12"/>
+          <p:cNvSpPr/>
+          <p:nvPr/>
+        </p:nvSpPr>
+        <p:spPr>
+          <a:xfrm>
+            <a:off x="9473184" y="2221992"/>
+            <a:ext cx="2157984" cy="685800"/>
+          </a:xfrm>
+          <a:prstGeom prst="rect">
+            <a:avLst/>
+          </a:prstGeom>
+          <a:noFill/>
+          <a:ln/>
+        </p:spPr>
+        <p:txBody>
+          <a:bodyPr wrap="square" lIns="0" tIns="0" rIns="0" bIns="0" rtlCol="0" anchor="t"/>
+          <a:lstStyle/>
+          <a:p>
+            <a:pPr marL="0" indent="0">
+              <a:buNone/>
+            </a:pPr>
+            <a:r>
+              <a:rPr lang="en-US" sz="1400" b="1" dirty="0">
+                <a:solidFill>
+                  <a:srgbClr val="1E2761"/>
+                </a:solidFill>
+                <a:latin typeface="Calibri" pitchFamily="34" charset="0"/>
+                <a:ea typeface="Calibri" pitchFamily="34" charset="-122"/>
+                <a:cs typeface="Calibri" pitchFamily="34" charset="-120"/>
+              </a:rPr>
+              <a:t>Tablas de contingencia</a:t>
+            </a:r>
+            <a:endParaRPr lang="en-US" sz="1400" dirty="0"/>
+          </a:p>
+        </p:txBody>
+      </p:sp>
+      <p:sp>
+        <p:nvSpPr>
+          <p:cNvPr id="15" name="Text 13"/>
+          <p:cNvSpPr/>
+          <p:nvPr/>
+        </p:nvSpPr>
+        <p:spPr>
+          <a:xfrm>
+            <a:off x="9473184" y="2880360"/>
+            <a:ext cx="2157984" cy="914400"/>
+          </a:xfrm>
+          <a:prstGeom prst="rect">
+            <a:avLst/>
+          </a:prstGeom>
+          <a:noFill/>
+          <a:ln/>
+        </p:spPr>
+        <p:txBody>
+          <a:bodyPr wrap="square" lIns="0" tIns="0" rIns="0" bIns="0" rtlCol="0" anchor="t"/>
+          <a:lstStyle/>
+          <a:p>
+            <a:pPr marL="0" indent="0">
+              <a:lnSpc>
+                <a:spcPct val="120000"/>
+              </a:lnSpc>
+              <a:buNone/>
+            </a:pPr>
+            <a:r>
+              <a:rPr lang="en-US" sz="1100" dirty="0">
+                <a:solidFill>
+                  <a:srgbClr val="5A5F73"/>
+                </a:solidFill>
+                <a:latin typeface="Calibri" pitchFamily="34" charset="0"/>
+                <a:ea typeface="Calibri" pitchFamily="34" charset="-122"/>
+                <a:cs typeface="Calibri" pitchFamily="34" charset="-120"/>
+              </a:rPr>
+              <a:t>Cruces entre variables</a:t>
+            </a:r>
+            <a:endParaRPr lang="en-US" sz="1100" dirty="0"/>
+          </a:p>
+          <a:p>
+            <a:pPr marL="0" indent="0">
+              <a:lnSpc>
+                <a:spcPct val="120000"/>
+              </a:lnSpc>
+              <a:buNone/>
+            </a:pPr>
+            <a:r>
+              <a:rPr lang="en-US" sz="1100" dirty="0">
+                <a:solidFill>
+                  <a:srgbClr val="5A5F73"/>
+                </a:solidFill>
+                <a:latin typeface="Calibri" pitchFamily="34" charset="0"/>
+                <a:ea typeface="Calibri" pitchFamily="34" charset="-122"/>
+                <a:cs typeface="Calibri" pitchFamily="34" charset="-120"/>
+              </a:rPr>
+              <a:t>categóricas y el objetivo</a:t>
+            </a:r>
+            <a:endParaRPr lang="en-US" sz="1100" dirty="0"/>
+          </a:p>
+        </p:txBody>
+      </p:sp>
+      <p:sp>
+        <p:nvSpPr>
+          <p:cNvPr id="16" name="Shape 14"/>
+          <p:cNvSpPr/>
+          <p:nvPr/>
+        </p:nvSpPr>
+        <p:spPr>
+          <a:xfrm>
+            <a:off x="548640" y="4206240"/>
+            <a:ext cx="11064240" cy="1600200"/>
+          </a:xfrm>
+          <a:prstGeom prst="roundRect">
+            <a:avLst>
+              <a:gd name="adj" fmla="val 4571"/>
+            </a:avLst>
+          </a:prstGeom>
+          <a:solidFill>
+            <a:srgbClr val="FBEAEA"/>
+          </a:solidFill>
+          <a:ln/>
+        </p:spPr>
+        <p:txBody>
+          <a:bodyPr/>
+          <a:lstStyle/>
+          <a:p>
+            <a:endParaRPr lang="es-CO"/>
+          </a:p>
+        </p:txBody>
+      </p:sp>
+      <p:sp>
+        <p:nvSpPr>
+          <p:cNvPr id="17" name="Text 15"/>
+          <p:cNvSpPr/>
+          <p:nvPr/>
+        </p:nvSpPr>
+        <p:spPr>
+          <a:xfrm>
+            <a:off x="822960" y="4389120"/>
+            <a:ext cx="10515600" cy="1280160"/>
+          </a:xfrm>
+          <a:prstGeom prst="rect">
+            <a:avLst/>
+          </a:prstGeom>
+          <a:noFill/>
+          <a:ln/>
+        </p:spPr>
+        <p:txBody>
+          <a:bodyPr wrap="square" lIns="0" tIns="0" rIns="0" bIns="0" rtlCol="0" anchor="t"/>
+          <a:lstStyle/>
+          <a:p>
+            <a:pPr marL="0" indent="0">
+              <a:lnSpc>
+                <a:spcPct val="125000"/>
+              </a:lnSpc>
+              <a:buNone/>
+            </a:pPr>
+            <a:r>
+              <a:rPr lang="en-US" sz="1400" b="1" dirty="0">
+                <a:solidFill>
+                  <a:srgbClr val="1E2761"/>
+                </a:solidFill>
+                <a:latin typeface="Calibri" pitchFamily="34" charset="0"/>
+                <a:ea typeface="Calibri" pitchFamily="34" charset="-122"/>
+                <a:cs typeface="Calibri" pitchFamily="34" charset="-120"/>
+              </a:rPr>
+              <a:t>Conclusión del multivariado:
+</a:t>
+            </a:r>
+            <a:endParaRPr lang="en-US" sz="1400" dirty="0"/>
+          </a:p>
+          <a:p>
+            <a:pPr marL="0" indent="0">
+              <a:lnSpc>
+                <a:spcPct val="125000"/>
+              </a:lnSpc>
+              <a:buNone/>
+            </a:pPr>
+            <a:r>
+              <a:rPr lang="en-US" sz="1250" dirty="0">
+                <a:solidFill>
+                  <a:srgbClr val="5A5F73"/>
+                </a:solidFill>
+                <a:latin typeface="Calibri" pitchFamily="34" charset="0"/>
+                <a:ea typeface="Calibri" pitchFamily="34" charset="-122"/>
+                <a:cs typeface="Calibri" pitchFamily="34" charset="-120"/>
+              </a:rPr>
+              <a:t>ninguna combinación de dos variables separa a los clientes en mora. Las nubes de puntos se superponen ampliamente en todos los gráficos. Esto confirma que el riesgo depende de múltiples factores simultáneos y justifica un modelo multivariado en la siguiente fase.</a:t>
+            </a:r>
+            <a:endParaRPr lang="en-US" sz="1400" dirty="0"/>
+          </a:p>
+        </p:txBody>
+      </p:sp>
+      <p:sp>
+        <p:nvSpPr>
+          <p:cNvPr id="18" name="Text 16"/>
           <p:cNvSpPr/>
           <p:nvPr/>
         </p:nvSpPr>
@@ -6255,7 +6242,7 @@
       </p:sp>
       <p:sp>
         <p:nvSpPr>
-          <p:cNvPr id="10" name="Text 7"/>
+          <p:cNvPr id="19" name="Text 17"/>
           <p:cNvSpPr/>
           <p:nvPr/>
         </p:nvSpPr>
@@ -7700,45 +7687,6 @@
       </p:sp>
       <p:sp>
         <p:nvSpPr>
-          <p:cNvPr id="11" name="Text 9"/>
-          <p:cNvSpPr/>
-          <p:nvPr/>
-        </p:nvSpPr>
-        <p:spPr>
-          <a:xfrm>
-            <a:off x="4663440" y="2286000"/>
-            <a:ext cx="548640" cy="548640"/>
-          </a:xfrm>
-          <a:prstGeom prst="rect">
-            <a:avLst/>
-          </a:prstGeom>
-          <a:noFill/>
-          <a:ln/>
-        </p:spPr>
-        <p:txBody>
-          <a:bodyPr wrap="square" lIns="0" tIns="0" rIns="0" bIns="0" rtlCol="0" anchor="ctr"/>
-          <a:lstStyle/>
-          <a:p>
-            <a:pPr marL="0" indent="0" algn="ctr">
-              <a:buNone/>
-            </a:pPr>
-            <a:r>
-              <a:rPr lang="en-US" sz="2000" b="1" dirty="0">
-                <a:solidFill>
-                  <a:srgbClr val="FFFFFF"/>
-                </a:solidFill>
-                <a:latin typeface="Calibri" pitchFamily="34" charset="0"/>
-                <a:ea typeface="Calibri" pitchFamily="34" charset="-122"/>
-                <a:cs typeface="Calibri" pitchFamily="34" charset="-120"/>
-              </a:rPr>
-              <a:t>2</a:t>
-            </a:r>
-            <a:endParaRPr lang="en-US" sz="2000" dirty="0"/>
-          </a:p>
-        </p:txBody>
-      </p:sp>
-      <p:sp>
-        <p:nvSpPr>
           <p:cNvPr id="14" name="Shape 12"/>
           <p:cNvSpPr/>
           <p:nvPr/>
@@ -7789,7 +7737,7 @@
           <a:bodyPr/>
           <a:lstStyle/>
           <a:p>
-            <a:endParaRPr lang="es-CO"/>
+            <a:endParaRPr lang="es-CO" dirty="0"/>
           </a:p>
         </p:txBody>
       </p:sp>
@@ -7826,7 +7774,7 @@
                 <a:ea typeface="Calibri" pitchFamily="34" charset="-122"/>
                 <a:cs typeface="Calibri" pitchFamily="34" charset="-120"/>
               </a:rPr>
-              <a:t>3</a:t>
+              <a:t>2</a:t>
             </a:r>
             <a:endParaRPr lang="en-US" sz="2000" dirty="0"/>
           </a:p>
@@ -8086,8 +8034,9 @@
                 </a:solidFill>
                 <a:latin typeface="Cambria" pitchFamily="34" charset="0"/>
                 <a:ea typeface="Cambria" pitchFamily="34" charset="-122"/>
-              </a:rPr>
-              <a:t>Proyecto </a:t>
+                <a:cs typeface="Cambria" pitchFamily="34" charset="-120"/>
+              </a:rPr>
+              <a:t>Un pipeline a </a:t>
             </a:r>
             <a:r>
               <a:rPr lang="en-US" sz="3000" b="1" dirty="0" err="1">
@@ -8096,8 +8045,9 @@
                 </a:solidFill>
                 <a:latin typeface="Cambria" pitchFamily="34" charset="0"/>
                 <a:ea typeface="Cambria" pitchFamily="34" charset="-122"/>
-              </a:rPr>
-              <a:t>durante</a:t>
+                <a:cs typeface="Cambria" pitchFamily="34" charset="-120"/>
+              </a:rPr>
+              <a:t>desarrollar</a:t>
             </a:r>
             <a:r>
               <a:rPr lang="en-US" sz="3000" b="1" dirty="0">
@@ -8106,8 +8056,9 @@
                 </a:solidFill>
                 <a:latin typeface="Cambria" pitchFamily="34" charset="0"/>
                 <a:ea typeface="Cambria" pitchFamily="34" charset="-122"/>
-              </a:rPr>
-              <a:t> el </a:t>
+                <a:cs typeface="Cambria" pitchFamily="34" charset="-120"/>
+              </a:rPr>
+              <a:t> </a:t>
             </a:r>
             <a:r>
               <a:rPr lang="en-US" sz="3000" b="1" dirty="0" err="1">
@@ -8116,6 +8067,29 @@
                 </a:solidFill>
                 <a:latin typeface="Cambria" pitchFamily="34" charset="0"/>
                 <a:ea typeface="Cambria" pitchFamily="34" charset="-122"/>
+                <a:cs typeface="Cambria" pitchFamily="34" charset="-120"/>
+              </a:rPr>
+              <a:t>durante</a:t>
+            </a:r>
+            <a:r>
+              <a:rPr lang="en-US" sz="3000" b="1" dirty="0">
+                <a:solidFill>
+                  <a:srgbClr val="1E2761"/>
+                </a:solidFill>
+                <a:latin typeface="Cambria" pitchFamily="34" charset="0"/>
+                <a:ea typeface="Cambria" pitchFamily="34" charset="-122"/>
+                <a:cs typeface="Cambria" pitchFamily="34" charset="-120"/>
+              </a:rPr>
+              <a:t> el </a:t>
+            </a:r>
+            <a:r>
+              <a:rPr lang="en-US" sz="3000" b="1" dirty="0" err="1">
+                <a:solidFill>
+                  <a:srgbClr val="1E2761"/>
+                </a:solidFill>
+                <a:latin typeface="Cambria" pitchFamily="34" charset="0"/>
+                <a:ea typeface="Cambria" pitchFamily="34" charset="-122"/>
+                <a:cs typeface="Cambria" pitchFamily="34" charset="-120"/>
               </a:rPr>
               <a:t>semestre</a:t>
             </a:r>
@@ -9458,6 +9432,45 @@
       </p:grpSpPr>
       <p:sp>
         <p:nvSpPr>
+          <p:cNvPr id="2" name="Text 0"/>
+          <p:cNvSpPr/>
+          <p:nvPr/>
+        </p:nvSpPr>
+        <p:spPr>
+          <a:xfrm>
+            <a:off x="548640" y="411480"/>
+            <a:ext cx="9144000" cy="320040"/>
+          </a:xfrm>
+          <a:prstGeom prst="rect">
+            <a:avLst/>
+          </a:prstGeom>
+          <a:noFill/>
+          <a:ln/>
+        </p:spPr>
+        <p:txBody>
+          <a:bodyPr wrap="square" lIns="0" tIns="0" rIns="0" bIns="0" rtlCol="0" anchor="ctr"/>
+          <a:lstStyle/>
+          <a:p>
+            <a:pPr marL="0" indent="0">
+              <a:buNone/>
+            </a:pPr>
+            <a:r>
+              <a:rPr lang="en-US" sz="1300" b="1" kern="0" spc="200" dirty="0">
+                <a:solidFill>
+                  <a:srgbClr val="B33A3A"/>
+                </a:solidFill>
+                <a:latin typeface="Calibri" pitchFamily="34" charset="0"/>
+                <a:ea typeface="Calibri" pitchFamily="34" charset="-122"/>
+                <a:cs typeface="Calibri" pitchFamily="34" charset="-120"/>
+              </a:rPr>
+              <a:t>E</a:t>
+            </a:r>
+            <a:endParaRPr lang="en-US" sz="1300" dirty="0"/>
+          </a:p>
+        </p:txBody>
+      </p:sp>
+      <p:sp>
+        <p:nvSpPr>
           <p:cNvPr id="3" name="Text 1"/>
           <p:cNvSpPr/>
           <p:nvPr/>
@@ -9500,18 +9513,7 @@
                 <a:ea typeface="Cambria" pitchFamily="34" charset="-122"/>
                 <a:cs typeface="Cambria" pitchFamily="34" charset="-120"/>
               </a:rPr>
-              <a:t> </a:t>
-            </a:r>
-            <a:r>
-              <a:rPr lang="en-US" sz="3000" b="1" dirty="0" err="1">
-                <a:solidFill>
-                  <a:srgbClr val="1E2761"/>
-                </a:solidFill>
-                <a:latin typeface="Cambria" pitchFamily="34" charset="0"/>
-                <a:ea typeface="Cambria" pitchFamily="34" charset="-122"/>
-                <a:cs typeface="Cambria" pitchFamily="34" charset="-120"/>
-              </a:rPr>
-              <a:t>Obtenido</a:t>
+              <a:t> general</a:t>
             </a:r>
             <a:endParaRPr lang="en-US" sz="3000" dirty="0"/>
           </a:p>
@@ -10189,7 +10191,7 @@
                 <a:ea typeface="Calibri" pitchFamily="34" charset="-122"/>
                 <a:cs typeface="Calibri" pitchFamily="34" charset="-120"/>
               </a:rPr>
-              <a:t> para la </a:t>
+              <a:t>  para la </a:t>
             </a:r>
             <a:r>
               <a:rPr lang="en-US" sz="1600" dirty="0" err="1">
@@ -10211,16 +10213,19 @@
                 <a:ea typeface="Calibri" pitchFamily="34" charset="-122"/>
                 <a:cs typeface="Calibri" pitchFamily="34" charset="-120"/>
               </a:rPr>
-              <a:t> de decisiones</a:t>
-            </a:r>
-          </a:p>
-          <a:p>
-            <a:pPr marL="0" indent="0">
-              <a:lnSpc>
-                <a:spcPct val="125000"/>
-              </a:lnSpc>
-              <a:buNone/>
-            </a:pPr>
+              <a:t> de </a:t>
+            </a:r>
+            <a:r>
+              <a:rPr lang="en-US" sz="1600" dirty="0" err="1">
+                <a:solidFill>
+                  <a:srgbClr val="5A5F73"/>
+                </a:solidFill>
+                <a:latin typeface="Calibri" pitchFamily="34" charset="0"/>
+                <a:ea typeface="Calibri" pitchFamily="34" charset="-122"/>
+                <a:cs typeface="Calibri" pitchFamily="34" charset="-120"/>
+              </a:rPr>
+              <a:t>decisiones</a:t>
+            </a:r>
             <a:endParaRPr lang="en-US" sz="1600" dirty="0">
               <a:solidFill>
                 <a:srgbClr val="5A5F73"/>
@@ -10237,135 +10242,6 @@
               </a:lnSpc>
               <a:buNone/>
             </a:pPr>
-            <a:r>
-              <a:rPr lang="en-US" sz="1600" dirty="0">
-                <a:solidFill>
-                  <a:srgbClr val="5A5F73"/>
-                </a:solidFill>
-                <a:latin typeface="Calibri" pitchFamily="34" charset="0"/>
-                <a:ea typeface="Calibri" pitchFamily="34" charset="-122"/>
-                <a:cs typeface="Calibri" pitchFamily="34" charset="-120"/>
-              </a:rPr>
-              <a:t>Los </a:t>
-            </a:r>
-            <a:r>
-              <a:rPr lang="en-US" sz="1600" dirty="0" err="1">
-                <a:solidFill>
-                  <a:srgbClr val="5A5F73"/>
-                </a:solidFill>
-                <a:latin typeface="Calibri" pitchFamily="34" charset="0"/>
-                <a:ea typeface="Calibri" pitchFamily="34" charset="-122"/>
-                <a:cs typeface="Calibri" pitchFamily="34" charset="-120"/>
-              </a:rPr>
-              <a:t>datos</a:t>
-            </a:r>
-            <a:r>
-              <a:rPr lang="en-US" sz="1600" dirty="0">
-                <a:solidFill>
-                  <a:srgbClr val="5A5F73"/>
-                </a:solidFill>
-                <a:latin typeface="Calibri" pitchFamily="34" charset="0"/>
-                <a:ea typeface="Calibri" pitchFamily="34" charset="-122"/>
-                <a:cs typeface="Calibri" pitchFamily="34" charset="-120"/>
-              </a:rPr>
-              <a:t> </a:t>
-            </a:r>
-            <a:r>
-              <a:rPr lang="en-US" sz="1600" dirty="0" err="1">
-                <a:solidFill>
-                  <a:srgbClr val="5A5F73"/>
-                </a:solidFill>
-                <a:latin typeface="Calibri" pitchFamily="34" charset="0"/>
-                <a:ea typeface="Calibri" pitchFamily="34" charset="-122"/>
-                <a:cs typeface="Calibri" pitchFamily="34" charset="-120"/>
-              </a:rPr>
-              <a:t>crediticios</a:t>
-            </a:r>
-            <a:r>
-              <a:rPr lang="en-US" sz="1600" dirty="0">
-                <a:solidFill>
-                  <a:srgbClr val="5A5F73"/>
-                </a:solidFill>
-                <a:latin typeface="Calibri" pitchFamily="34" charset="0"/>
-                <a:ea typeface="Calibri" pitchFamily="34" charset="-122"/>
-                <a:cs typeface="Calibri" pitchFamily="34" charset="-120"/>
-              </a:rPr>
-              <a:t> van </a:t>
-            </a:r>
-            <a:r>
-              <a:rPr lang="en-US" sz="1600" dirty="0" err="1">
-                <a:solidFill>
-                  <a:srgbClr val="5A5F73"/>
-                </a:solidFill>
-                <a:latin typeface="Calibri" pitchFamily="34" charset="0"/>
-                <a:ea typeface="Calibri" pitchFamily="34" charset="-122"/>
-                <a:cs typeface="Calibri" pitchFamily="34" charset="-120"/>
-              </a:rPr>
-              <a:t>desde</a:t>
-            </a:r>
-            <a:r>
-              <a:rPr lang="en-US" sz="1600" dirty="0">
-                <a:solidFill>
-                  <a:srgbClr val="5A5F73"/>
-                </a:solidFill>
-                <a:latin typeface="Calibri" pitchFamily="34" charset="0"/>
-                <a:ea typeface="Calibri" pitchFamily="34" charset="-122"/>
-                <a:cs typeface="Calibri" pitchFamily="34" charset="-120"/>
-              </a:rPr>
-              <a:t> </a:t>
-            </a:r>
-            <a:r>
-              <a:rPr lang="en-US" sz="1600" dirty="0" err="1">
-                <a:solidFill>
-                  <a:srgbClr val="5A5F73"/>
-                </a:solidFill>
-                <a:latin typeface="Calibri" pitchFamily="34" charset="0"/>
-                <a:ea typeface="Calibri" pitchFamily="34" charset="-122"/>
-                <a:cs typeface="Calibri" pitchFamily="34" charset="-120"/>
-              </a:rPr>
-              <a:t>noviembre</a:t>
-            </a:r>
-            <a:r>
-              <a:rPr lang="en-US" sz="1600" dirty="0">
-                <a:solidFill>
-                  <a:srgbClr val="5A5F73"/>
-                </a:solidFill>
-                <a:latin typeface="Calibri" pitchFamily="34" charset="0"/>
-                <a:ea typeface="Calibri" pitchFamily="34" charset="-122"/>
-                <a:cs typeface="Calibri" pitchFamily="34" charset="-120"/>
-              </a:rPr>
-              <a:t> del 2024 hasta </a:t>
-            </a:r>
-            <a:r>
-              <a:rPr lang="en-US" sz="1600" dirty="0" err="1">
-                <a:solidFill>
-                  <a:srgbClr val="5A5F73"/>
-                </a:solidFill>
-                <a:latin typeface="Calibri" pitchFamily="34" charset="0"/>
-                <a:ea typeface="Calibri" pitchFamily="34" charset="-122"/>
-                <a:cs typeface="Calibri" pitchFamily="34" charset="-120"/>
-              </a:rPr>
-              <a:t>abril</a:t>
-            </a:r>
-            <a:r>
-              <a:rPr lang="en-US" sz="1600" dirty="0">
-                <a:solidFill>
-                  <a:srgbClr val="5A5F73"/>
-                </a:solidFill>
-                <a:latin typeface="Calibri" pitchFamily="34" charset="0"/>
-                <a:ea typeface="Calibri" pitchFamily="34" charset="-122"/>
-                <a:cs typeface="Calibri" pitchFamily="34" charset="-120"/>
-              </a:rPr>
-              <a:t> 2026</a:t>
-            </a:r>
-          </a:p>
-          <a:p>
-            <a:pPr marL="0" indent="0">
-              <a:lnSpc>
-                <a:spcPct val="125000"/>
-              </a:lnSpc>
-              <a:buNone/>
-            </a:pPr>
             <a:endParaRPr lang="en-US" sz="1600" dirty="0">
               <a:solidFill>
                 <a:srgbClr val="5A5F73"/>
@@ -10383,6 +10259,17 @@
               <a:buNone/>
             </a:pPr>
             <a:r>
+              <a:rPr lang="en-US" sz="1600" dirty="0">
+                <a:solidFill>
+                  <a:srgbClr val="5A5F73"/>
+                </a:solidFill>
+                <a:latin typeface="Calibri" pitchFamily="34" charset="0"/>
+                <a:ea typeface="Calibri" pitchFamily="34" charset="-122"/>
+                <a:cs typeface="Calibri" pitchFamily="34" charset="-120"/>
+              </a:rPr>
+              <a:t>Los </a:t>
+            </a:r>
+            <a:r>
               <a:rPr lang="en-US" sz="1600" dirty="0" err="1">
                 <a:solidFill>
                   <a:srgbClr val="5A5F73"/>
@@ -10391,7 +10278,7 @@
                 <a:ea typeface="Calibri" pitchFamily="34" charset="-122"/>
                 <a:cs typeface="Calibri" pitchFamily="34" charset="-120"/>
               </a:rPr>
-              <a:t>Además</a:t>
+              <a:t>dato</a:t>
             </a:r>
             <a:r>
               <a:rPr lang="en-US" sz="1600" dirty="0">
@@ -10402,7 +10289,7 @@
                 <a:ea typeface="Calibri" pitchFamily="34" charset="-122"/>
                 <a:cs typeface="Calibri" pitchFamily="34" charset="-120"/>
               </a:rPr>
-              <a:t> se propone la </a:t>
+              <a:t> se dan </a:t>
             </a:r>
             <a:r>
               <a:rPr lang="en-US" sz="1600" dirty="0" err="1">
@@ -10413,7 +10300,7 @@
                 <a:ea typeface="Calibri" pitchFamily="34" charset="-122"/>
                 <a:cs typeface="Calibri" pitchFamily="34" charset="-120"/>
               </a:rPr>
-              <a:t>construcción</a:t>
+              <a:t>desde</a:t>
             </a:r>
             <a:r>
               <a:rPr lang="en-US" sz="1600" dirty="0">
@@ -10424,7 +10311,7 @@
                 <a:ea typeface="Calibri" pitchFamily="34" charset="-122"/>
                 <a:cs typeface="Calibri" pitchFamily="34" charset="-120"/>
               </a:rPr>
-              <a:t> de un diccionario de </a:t>
+              <a:t> </a:t>
             </a:r>
             <a:r>
               <a:rPr lang="en-US" sz="1600" dirty="0" err="1">
@@ -10435,40 +10322,41 @@
                 <a:ea typeface="Calibri" pitchFamily="34" charset="-122"/>
                 <a:cs typeface="Calibri" pitchFamily="34" charset="-120"/>
               </a:rPr>
-              <a:t>datos</a:t>
-            </a:r>
-            <a:endParaRPr lang="en-US" sz="1600" dirty="0">
-              <a:solidFill>
-                <a:srgbClr val="5A5F73"/>
-              </a:solidFill>
-              <a:latin typeface="Calibri" pitchFamily="34" charset="0"/>
-              <a:ea typeface="Calibri" pitchFamily="34" charset="-122"/>
-              <a:cs typeface="Calibri" pitchFamily="34" charset="-120"/>
-            </a:endParaRPr>
-          </a:p>
-          <a:p>
-            <a:pPr marL="0" indent="0">
-              <a:lnSpc>
-                <a:spcPct val="125000"/>
-              </a:lnSpc>
-              <a:buNone/>
-            </a:pPr>
-            <a:endParaRPr lang="en-US" sz="1600" dirty="0">
-              <a:solidFill>
-                <a:srgbClr val="5A5F73"/>
-              </a:solidFill>
-              <a:latin typeface="Calibri" pitchFamily="34" charset="0"/>
-              <a:ea typeface="Calibri" pitchFamily="34" charset="-122"/>
-              <a:cs typeface="Calibri" pitchFamily="34" charset="-120"/>
-            </a:endParaRPr>
-          </a:p>
-          <a:p>
-            <a:pPr marL="0" indent="0">
-              <a:lnSpc>
-                <a:spcPct val="125000"/>
-              </a:lnSpc>
-              <a:buNone/>
-            </a:pPr>
+              <a:t>noviembre</a:t>
+            </a:r>
+            <a:r>
+              <a:rPr lang="en-US" sz="1600" dirty="0">
+                <a:solidFill>
+                  <a:srgbClr val="5A5F73"/>
+                </a:solidFill>
+                <a:latin typeface="Calibri" pitchFamily="34" charset="0"/>
+                <a:ea typeface="Calibri" pitchFamily="34" charset="-122"/>
+                <a:cs typeface="Calibri" pitchFamily="34" charset="-120"/>
+              </a:rPr>
+              <a:t> del 2024 hasta </a:t>
+            </a:r>
+            <a:r>
+              <a:rPr lang="en-US" sz="1600" dirty="0" err="1">
+                <a:solidFill>
+                  <a:srgbClr val="5A5F73"/>
+                </a:solidFill>
+                <a:latin typeface="Calibri" pitchFamily="34" charset="0"/>
+                <a:ea typeface="Calibri" pitchFamily="34" charset="-122"/>
+                <a:cs typeface="Calibri" pitchFamily="34" charset="-120"/>
+              </a:rPr>
+              <a:t>abril</a:t>
+            </a:r>
+            <a:r>
+              <a:rPr lang="en-US" sz="1600" dirty="0">
+                <a:solidFill>
+                  <a:srgbClr val="5A5F73"/>
+                </a:solidFill>
+                <a:latin typeface="Calibri" pitchFamily="34" charset="0"/>
+                <a:ea typeface="Calibri" pitchFamily="34" charset="-122"/>
+                <a:cs typeface="Calibri" pitchFamily="34" charset="-120"/>
+              </a:rPr>
+              <a:t> 2026</a:t>
+            </a:r>
             <a:endParaRPr lang="en-US" sz="1600" dirty="0"/>
           </a:p>
         </p:txBody>
@@ -10879,6 +10767,51 @@
               <a:t>3</a:t>
             </a:r>
             <a:endParaRPr lang="en-US" sz="1000" dirty="0"/>
+          </a:p>
+        </p:txBody>
+      </p:sp>
+      <p:sp>
+        <p:nvSpPr>
+          <p:cNvPr id="17" name="Shape 9">
+            <a:extLst>
+              <a:ext uri="{FF2B5EF4-FFF2-40B4-BE49-F238E27FC236}">
+                <a16:creationId xmlns:a16="http://schemas.microsoft.com/office/drawing/2014/main" id="{D525EDD1-6568-B6D4-8B70-CD8A670FC315}"/>
+              </a:ext>
+            </a:extLst>
+          </p:cNvPr>
+          <p:cNvSpPr/>
+          <p:nvPr/>
+        </p:nvSpPr>
+        <p:spPr>
+          <a:xfrm>
+            <a:off x="457200" y="4411980"/>
+            <a:ext cx="4206240" cy="1188720"/>
+          </a:xfrm>
+          <a:prstGeom prst="roundRect">
+            <a:avLst>
+              <a:gd name="adj" fmla="val 6154"/>
+            </a:avLst>
+          </a:prstGeom>
+          <a:solidFill>
+            <a:srgbClr val="F4F7FC"/>
+          </a:solidFill>
+          <a:ln/>
+          <a:effectLst>
+            <a:outerShdw blurRad="76200" dist="25400" dir="5400000" algn="bl" rotWithShape="0">
+              <a:srgbClr val="000000">
+                <a:alpha val="12000"/>
+              </a:srgbClr>
+            </a:outerShdw>
+          </a:effectLst>
+        </p:spPr>
+        <p:txBody>
+          <a:bodyPr/>
+          <a:lstStyle/>
+          <a:p>
+            <a:r>
+              <a:rPr lang="es-CO" dirty="0"/>
+              <a:t>TARGET : Pago a tiempo</a:t>
+            </a:r>
           </a:p>
         </p:txBody>
       </p:sp>
@@ -10915,7 +10848,7 @@
         </p:nvSpPr>
         <p:spPr>
           <a:xfrm>
-            <a:off x="548640" y="402336"/>
+            <a:off x="548640" y="411480"/>
             <a:ext cx="9144000" cy="320040"/>
           </a:xfrm>
           <a:prstGeom prst="rect">
@@ -10940,7 +10873,7 @@
                 <a:ea typeface="Calibri" pitchFamily="34" charset="-122"/>
                 <a:cs typeface="Calibri" pitchFamily="34" charset="-120"/>
               </a:rPr>
-              <a:t>INVESTIGACION SECTOR BANCARIO COLOMBIANO</a:t>
+              <a:t>INVESTIGACIÓN METODOLÓGICA BANCOS EN COLOMBIA</a:t>
             </a:r>
             <a:endParaRPr lang="en-US" sz="1300" dirty="0"/>
           </a:p>
@@ -11018,95 +10951,7 @@
                 <a:ea typeface="Calibri" pitchFamily="34" charset="-122"/>
                 <a:cs typeface="Calibri" pitchFamily="34" charset="-120"/>
               </a:rPr>
-              <a:t>No se </a:t>
-            </a:r>
-            <a:r>
-              <a:rPr lang="en-US" sz="1400" i="1" dirty="0" err="1">
-                <a:solidFill>
-                  <a:srgbClr val="5A5F73"/>
-                </a:solidFill>
-                <a:latin typeface="Calibri" pitchFamily="34" charset="0"/>
-                <a:ea typeface="Calibri" pitchFamily="34" charset="-122"/>
-                <a:cs typeface="Calibri" pitchFamily="34" charset="-120"/>
-              </a:rPr>
-              <a:t>entregó</a:t>
-            </a:r>
-            <a:r>
-              <a:rPr lang="en-US" sz="1400" i="1" dirty="0">
-                <a:solidFill>
-                  <a:srgbClr val="5A5F73"/>
-                </a:solidFill>
-                <a:latin typeface="Calibri" pitchFamily="34" charset="0"/>
-                <a:ea typeface="Calibri" pitchFamily="34" charset="-122"/>
-                <a:cs typeface="Calibri" pitchFamily="34" charset="-120"/>
-              </a:rPr>
-              <a:t> diccionario , </a:t>
-            </a:r>
-            <a:r>
-              <a:rPr lang="en-US" sz="1400" i="1" dirty="0" err="1">
-                <a:solidFill>
-                  <a:srgbClr val="5A5F73"/>
-                </a:solidFill>
-                <a:latin typeface="Calibri" pitchFamily="34" charset="0"/>
-                <a:ea typeface="Calibri" pitchFamily="34" charset="-122"/>
-                <a:cs typeface="Calibri" pitchFamily="34" charset="-120"/>
-              </a:rPr>
-              <a:t>entonces</a:t>
-            </a:r>
-            <a:r>
-              <a:rPr lang="en-US" sz="1400" i="1" dirty="0">
-                <a:solidFill>
-                  <a:srgbClr val="5A5F73"/>
-                </a:solidFill>
-                <a:latin typeface="Calibri" pitchFamily="34" charset="0"/>
-                <a:ea typeface="Calibri" pitchFamily="34" charset="-122"/>
-                <a:cs typeface="Calibri" pitchFamily="34" charset="-120"/>
-              </a:rPr>
-              <a:t> se </a:t>
-            </a:r>
-            <a:r>
-              <a:rPr lang="en-US" sz="1400" i="1" dirty="0" err="1">
-                <a:solidFill>
-                  <a:srgbClr val="5A5F73"/>
-                </a:solidFill>
-                <a:latin typeface="Calibri" pitchFamily="34" charset="0"/>
-                <a:ea typeface="Calibri" pitchFamily="34" charset="-122"/>
-                <a:cs typeface="Calibri" pitchFamily="34" charset="-120"/>
-              </a:rPr>
-              <a:t>implementa</a:t>
-            </a:r>
-            <a:r>
-              <a:rPr lang="en-US" sz="1400" i="1" dirty="0">
-                <a:solidFill>
-                  <a:srgbClr val="5A5F73"/>
-                </a:solidFill>
-                <a:latin typeface="Calibri" pitchFamily="34" charset="0"/>
-                <a:ea typeface="Calibri" pitchFamily="34" charset="-122"/>
-                <a:cs typeface="Calibri" pitchFamily="34" charset="-120"/>
-              </a:rPr>
-              <a:t> un diccionario de </a:t>
-            </a:r>
-            <a:r>
-              <a:rPr lang="en-US" sz="1400" i="1" dirty="0" err="1">
-                <a:solidFill>
-                  <a:srgbClr val="5A5F73"/>
-                </a:solidFill>
-                <a:latin typeface="Calibri" pitchFamily="34" charset="0"/>
-                <a:ea typeface="Calibri" pitchFamily="34" charset="-122"/>
-                <a:cs typeface="Calibri" pitchFamily="34" charset="-120"/>
-              </a:rPr>
-              <a:t>datos</a:t>
-            </a:r>
-            <a:r>
-              <a:rPr lang="en-US" sz="1400" i="1" dirty="0">
-                <a:solidFill>
-                  <a:srgbClr val="5A5F73"/>
-                </a:solidFill>
-                <a:latin typeface="Calibri" pitchFamily="34" charset="0"/>
-                <a:ea typeface="Calibri" pitchFamily="34" charset="-122"/>
-                <a:cs typeface="Calibri" pitchFamily="34" charset="-120"/>
-              </a:rPr>
-              <a:t>.</a:t>
+              <a:t>No se entregó diccionario. Construirlo reveló tres errores metodológicos reales.</a:t>
             </a:r>
             <a:endParaRPr lang="en-US" sz="1400" dirty="0"/>
           </a:p>
@@ -11845,7 +11690,7 @@
         </p:nvSpPr>
         <p:spPr>
           <a:xfrm>
-            <a:off x="548640" y="4640113"/>
+            <a:off x="548640" y="4663440"/>
             <a:ext cx="11064240" cy="1051560"/>
           </a:xfrm>
           <a:prstGeom prst="roundRect">
@@ -11895,9 +11740,6 @@
             </a:pPr>
             <a:r>
               <a:rPr lang="en-US" sz="1200" b="1" dirty="0">
-                <a:solidFill>
-                  <a:srgbClr val="1E2761"/>
-                </a:solidFill>
                 <a:latin typeface="Calibri" pitchFamily="34" charset="0"/>
                 <a:ea typeface="Calibri" pitchFamily="34" charset="-122"/>
                 <a:cs typeface="Calibri" pitchFamily="34" charset="-120"/>
@@ -11910,7 +11752,7 @@
                 <a:ea typeface="Calibri" pitchFamily="34" charset="-122"/>
                 <a:cs typeface="Calibri" pitchFamily="34" charset="-120"/>
               </a:rPr>
-              <a:t>bajo Ley 1266 de 2008 todas las variables son (dato financiero y crediticio). Ninguna es </a:t>
+              <a:t>bajo Ley 1266 de 2008 todas las variables son </a:t>
             </a:r>
             <a:r>
               <a:rPr lang="en-US" sz="1200" b="1" dirty="0">
@@ -11918,6 +11760,22 @@
                 <a:ea typeface="Calibri" pitchFamily="34" charset="-122"/>
                 <a:cs typeface="Calibri" pitchFamily="34" charset="-120"/>
               </a:rPr>
+              <a:t>semiprivadas</a:t>
+            </a:r>
+            <a:r>
+              <a:rPr lang="en-US" sz="1200" dirty="0">
+                <a:latin typeface="Calibri" pitchFamily="34" charset="0"/>
+                <a:ea typeface="Calibri" pitchFamily="34" charset="-122"/>
+                <a:cs typeface="Calibri" pitchFamily="34" charset="-120"/>
+              </a:rPr>
+              <a:t> (dato financiero y crediticio). Ninguna es </a:t>
+            </a:r>
+            <a:r>
+              <a:rPr lang="en-US" sz="1200" b="1" dirty="0">
+                <a:latin typeface="Calibri" pitchFamily="34" charset="0"/>
+                <a:ea typeface="Calibri" pitchFamily="34" charset="-122"/>
+                <a:cs typeface="Calibri" pitchFamily="34" charset="-120"/>
+              </a:rPr>
               <a:t>sensible</a:t>
             </a:r>
             <a:r>
@@ -11926,7 +11784,7 @@
                 <a:ea typeface="Calibri" pitchFamily="34" charset="-122"/>
                 <a:cs typeface="Calibri" pitchFamily="34" charset="-120"/>
               </a:rPr>
-              <a:t> en el sentido de la Ley 1581 art. 5</a:t>
+              <a:t> en el sentido de la Ley 1581 art. 5 (origen racial, salud, biometría).</a:t>
             </a:r>
             <a:endParaRPr lang="en-US" sz="1200" dirty="0"/>
           </a:p>
@@ -12107,7 +11965,7 @@
                 <a:ea typeface="Cambria" pitchFamily="34" charset="-122"/>
                 <a:cs typeface="Cambria" pitchFamily="34" charset="-120"/>
               </a:rPr>
-              <a:t>Tres errores que el diccionario </a:t>
+              <a:t>Tres errores que el </a:t>
             </a:r>
             <a:r>
               <a:rPr lang="en-US" sz="3000" b="1" dirty="0" err="1">
@@ -12118,7 +11976,7 @@
                 <a:ea typeface="Cambria" pitchFamily="34" charset="-122"/>
                 <a:cs typeface="Cambria" pitchFamily="34" charset="-120"/>
               </a:rPr>
-              <a:t>permitió</a:t>
+              <a:t>diccionario</a:t>
             </a:r>
             <a:r>
               <a:rPr lang="en-US" sz="3000" b="1" dirty="0">
@@ -12140,7 +11998,29 @@
                 <a:ea typeface="Cambria" pitchFamily="34" charset="-122"/>
                 <a:cs typeface="Cambria" pitchFamily="34" charset="-120"/>
               </a:rPr>
-              <a:t>conocer</a:t>
+              <a:t>permitió</a:t>
+            </a:r>
+            <a:r>
+              <a:rPr lang="en-US" sz="3000" b="1" dirty="0">
+                <a:solidFill>
+                  <a:srgbClr val="1E2761"/>
+                </a:solidFill>
+                <a:latin typeface="Cambria" pitchFamily="34" charset="0"/>
+                <a:ea typeface="Cambria" pitchFamily="34" charset="-122"/>
+                <a:cs typeface="Cambria" pitchFamily="34" charset="-120"/>
+              </a:rPr>
+              <a:t> </a:t>
+            </a:r>
+            <a:r>
+              <a:rPr lang="en-US" sz="3000" b="1" dirty="0" err="1">
+                <a:solidFill>
+                  <a:srgbClr val="1E2761"/>
+                </a:solidFill>
+                <a:latin typeface="Cambria" pitchFamily="34" charset="0"/>
+                <a:ea typeface="Cambria" pitchFamily="34" charset="-122"/>
+                <a:cs typeface="Cambria" pitchFamily="34" charset="-120"/>
+              </a:rPr>
+              <a:t>revelar</a:t>
             </a:r>
             <a:endParaRPr lang="en-US" sz="3000" dirty="0"/>
           </a:p>
@@ -13877,7 +13757,7 @@
               <a:buNone/>
             </a:pPr>
             <a:r>
-              <a:rPr lang="en-US" sz="3000" b="1" dirty="0">
+              <a:rPr lang="en-US" sz="3000" b="1" dirty="0" err="1">
                 <a:solidFill>
                   <a:srgbClr val="1E2761"/>
                 </a:solidFill>
@@ -13885,7 +13765,40 @@
                 <a:ea typeface="Cambria" pitchFamily="34" charset="-122"/>
                 <a:cs typeface="Cambria" pitchFamily="34" charset="-120"/>
               </a:rPr>
-              <a:t>Lo que encontramos antes de analizar</a:t>
+              <a:t>Información</a:t>
+            </a:r>
+            <a:r>
+              <a:rPr lang="en-US" sz="3000" b="1" dirty="0">
+                <a:solidFill>
+                  <a:srgbClr val="1E2761"/>
+                </a:solidFill>
+                <a:latin typeface="Cambria" pitchFamily="34" charset="0"/>
+                <a:ea typeface="Cambria" pitchFamily="34" charset="-122"/>
+                <a:cs typeface="Cambria" pitchFamily="34" charset="-120"/>
+              </a:rPr>
+              <a:t> </a:t>
+            </a:r>
+            <a:r>
+              <a:rPr lang="en-US" sz="3000" b="1" dirty="0" err="1">
+                <a:solidFill>
+                  <a:srgbClr val="1E2761"/>
+                </a:solidFill>
+                <a:latin typeface="Cambria" pitchFamily="34" charset="0"/>
+                <a:ea typeface="Cambria" pitchFamily="34" charset="-122"/>
+                <a:cs typeface="Cambria" pitchFamily="34" charset="-120"/>
+              </a:rPr>
+              <a:t>encontrada</a:t>
+            </a:r>
+            <a:r>
+              <a:rPr lang="en-US" sz="3000" b="1" dirty="0">
+                <a:solidFill>
+                  <a:srgbClr val="1E2761"/>
+                </a:solidFill>
+                <a:latin typeface="Cambria" pitchFamily="34" charset="0"/>
+                <a:ea typeface="Cambria" pitchFamily="34" charset="-122"/>
+                <a:cs typeface="Cambria" pitchFamily="34" charset="-120"/>
+              </a:rPr>
+              <a:t> antes de analizar</a:t>
             </a:r>
             <a:endParaRPr lang="en-US" sz="3000" dirty="0"/>
           </a:p>
@@ -14614,7 +14527,106 @@
                 <a:ea typeface="Cambria" pitchFamily="34" charset="-122"/>
                 <a:cs typeface="Cambria" pitchFamily="34" charset="-120"/>
               </a:rPr>
-              <a:t>Un desbalance que condiciona todo el análisis</a:t>
+              <a:t>Un </a:t>
+            </a:r>
+            <a:r>
+              <a:rPr lang="en-US" sz="3000" b="1" dirty="0" err="1">
+                <a:solidFill>
+                  <a:srgbClr val="1E2761"/>
+                </a:solidFill>
+                <a:latin typeface="Cambria" pitchFamily="34" charset="0"/>
+                <a:ea typeface="Cambria" pitchFamily="34" charset="-122"/>
+                <a:cs typeface="Cambria" pitchFamily="34" charset="-120"/>
+              </a:rPr>
+              <a:t>desbalance</a:t>
+            </a:r>
+            <a:r>
+              <a:rPr lang="en-US" sz="3000" b="1" dirty="0">
+                <a:solidFill>
+                  <a:srgbClr val="1E2761"/>
+                </a:solidFill>
+                <a:latin typeface="Cambria" pitchFamily="34" charset="0"/>
+                <a:ea typeface="Cambria" pitchFamily="34" charset="-122"/>
+                <a:cs typeface="Cambria" pitchFamily="34" charset="-120"/>
+              </a:rPr>
+              <a:t> </a:t>
+            </a:r>
+            <a:r>
+              <a:rPr lang="en-US" sz="3000" b="1" dirty="0" err="1">
+                <a:solidFill>
+                  <a:srgbClr val="1E2761"/>
+                </a:solidFill>
+                <a:latin typeface="Cambria" pitchFamily="34" charset="0"/>
+                <a:ea typeface="Cambria" pitchFamily="34" charset="-122"/>
+                <a:cs typeface="Cambria" pitchFamily="34" charset="-120"/>
+              </a:rPr>
+              <a:t>importante</a:t>
+            </a:r>
+            <a:r>
+              <a:rPr lang="en-US" sz="3000" b="1" dirty="0">
+                <a:solidFill>
+                  <a:srgbClr val="1E2761"/>
+                </a:solidFill>
+                <a:latin typeface="Cambria" pitchFamily="34" charset="0"/>
+                <a:ea typeface="Cambria" pitchFamily="34" charset="-122"/>
+                <a:cs typeface="Cambria" pitchFamily="34" charset="-120"/>
+              </a:rPr>
+              <a:t> a </a:t>
+            </a:r>
+            <a:r>
+              <a:rPr lang="en-US" sz="3000" b="1" dirty="0" err="1">
+                <a:solidFill>
+                  <a:srgbClr val="1E2761"/>
+                </a:solidFill>
+                <a:latin typeface="Cambria" pitchFamily="34" charset="0"/>
+                <a:ea typeface="Cambria" pitchFamily="34" charset="-122"/>
+                <a:cs typeface="Cambria" pitchFamily="34" charset="-120"/>
+              </a:rPr>
+              <a:t>tener</a:t>
+            </a:r>
+            <a:r>
+              <a:rPr lang="en-US" sz="3000" b="1" dirty="0">
+                <a:solidFill>
+                  <a:srgbClr val="1E2761"/>
+                </a:solidFill>
+                <a:latin typeface="Cambria" pitchFamily="34" charset="0"/>
+                <a:ea typeface="Cambria" pitchFamily="34" charset="-122"/>
+                <a:cs typeface="Cambria" pitchFamily="34" charset="-120"/>
+              </a:rPr>
+              <a:t> </a:t>
+            </a:r>
+            <a:r>
+              <a:rPr lang="en-US" sz="3000" b="1" dirty="0" err="1">
+                <a:solidFill>
+                  <a:srgbClr val="1E2761"/>
+                </a:solidFill>
+                <a:latin typeface="Cambria" pitchFamily="34" charset="0"/>
+                <a:ea typeface="Cambria" pitchFamily="34" charset="-122"/>
+                <a:cs typeface="Cambria" pitchFamily="34" charset="-120"/>
+              </a:rPr>
+              <a:t>en</a:t>
+            </a:r>
+            <a:r>
+              <a:rPr lang="en-US" sz="3000" b="1" dirty="0">
+                <a:solidFill>
+                  <a:srgbClr val="1E2761"/>
+                </a:solidFill>
+                <a:latin typeface="Cambria" pitchFamily="34" charset="0"/>
+                <a:ea typeface="Cambria" pitchFamily="34" charset="-122"/>
+                <a:cs typeface="Cambria" pitchFamily="34" charset="-120"/>
+              </a:rPr>
+              <a:t> </a:t>
+            </a:r>
+            <a:r>
+              <a:rPr lang="en-US" sz="3000" b="1" dirty="0" err="1">
+                <a:solidFill>
+                  <a:srgbClr val="1E2761"/>
+                </a:solidFill>
+                <a:latin typeface="Cambria" pitchFamily="34" charset="0"/>
+                <a:ea typeface="Cambria" pitchFamily="34" charset="-122"/>
+                <a:cs typeface="Cambria" pitchFamily="34" charset="-120"/>
+              </a:rPr>
+              <a:t>cuenta</a:t>
             </a:r>
             <a:endParaRPr lang="en-US" sz="3000" dirty="0"/>
           </a:p>

</xml_diff>

<commit_message>
feat(eda): agrega dispersion y tablas pivote
</commit_message>
<xml_diff>
--- a/PRESENTACION.pptx
+++ b/PRESENTACION.pptx
@@ -207,7 +207,7 @@
             </c:spPr>
             <c:extLst>
               <c:ext xmlns:c16="http://schemas.microsoft.com/office/drawing/2014/chart" uri="{C3380CC4-5D6E-409C-BE32-E72D297353CC}">
-                <c16:uniqueId val="{00000001-2A58-4B65-9023-DC9A707F2F27}"/>
+                <c16:uniqueId val="{00000001-D9A9-43B9-99B2-1E42F13B03AE}"/>
               </c:ext>
             </c:extLst>
           </c:dPt>
@@ -222,7 +222,7 @@
             </c:spPr>
             <c:extLst>
               <c:ext xmlns:c16="http://schemas.microsoft.com/office/drawing/2014/chart" uri="{C3380CC4-5D6E-409C-BE32-E72D297353CC}">
-                <c16:uniqueId val="{00000003-2A58-4B65-9023-DC9A707F2F27}"/>
+                <c16:uniqueId val="{00000003-D9A9-43B9-99B2-1E42F13B03AE}"/>
               </c:ext>
             </c:extLst>
           </c:dPt>
@@ -255,7 +255,7 @@
               <c:extLst>
                 <c:ext xmlns:c15="http://schemas.microsoft.com/office/drawing/2012/chart" uri="{CE6537A1-D6FC-4f65-9D91-7224C49458BB}"/>
                 <c:ext xmlns:c16="http://schemas.microsoft.com/office/drawing/2014/chart" uri="{C3380CC4-5D6E-409C-BE32-E72D297353CC}">
-                  <c16:uniqueId val="{00000001-2A58-4B65-9023-DC9A707F2F27}"/>
+                  <c16:uniqueId val="{00000001-D9A9-43B9-99B2-1E42F13B03AE}"/>
                 </c:ext>
               </c:extLst>
             </c:dLbl>
@@ -287,7 +287,7 @@
               <c:extLst>
                 <c:ext xmlns:c15="http://schemas.microsoft.com/office/drawing/2012/chart" uri="{CE6537A1-D6FC-4f65-9D91-7224C49458BB}"/>
                 <c:ext xmlns:c16="http://schemas.microsoft.com/office/drawing/2014/chart" uri="{C3380CC4-5D6E-409C-BE32-E72D297353CC}">
-                  <c16:uniqueId val="{00000003-2A58-4B65-9023-DC9A707F2F27}"/>
+                  <c16:uniqueId val="{00000003-D9A9-43B9-99B2-1E42F13B03AE}"/>
                 </c:ext>
               </c:extLst>
             </c:dLbl>
@@ -357,7 +357,7 @@
           </c:val>
           <c:extLst>
             <c:ext xmlns:c16="http://schemas.microsoft.com/office/drawing/2014/chart" uri="{C3380CC4-5D6E-409C-BE32-E72D297353CC}">
-              <c16:uniqueId val="{00000004-2A58-4B65-9023-DC9A707F2F27}"/>
+              <c16:uniqueId val="{00000004-D9A9-43B9-99B2-1E42F13B03AE}"/>
             </c:ext>
           </c:extLst>
         </c:ser>
@@ -455,7 +455,7 @@
             <c:bubble3D val="0"/>
             <c:extLst>
               <c:ext xmlns:c16="http://schemas.microsoft.com/office/drawing/2014/chart" uri="{C3380CC4-5D6E-409C-BE32-E72D297353CC}">
-                <c16:uniqueId val="{00000001-C7EA-4A60-8A44-719B1FCC74AD}"/>
+                <c16:uniqueId val="{00000001-6CFE-44F6-8626-33ADD0173059}"/>
               </c:ext>
             </c:extLst>
           </c:dPt>
@@ -471,7 +471,7 @@
             </c:spPr>
             <c:extLst>
               <c:ext xmlns:c16="http://schemas.microsoft.com/office/drawing/2014/chart" uri="{C3380CC4-5D6E-409C-BE32-E72D297353CC}">
-                <c16:uniqueId val="{00000003-C7EA-4A60-8A44-719B1FCC74AD}"/>
+                <c16:uniqueId val="{00000003-6CFE-44F6-8626-33ADD0173059}"/>
               </c:ext>
             </c:extLst>
           </c:dPt>
@@ -545,7 +545,7 @@
           </c:val>
           <c:extLst>
             <c:ext xmlns:c16="http://schemas.microsoft.com/office/drawing/2014/chart" uri="{C3380CC4-5D6E-409C-BE32-E72D297353CC}">
-              <c16:uniqueId val="{00000004-C7EA-4A60-8A44-719B1FCC74AD}"/>
+              <c16:uniqueId val="{00000004-6CFE-44F6-8626-33ADD0173059}"/>
             </c:ext>
           </c:extLst>
         </c:ser>
@@ -713,7 +713,7 @@
             <c:bubble3D val="0"/>
             <c:extLst>
               <c:ext xmlns:c16="http://schemas.microsoft.com/office/drawing/2014/chart" uri="{C3380CC4-5D6E-409C-BE32-E72D297353CC}">
-                <c16:uniqueId val="{00000001-1951-4F8A-9560-E27C3F002B3B}"/>
+                <c16:uniqueId val="{00000001-39F2-4A5A-92F3-5EC0E0FFBEAC}"/>
               </c:ext>
             </c:extLst>
           </c:dPt>
@@ -729,7 +729,7 @@
             </c:spPr>
             <c:extLst>
               <c:ext xmlns:c16="http://schemas.microsoft.com/office/drawing/2014/chart" uri="{C3380CC4-5D6E-409C-BE32-E72D297353CC}">
-                <c16:uniqueId val="{00000003-1951-4F8A-9560-E27C3F002B3B}"/>
+                <c16:uniqueId val="{00000003-39F2-4A5A-92F3-5EC0E0FFBEAC}"/>
               </c:ext>
             </c:extLst>
           </c:dPt>
@@ -745,7 +745,7 @@
             </c:spPr>
             <c:extLst>
               <c:ext xmlns:c16="http://schemas.microsoft.com/office/drawing/2014/chart" uri="{C3380CC4-5D6E-409C-BE32-E72D297353CC}">
-                <c16:uniqueId val="{00000005-1951-4F8A-9560-E27C3F002B3B}"/>
+                <c16:uniqueId val="{00000005-39F2-4A5A-92F3-5EC0E0FFBEAC}"/>
               </c:ext>
             </c:extLst>
           </c:dPt>
@@ -761,7 +761,7 @@
             </c:spPr>
             <c:extLst>
               <c:ext xmlns:c16="http://schemas.microsoft.com/office/drawing/2014/chart" uri="{C3380CC4-5D6E-409C-BE32-E72D297353CC}">
-                <c16:uniqueId val="{00000007-1951-4F8A-9560-E27C3F002B3B}"/>
+                <c16:uniqueId val="{00000007-39F2-4A5A-92F3-5EC0E0FFBEAC}"/>
               </c:ext>
             </c:extLst>
           </c:dPt>
@@ -849,7 +849,7 @@
           </c:val>
           <c:extLst>
             <c:ext xmlns:c16="http://schemas.microsoft.com/office/drawing/2014/chart" uri="{C3380CC4-5D6E-409C-BE32-E72D297353CC}">
-              <c16:uniqueId val="{00000008-1951-4F8A-9560-E27C3F002B3B}"/>
+              <c16:uniqueId val="{00000008-39F2-4A5A-92F3-5EC0E0FFBEAC}"/>
             </c:ext>
           </c:extLst>
         </c:ser>
@@ -988,7 +988,7 @@
             <c:bubble3D val="0"/>
             <c:extLst>
               <c:ext xmlns:c16="http://schemas.microsoft.com/office/drawing/2014/chart" uri="{C3380CC4-5D6E-409C-BE32-E72D297353CC}">
-                <c16:uniqueId val="{00000001-B85E-42BC-87A7-574C5FBD7F09}"/>
+                <c16:uniqueId val="{00000001-8CAB-4BDD-A07D-7DD100802456}"/>
               </c:ext>
             </c:extLst>
           </c:dPt>
@@ -998,7 +998,7 @@
             <c:bubble3D val="0"/>
             <c:extLst>
               <c:ext xmlns:c16="http://schemas.microsoft.com/office/drawing/2014/chart" uri="{C3380CC4-5D6E-409C-BE32-E72D297353CC}">
-                <c16:uniqueId val="{00000003-B85E-42BC-87A7-574C5FBD7F09}"/>
+                <c16:uniqueId val="{00000003-8CAB-4BDD-A07D-7DD100802456}"/>
               </c:ext>
             </c:extLst>
           </c:dPt>
@@ -1008,7 +1008,7 @@
             <c:bubble3D val="0"/>
             <c:extLst>
               <c:ext xmlns:c16="http://schemas.microsoft.com/office/drawing/2014/chart" uri="{C3380CC4-5D6E-409C-BE32-E72D297353CC}">
-                <c16:uniqueId val="{00000005-B85E-42BC-87A7-574C5FBD7F09}"/>
+                <c16:uniqueId val="{00000005-8CAB-4BDD-A07D-7DD100802456}"/>
               </c:ext>
             </c:extLst>
           </c:dPt>
@@ -1024,7 +1024,7 @@
             </c:spPr>
             <c:extLst>
               <c:ext xmlns:c16="http://schemas.microsoft.com/office/drawing/2014/chart" uri="{C3380CC4-5D6E-409C-BE32-E72D297353CC}">
-                <c16:uniqueId val="{00000007-B85E-42BC-87A7-574C5FBD7F09}"/>
+                <c16:uniqueId val="{00000007-8CAB-4BDD-A07D-7DD100802456}"/>
               </c:ext>
             </c:extLst>
           </c:dPt>
@@ -1040,7 +1040,7 @@
             </c:spPr>
             <c:extLst>
               <c:ext xmlns:c16="http://schemas.microsoft.com/office/drawing/2014/chart" uri="{C3380CC4-5D6E-409C-BE32-E72D297353CC}">
-                <c16:uniqueId val="{00000009-B85E-42BC-87A7-574C5FBD7F09}"/>
+                <c16:uniqueId val="{00000009-8CAB-4BDD-A07D-7DD100802456}"/>
               </c:ext>
             </c:extLst>
           </c:dPt>
@@ -1056,7 +1056,7 @@
             </c:spPr>
             <c:extLst>
               <c:ext xmlns:c16="http://schemas.microsoft.com/office/drawing/2014/chart" uri="{C3380CC4-5D6E-409C-BE32-E72D297353CC}">
-                <c16:uniqueId val="{0000000B-B85E-42BC-87A7-574C5FBD7F09}"/>
+                <c16:uniqueId val="{0000000B-8CAB-4BDD-A07D-7DD100802456}"/>
               </c:ext>
             </c:extLst>
           </c:dPt>
@@ -1072,7 +1072,7 @@
             </c:spPr>
             <c:extLst>
               <c:ext xmlns:c16="http://schemas.microsoft.com/office/drawing/2014/chart" uri="{C3380CC4-5D6E-409C-BE32-E72D297353CC}">
-                <c16:uniqueId val="{0000000D-B85E-42BC-87A7-574C5FBD7F09}"/>
+                <c16:uniqueId val="{0000000D-8CAB-4BDD-A07D-7DD100802456}"/>
               </c:ext>
             </c:extLst>
           </c:dPt>
@@ -1088,7 +1088,7 @@
             </c:spPr>
             <c:extLst>
               <c:ext xmlns:c16="http://schemas.microsoft.com/office/drawing/2014/chart" uri="{C3380CC4-5D6E-409C-BE32-E72D297353CC}">
-                <c16:uniqueId val="{0000000F-B85E-42BC-87A7-574C5FBD7F09}"/>
+                <c16:uniqueId val="{0000000F-8CAB-4BDD-A07D-7DD100802456}"/>
               </c:ext>
             </c:extLst>
           </c:dPt>
@@ -1196,7 +1196,7 @@
           </c:val>
           <c:extLst>
             <c:ext xmlns:c16="http://schemas.microsoft.com/office/drawing/2014/chart" uri="{C3380CC4-5D6E-409C-BE32-E72D297353CC}">
-              <c16:uniqueId val="{00000010-B85E-42BC-87A7-574C5FBD7F09}"/>
+              <c16:uniqueId val="{00000010-8CAB-4BDD-A07D-7DD100802456}"/>
             </c:ext>
           </c:extLst>
         </c:ser>
@@ -1295,304 +1295,6 @@
 </file>
 
 <file path=ppt/charts/chart5.xml><?xml version="1.0" encoding="utf-8"?>
-<c:chartSpace xmlns:c="http://schemas.openxmlformats.org/drawingml/2006/chart" xmlns:a="http://schemas.openxmlformats.org/drawingml/2006/main" xmlns:r="http://schemas.openxmlformats.org/officeDocument/2006/relationships" xmlns:c16r2="http://schemas.microsoft.com/office/drawing/2015/06/chart">
-  <c:date1904 val="0"/>
-  <c:lang val="es-ES"/>
-  <c:roundedCorners val="1"/>
-  <c:style val="2"/>
-  <c:chart>
-    <c:title>
-      <c:tx>
-        <c:rich>
-          <a:bodyPr/>
-          <a:lstStyle/>
-          <a:p>
-            <a:pPr>
-              <a:defRPr sz="1300" b="0" i="0" u="none" strike="noStrike">
-                <a:solidFill>
-                  <a:srgbClr val="1E2761"/>
-                </a:solidFill>
-                <a:latin typeface="Calibri"/>
-              </a:defRPr>
-            </a:pPr>
-            <a:r>
-              <a:rPr lang="es-CO" sz="1300" b="0" i="0" u="none" strike="noStrike">
-                <a:solidFill>
-                  <a:srgbClr val="1E2761"/>
-                </a:solidFill>
-                <a:latin typeface="Calibri"/>
-              </a:rPr>
-              <a:t>PCA — varianza acumulada por componente</a:t>
-            </a:r>
-          </a:p>
-        </c:rich>
-      </c:tx>
-      <c:overlay val="0"/>
-    </c:title>
-    <c:autoTitleDeleted val="0"/>
-    <c:plotArea>
-      <c:layout/>
-      <c:lineChart>
-        <c:grouping val="standard"/>
-        <c:varyColors val="0"/>
-        <c:ser>
-          <c:idx val="0"/>
-          <c:order val="0"/>
-          <c:tx>
-            <c:strRef>
-              <c:f>Sheet1!$B$1</c:f>
-              <c:strCache>
-                <c:ptCount val="1"/>
-                <c:pt idx="0">
-                  <c:v>Varianza acumulada (%)</c:v>
-                </c:pt>
-              </c:strCache>
-            </c:strRef>
-          </c:tx>
-          <c:spPr>
-            <a:ln w="38100" cap="flat">
-              <a:solidFill>
-                <a:srgbClr val="1E2761"/>
-              </a:solidFill>
-              <a:prstDash val="solid"/>
-              <a:round/>
-            </a:ln>
-            <a:effectLst/>
-          </c:spPr>
-          <c:marker>
-            <c:symbol val="circle"/>
-            <c:size val="6"/>
-            <c:spPr>
-              <a:solidFill>
-                <a:srgbClr val="1E2761"/>
-              </a:solidFill>
-              <a:ln w="9525" cap="flat">
-                <a:solidFill>
-                  <a:srgbClr val="1E2761"/>
-                </a:solidFill>
-                <a:prstDash val="solid"/>
-                <a:round/>
-              </a:ln>
-              <a:effectLst/>
-            </c:spPr>
-          </c:marker>
-          <c:cat>
-            <c:strRef>
-              <c:f>Sheet1!$A$2:$A$11</c:f>
-              <c:strCache>
-                <c:ptCount val="10"/>
-                <c:pt idx="0">
-                  <c:v>PC1</c:v>
-                </c:pt>
-                <c:pt idx="1">
-                  <c:v>PC2</c:v>
-                </c:pt>
-                <c:pt idx="2">
-                  <c:v>PC3</c:v>
-                </c:pt>
-                <c:pt idx="3">
-                  <c:v>PC4</c:v>
-                </c:pt>
-                <c:pt idx="4">
-                  <c:v>PC5</c:v>
-                </c:pt>
-                <c:pt idx="5">
-                  <c:v>PC6</c:v>
-                </c:pt>
-                <c:pt idx="6">
-                  <c:v>PC7</c:v>
-                </c:pt>
-                <c:pt idx="7">
-                  <c:v>PC8</c:v>
-                </c:pt>
-                <c:pt idx="8">
-                  <c:v>PC9</c:v>
-                </c:pt>
-                <c:pt idx="9">
-                  <c:v>PC10</c:v>
-                </c:pt>
-              </c:strCache>
-            </c:strRef>
-          </c:cat>
-          <c:val>
-            <c:numRef>
-              <c:f>Sheet1!$B$2:$B$11</c:f>
-              <c:numCache>
-                <c:formatCode>General</c:formatCode>
-                <c:ptCount val="10"/>
-                <c:pt idx="0">
-                  <c:v>20.100000000000001</c:v>
-                </c:pt>
-                <c:pt idx="1">
-                  <c:v>31.8</c:v>
-                </c:pt>
-                <c:pt idx="2">
-                  <c:v>41.1</c:v>
-                </c:pt>
-                <c:pt idx="3">
-                  <c:v>48</c:v>
-                </c:pt>
-                <c:pt idx="4">
-                  <c:v>54.7</c:v>
-                </c:pt>
-                <c:pt idx="5">
-                  <c:v>60.8</c:v>
-                </c:pt>
-                <c:pt idx="6">
-                  <c:v>66.7</c:v>
-                </c:pt>
-                <c:pt idx="7">
-                  <c:v>72.5</c:v>
-                </c:pt>
-                <c:pt idx="8">
-                  <c:v>77</c:v>
-                </c:pt>
-                <c:pt idx="9">
-                  <c:v>81.2</c:v>
-                </c:pt>
-              </c:numCache>
-            </c:numRef>
-          </c:val>
-          <c:smooth val="0"/>
-          <c:extLst>
-            <c:ext xmlns:c16="http://schemas.microsoft.com/office/drawing/2014/chart" uri="{C3380CC4-5D6E-409C-BE32-E72D297353CC}">
-              <c16:uniqueId val="{00000000-3E6D-4810-AA29-5FBBAB2CFD27}"/>
-            </c:ext>
-          </c:extLst>
-        </c:ser>
-        <c:dLbls>
-          <c:showLegendKey val="0"/>
-          <c:showVal val="0"/>
-          <c:showCatName val="0"/>
-          <c:showSerName val="0"/>
-          <c:showPercent val="0"/>
-          <c:showBubbleSize val="0"/>
-        </c:dLbls>
-        <c:marker val="1"/>
-        <c:smooth val="0"/>
-        <c:axId val="2094734554"/>
-        <c:axId val="2094734552"/>
-      </c:lineChart>
-      <c:catAx>
-        <c:axId val="2094734554"/>
-        <c:scaling>
-          <c:orientation val="minMax"/>
-        </c:scaling>
-        <c:delete val="0"/>
-        <c:axPos val="b"/>
-        <c:numFmt formatCode="General" sourceLinked="1"/>
-        <c:majorTickMark val="out"/>
-        <c:minorTickMark val="none"/>
-        <c:tickLblPos val="low"/>
-        <c:spPr>
-          <a:ln w="12700" cap="flat">
-            <a:solidFill>
-              <a:srgbClr val="888888"/>
-            </a:solidFill>
-            <a:prstDash val="solid"/>
-            <a:round/>
-          </a:ln>
-        </c:spPr>
-        <c:txPr>
-          <a:bodyPr/>
-          <a:lstStyle/>
-          <a:p>
-            <a:pPr>
-              <a:defRPr sz="1000" b="0" i="0" u="none" strike="noStrike">
-                <a:solidFill>
-                  <a:srgbClr val="5A5F73"/>
-                </a:solidFill>
-                <a:latin typeface="Calibri"/>
-              </a:defRPr>
-            </a:pPr>
-            <a:endParaRPr lang="en-US"/>
-          </a:p>
-        </c:txPr>
-        <c:crossAx val="2094734552"/>
-        <c:crosses val="autoZero"/>
-        <c:auto val="1"/>
-        <c:lblAlgn val="ctr"/>
-        <c:lblOffset val="100"/>
-        <c:noMultiLvlLbl val="1"/>
-      </c:catAx>
-      <c:valAx>
-        <c:axId val="2094734552"/>
-        <c:scaling>
-          <c:orientation val="minMax"/>
-          <c:max val="100"/>
-          <c:min val="0"/>
-        </c:scaling>
-        <c:delete val="0"/>
-        <c:axPos val="l"/>
-        <c:majorGridlines>
-          <c:spPr>
-            <a:ln w="12700" cap="flat">
-              <a:solidFill>
-                <a:srgbClr val="888888"/>
-              </a:solidFill>
-              <a:prstDash val="solid"/>
-              <a:round/>
-            </a:ln>
-          </c:spPr>
-        </c:majorGridlines>
-        <c:numFmt formatCode="General" sourceLinked="0"/>
-        <c:majorTickMark val="out"/>
-        <c:minorTickMark val="none"/>
-        <c:tickLblPos val="nextTo"/>
-        <c:spPr>
-          <a:ln w="12700" cap="flat">
-            <a:solidFill>
-              <a:srgbClr val="888888"/>
-            </a:solidFill>
-            <a:prstDash val="solid"/>
-            <a:round/>
-          </a:ln>
-        </c:spPr>
-        <c:txPr>
-          <a:bodyPr/>
-          <a:lstStyle/>
-          <a:p>
-            <a:pPr>
-              <a:defRPr sz="1000" b="0" i="0" u="none" strike="noStrike">
-                <a:solidFill>
-                  <a:srgbClr val="5A5F73"/>
-                </a:solidFill>
-                <a:latin typeface="Calibri"/>
-              </a:defRPr>
-            </a:pPr>
-            <a:endParaRPr lang="en-US"/>
-          </a:p>
-        </c:txPr>
-        <c:crossAx val="2094734554"/>
-        <c:crosses val="autoZero"/>
-        <c:crossBetween val="between"/>
-      </c:valAx>
-      <c:spPr>
-        <a:noFill/>
-        <a:ln>
-          <a:noFill/>
-        </a:ln>
-        <a:effectLst/>
-      </c:spPr>
-    </c:plotArea>
-    <c:plotVisOnly val="1"/>
-    <c:dispBlanksAs val="span"/>
-    <c:showDLblsOverMax val="1"/>
-  </c:chart>
-  <c:spPr>
-    <a:noFill/>
-    <a:ln>
-      <a:noFill/>
-    </a:ln>
-    <a:effectLst/>
-  </c:spPr>
-  <c:externalData r:id="rId1">
-    <c:autoUpdate val="0"/>
-  </c:externalData>
-</c:chartSpace>
-</file>
-
-<file path=ppt/charts/chart6.xml><?xml version="1.0" encoding="utf-8"?>
 <c:chartSpace xmlns:c="http://schemas.openxmlformats.org/drawingml/2006/chart" xmlns:a="http://schemas.openxmlformats.org/drawingml/2006/main" xmlns:r="http://schemas.openxmlformats.org/officeDocument/2006/relationships" xmlns:c16r2="http://schemas.microsoft.com/office/drawing/2015/06/chart">
   <c:date1904 val="0"/>
   <c:lang val="es-ES"/>
@@ -1661,7 +1363,7 @@
             <c:bubble3D val="0"/>
             <c:extLst>
               <c:ext xmlns:c16="http://schemas.microsoft.com/office/drawing/2014/chart" uri="{C3380CC4-5D6E-409C-BE32-E72D297353CC}">
-                <c16:uniqueId val="{00000001-8200-4837-83A0-E49E9D63A97E}"/>
+                <c16:uniqueId val="{00000001-02EC-40B8-A8D6-5D239C87059B}"/>
               </c:ext>
             </c:extLst>
           </c:dPt>
@@ -1677,7 +1379,7 @@
             </c:spPr>
             <c:extLst>
               <c:ext xmlns:c16="http://schemas.microsoft.com/office/drawing/2014/chart" uri="{C3380CC4-5D6E-409C-BE32-E72D297353CC}">
-                <c16:uniqueId val="{00000003-8200-4837-83A0-E49E9D63A97E}"/>
+                <c16:uniqueId val="{00000003-02EC-40B8-A8D6-5D239C87059B}"/>
               </c:ext>
             </c:extLst>
           </c:dPt>
@@ -1749,7 +1451,7 @@
           </c:val>
           <c:extLst>
             <c:ext xmlns:c16="http://schemas.microsoft.com/office/drawing/2014/chart" uri="{C3380CC4-5D6E-409C-BE32-E72D297353CC}">
-              <c16:uniqueId val="{00000004-8200-4837-83A0-E49E9D63A97E}"/>
+              <c16:uniqueId val="{00000004-02EC-40B8-A8D6-5D239C87059B}"/>
             </c:ext>
           </c:extLst>
         </c:ser>
@@ -1872,7 +1574,7 @@
     </p:spTree>
     <p:extLst>
       <p:ext uri="{BB962C8B-B14F-4D97-AF65-F5344CB8AC3E}">
-        <p14:creationId xmlns:p14="http://schemas.microsoft.com/office/powerpoint/2010/main" val="3400754728"/>
+        <p14:creationId xmlns:p14="http://schemas.microsoft.com/office/powerpoint/2010/main" val="4157034081"/>
       </p:ext>
     </p:extLst>
   </p:cSld>
@@ -2000,13 +1702,6 @@
           </p:nvPr>
         </p:nvSpPr>
         <p:spPr/>
-        <p:txBody>
-          <a:bodyPr/>
-          <a:lstStyle/>
-          <a:p>
-            <a:endParaRPr lang="es-CO"/>
-          </a:p>
-        </p:txBody>
       </p:sp>
       <p:sp>
         <p:nvSpPr>
@@ -2094,13 +1789,6 @@
           </p:nvPr>
         </p:nvSpPr>
         <p:spPr/>
-        <p:txBody>
-          <a:bodyPr/>
-          <a:lstStyle/>
-          <a:p>
-            <a:endParaRPr lang="es-CO"/>
-          </a:p>
-        </p:txBody>
       </p:sp>
       <p:sp>
         <p:nvSpPr>
@@ -2188,13 +1876,6 @@
           </p:nvPr>
         </p:nvSpPr>
         <p:spPr/>
-        <p:txBody>
-          <a:bodyPr/>
-          <a:lstStyle/>
-          <a:p>
-            <a:endParaRPr lang="es-CO"/>
-          </a:p>
-        </p:txBody>
       </p:sp>
       <p:sp>
         <p:nvSpPr>
@@ -2282,13 +1963,6 @@
           </p:nvPr>
         </p:nvSpPr>
         <p:spPr/>
-        <p:txBody>
-          <a:bodyPr/>
-          <a:lstStyle/>
-          <a:p>
-            <a:endParaRPr lang="es-CO"/>
-          </a:p>
-        </p:txBody>
       </p:sp>
       <p:sp>
         <p:nvSpPr>
@@ -2376,13 +2050,6 @@
           </p:nvPr>
         </p:nvSpPr>
         <p:spPr/>
-        <p:txBody>
-          <a:bodyPr/>
-          <a:lstStyle/>
-          <a:p>
-            <a:endParaRPr lang="es-CO"/>
-          </a:p>
-        </p:txBody>
       </p:sp>
       <p:sp>
         <p:nvSpPr>
@@ -2401,7 +2068,7 @@
           <a:p>
             <a:r>
               <a:rPr lang="en-US" dirty="0"/>
-              <a:t>El PCA aquí tiene valor diagnóstico, no operativo: confirma que no existe estructura lineal simple que separe a los clientes en mora.</a:t>
+              <a:t>El análisis multivariado usa las técnicas pedidas: matriz de correlación, pairplot con hue, dispersión entre numéricas y tablas cruzadas. No se aplicó reducción de dimensionalidad porque corresponde a la fase de Feature Engineering.</a:t>
             </a:r>
           </a:p>
         </p:txBody>
@@ -2470,13 +2137,6 @@
           </p:nvPr>
         </p:nvSpPr>
         <p:spPr/>
-        <p:txBody>
-          <a:bodyPr/>
-          <a:lstStyle/>
-          <a:p>
-            <a:endParaRPr lang="es-CO"/>
-          </a:p>
-        </p:txBody>
       </p:sp>
       <p:sp>
         <p:nvSpPr>
@@ -2564,13 +2224,6 @@
           </p:nvPr>
         </p:nvSpPr>
         <p:spPr/>
-        <p:txBody>
-          <a:bodyPr/>
-          <a:lstStyle/>
-          <a:p>
-            <a:endParaRPr lang="es-CO"/>
-          </a:p>
-        </p:txBody>
       </p:sp>
       <p:sp>
         <p:nvSpPr>
@@ -2658,13 +2311,6 @@
           </p:nvPr>
         </p:nvSpPr>
         <p:spPr/>
-        <p:txBody>
-          <a:bodyPr/>
-          <a:lstStyle/>
-          <a:p>
-            <a:endParaRPr lang="es-CO"/>
-          </a:p>
-        </p:txBody>
       </p:sp>
       <p:sp>
         <p:nvSpPr>
@@ -2752,13 +2398,6 @@
           </p:nvPr>
         </p:nvSpPr>
         <p:spPr/>
-        <p:txBody>
-          <a:bodyPr/>
-          <a:lstStyle/>
-          <a:p>
-            <a:endParaRPr lang="es-CO"/>
-          </a:p>
-        </p:txBody>
       </p:sp>
       <p:sp>
         <p:nvSpPr>
@@ -2846,13 +2485,6 @@
           </p:nvPr>
         </p:nvSpPr>
         <p:spPr/>
-        <p:txBody>
-          <a:bodyPr/>
-          <a:lstStyle/>
-          <a:p>
-            <a:endParaRPr lang="es-CO"/>
-          </a:p>
-        </p:txBody>
       </p:sp>
       <p:sp>
         <p:nvSpPr>
@@ -2940,13 +2572,6 @@
           </p:nvPr>
         </p:nvSpPr>
         <p:spPr/>
-        <p:txBody>
-          <a:bodyPr/>
-          <a:lstStyle/>
-          <a:p>
-            <a:endParaRPr lang="es-CO"/>
-          </a:p>
-        </p:txBody>
       </p:sp>
       <p:sp>
         <p:nvSpPr>
@@ -3034,13 +2659,6 @@
           </p:nvPr>
         </p:nvSpPr>
         <p:spPr/>
-        <p:txBody>
-          <a:bodyPr/>
-          <a:lstStyle/>
-          <a:p>
-            <a:endParaRPr lang="es-CO"/>
-          </a:p>
-        </p:txBody>
       </p:sp>
       <p:sp>
         <p:nvSpPr>
@@ -3128,13 +2746,6 @@
           </p:nvPr>
         </p:nvSpPr>
         <p:spPr/>
-        <p:txBody>
-          <a:bodyPr/>
-          <a:lstStyle/>
-          <a:p>
-            <a:endParaRPr lang="es-CO"/>
-          </a:p>
-        </p:txBody>
       </p:sp>
       <p:sp>
         <p:nvSpPr>
@@ -3222,13 +2833,6 @@
           </p:nvPr>
         </p:nvSpPr>
         <p:spPr/>
-        <p:txBody>
-          <a:bodyPr/>
-          <a:lstStyle/>
-          <a:p>
-            <a:endParaRPr lang="es-CO"/>
-          </a:p>
-        </p:txBody>
       </p:sp>
       <p:sp>
         <p:nvSpPr>
@@ -3316,13 +2920,6 @@
           </p:nvPr>
         </p:nvSpPr>
         <p:spPr/>
-        <p:txBody>
-          <a:bodyPr/>
-          <a:lstStyle/>
-          <a:p>
-            <a:endParaRPr lang="es-CO"/>
-          </a:p>
-        </p:txBody>
       </p:sp>
       <p:sp>
         <p:nvSpPr>
@@ -3410,13 +3007,6 @@
           </p:nvPr>
         </p:nvSpPr>
         <p:spPr/>
-        <p:txBody>
-          <a:bodyPr/>
-          <a:lstStyle/>
-          <a:p>
-            <a:endParaRPr lang="es-CO"/>
-          </a:p>
-        </p:txBody>
       </p:sp>
       <p:sp>
         <p:nvSpPr>
@@ -3504,13 +3094,6 @@
           </p:nvPr>
         </p:nvSpPr>
         <p:spPr/>
-        <p:txBody>
-          <a:bodyPr/>
-          <a:lstStyle/>
-          <a:p>
-            <a:endParaRPr lang="es-CO"/>
-          </a:p>
-        </p:txBody>
       </p:sp>
       <p:sp>
         <p:nvSpPr>
@@ -3598,13 +3181,6 @@
           </p:nvPr>
         </p:nvSpPr>
         <p:spPr/>
-        <p:txBody>
-          <a:bodyPr/>
-          <a:lstStyle/>
-          <a:p>
-            <a:endParaRPr lang="es-CO"/>
-          </a:p>
-        </p:txBody>
       </p:sp>
       <p:sp>
         <p:nvSpPr>
@@ -4156,7 +3732,7 @@
         </p:nvSpPr>
         <p:spPr>
           <a:xfrm>
-            <a:off x="735874" y="4343400"/>
+            <a:off x="822960" y="4343401"/>
             <a:ext cx="8229600" cy="365760"/>
           </a:xfrm>
           <a:prstGeom prst="rect">
@@ -4953,7 +4529,7 @@
                 <a:ea typeface="Cambria" pitchFamily="34" charset="-122"/>
                 <a:cs typeface="Cambria" pitchFamily="34" charset="-120"/>
               </a:rPr>
-              <a:t>Los atributos derivados superan a los originales</a:t>
+              <a:t>Atributos derivados: propuestas de alto valor</a:t>
             </a:r>
             <a:endParaRPr lang="en-US" sz="3000" dirty="0"/>
           </a:p>
@@ -5714,7 +5290,7 @@
               <a:buNone/>
             </a:pPr>
             <a:r>
-              <a:rPr lang="en-US" sz="2600" b="1" dirty="0">
+              <a:rPr lang="en-US" sz="2300" b="1" dirty="0">
                 <a:solidFill>
                   <a:srgbClr val="FFFFFF"/>
                 </a:solidFill>
@@ -5722,9 +5298,9 @@
                 <a:ea typeface="Cambria" pitchFamily="34" charset="-122"/>
                 <a:cs typeface="Cambria" pitchFamily="34" charset="-120"/>
               </a:rPr>
-              <a:t>2 de 2</a:t>
-            </a:r>
-            <a:endParaRPr lang="en-US" sz="2600" dirty="0"/>
+              <a:t>Propuestas</a:t>
+            </a:r>
+            <a:endParaRPr lang="en-US" sz="2300" dirty="0"/>
           </a:p>
         </p:txBody>
       </p:sp>
@@ -5736,8 +5312,8 @@
         </p:nvSpPr>
         <p:spPr>
           <a:xfrm>
-            <a:off x="7863840" y="2880360"/>
-            <a:ext cx="3474720" cy="914400"/>
+            <a:off x="7863840" y="2834640"/>
+            <a:ext cx="3474720" cy="1143000"/>
           </a:xfrm>
           <a:prstGeom prst="rect">
             <a:avLst/>
@@ -5756,7 +5332,7 @@
               <a:buNone/>
             </a:pPr>
             <a:r>
-              <a:rPr lang="en-US" sz="1300" dirty="0">
+              <a:rPr lang="en-US" sz="1200" dirty="0">
                 <a:solidFill>
                   <a:srgbClr val="CADCFC"/>
                 </a:solidFill>
@@ -5764,9 +5340,9 @@
                 <a:ea typeface="Calibri" pitchFamily="34" charset="-122"/>
                 <a:cs typeface="Calibri" pitchFamily="34" charset="-120"/>
               </a:rPr>
-              <a:t>los dos mejores predictores del dataset son variables construidas, no originales</a:t>
-            </a:r>
-            <a:endParaRPr lang="en-US" sz="1300" dirty="0"/>
+              <a:t>Identificadas y evaluadas durante el EDA. Se implementarán en la Fase 2; ninguna se incorporó al dataset limpio.</a:t>
+            </a:r>
+            <a:endParaRPr lang="en-US" sz="1200" dirty="0"/>
           </a:p>
         </p:txBody>
       </p:sp>
@@ -5778,8 +5354,8 @@
         </p:nvSpPr>
         <p:spPr>
           <a:xfrm>
-            <a:off x="7863840" y="3977640"/>
-            <a:ext cx="3474720" cy="2011680"/>
+            <a:off x="7863840" y="4069080"/>
+            <a:ext cx="3474720" cy="1874520"/>
           </a:xfrm>
           <a:prstGeom prst="rect">
             <a:avLst/>
@@ -5987,86 +5563,99 @@
                 <a:ea typeface="Cambria" pitchFamily="34" charset="-122"/>
                 <a:cs typeface="Cambria" pitchFamily="34" charset="-120"/>
               </a:rPr>
-              <a:t>¿Se separan las clases en el espacio multivariado?</a:t>
+              <a:t>Relaciones entre variables</a:t>
             </a:r>
             <a:endParaRPr lang="en-US" sz="3000" dirty="0"/>
           </a:p>
         </p:txBody>
       </p:sp>
-      <p:graphicFrame>
-        <p:nvGraphicFramePr>
-          <p:cNvPr id="4" name="Chart 0"/>
-          <p:cNvGraphicFramePr/>
-          <p:nvPr/>
-        </p:nvGraphicFramePr>
-        <p:xfrm>
-          <a:off x="548640" y="1920240"/>
-          <a:ext cx="6035040" cy="4023360"/>
-        </p:xfrm>
-        <a:graphic>
-          <a:graphicData uri="http://schemas.openxmlformats.org/drawingml/2006/chart">
-            <c:chart xmlns:c="http://schemas.openxmlformats.org/drawingml/2006/chart" xmlns:r="http://schemas.openxmlformats.org/officeDocument/2006/relationships" r:id="rId3"/>
-          </a:graphicData>
-        </a:graphic>
-      </p:graphicFrame>
-      <p:sp>
-        <p:nvSpPr>
-          <p:cNvPr id="5" name="Text 2"/>
-          <p:cNvSpPr/>
-          <p:nvPr/>
-        </p:nvSpPr>
-        <p:spPr>
-          <a:xfrm>
-            <a:off x="6949440" y="2103120"/>
-            <a:ext cx="4663440" cy="822960"/>
-          </a:xfrm>
-          <a:prstGeom prst="rect">
-            <a:avLst/>
-          </a:prstGeom>
-          <a:noFill/>
-          <a:ln/>
-        </p:spPr>
-        <p:txBody>
-          <a:bodyPr wrap="square" lIns="0" tIns="0" rIns="0" bIns="0" rtlCol="0" anchor="ctr"/>
-          <a:lstStyle/>
-          <a:p>
-            <a:pPr marL="0" indent="0">
-              <a:buNone/>
-            </a:pPr>
-            <a:r>
-              <a:rPr lang="en-US" sz="4000" b="1" dirty="0">
-                <a:solidFill>
-                  <a:srgbClr val="1E2761"/>
-                </a:solidFill>
-                <a:latin typeface="Cambria" pitchFamily="34" charset="0"/>
-                <a:ea typeface="Cambria" pitchFamily="34" charset="-122"/>
-                <a:cs typeface="Cambria" pitchFamily="34" charset="-120"/>
-              </a:rPr>
-              <a:t>10 de 17</a:t>
-            </a:r>
-            <a:endParaRPr lang="en-US" sz="4000" dirty="0"/>
-          </a:p>
-        </p:txBody>
-      </p:sp>
-      <p:sp>
-        <p:nvSpPr>
-          <p:cNvPr id="6" name="Text 3"/>
-          <p:cNvSpPr/>
-          <p:nvPr/>
-        </p:nvSpPr>
-        <p:spPr>
-          <a:xfrm>
-            <a:off x="6949440" y="2926080"/>
-            <a:ext cx="4663440" cy="731520"/>
-          </a:xfrm>
-          <a:prstGeom prst="rect">
-            <a:avLst/>
-          </a:prstGeom>
-          <a:noFill/>
-          <a:ln/>
-        </p:spPr>
-        <p:txBody>
-          <a:bodyPr wrap="square" lIns="0" tIns="0" rIns="0" bIns="0" rtlCol="0" anchor="ctr"/>
+      <p:sp>
+        <p:nvSpPr>
+          <p:cNvPr id="4" name="Shape 2"/>
+          <p:cNvSpPr/>
+          <p:nvPr/>
+        </p:nvSpPr>
+        <p:spPr>
+          <a:xfrm>
+            <a:off x="548640" y="1965960"/>
+            <a:ext cx="2670048" cy="1920240"/>
+          </a:xfrm>
+          <a:prstGeom prst="roundRect">
+            <a:avLst>
+              <a:gd name="adj" fmla="val 3810"/>
+            </a:avLst>
+          </a:prstGeom>
+          <a:solidFill>
+            <a:srgbClr val="1E2761"/>
+          </a:solidFill>
+          <a:ln/>
+        </p:spPr>
+        <p:txBody>
+          <a:bodyPr/>
+          <a:lstStyle/>
+          <a:p>
+            <a:endParaRPr lang="es-CO"/>
+          </a:p>
+        </p:txBody>
+      </p:sp>
+      <p:sp>
+        <p:nvSpPr>
+          <p:cNvPr id="5" name="Text 3"/>
+          <p:cNvSpPr/>
+          <p:nvPr/>
+        </p:nvSpPr>
+        <p:spPr>
+          <a:xfrm>
+            <a:off x="804672" y="2221992"/>
+            <a:ext cx="2157984" cy="685800"/>
+          </a:xfrm>
+          <a:prstGeom prst="rect">
+            <a:avLst/>
+          </a:prstGeom>
+          <a:noFill/>
+          <a:ln/>
+        </p:spPr>
+        <p:txBody>
+          <a:bodyPr wrap="square" lIns="0" tIns="0" rIns="0" bIns="0" rtlCol="0" anchor="t"/>
+          <a:lstStyle/>
+          <a:p>
+            <a:pPr marL="0" indent="0">
+              <a:buNone/>
+            </a:pPr>
+            <a:r>
+              <a:rPr lang="en-US" sz="1400" b="1" dirty="0">
+                <a:solidFill>
+                  <a:srgbClr val="FFFFFF"/>
+                </a:solidFill>
+                <a:latin typeface="Calibri" pitchFamily="34" charset="0"/>
+                <a:ea typeface="Calibri" pitchFamily="34" charset="-122"/>
+                <a:cs typeface="Calibri" pitchFamily="34" charset="-120"/>
+              </a:rPr>
+              <a:t>Matriz de correlación</a:t>
+            </a:r>
+            <a:endParaRPr lang="en-US" sz="1400" dirty="0"/>
+          </a:p>
+        </p:txBody>
+      </p:sp>
+      <p:sp>
+        <p:nvSpPr>
+          <p:cNvPr id="6" name="Text 4"/>
+          <p:cNvSpPr/>
+          <p:nvPr/>
+        </p:nvSpPr>
+        <p:spPr>
+          <a:xfrm>
+            <a:off x="804672" y="2880360"/>
+            <a:ext cx="2157984" cy="914400"/>
+          </a:xfrm>
+          <a:prstGeom prst="rect">
+            <a:avLst/>
+          </a:prstGeom>
+          <a:noFill/>
+          <a:ln/>
+        </p:spPr>
+        <p:txBody>
+          <a:bodyPr wrap="square" lIns="0" tIns="0" rIns="0" bIns="0" rtlCol="0" anchor="t"/>
           <a:lstStyle/>
           <a:p>
             <a:pPr marL="0" indent="0">
@@ -6076,34 +5665,74 @@
               <a:buNone/>
             </a:pPr>
             <a:r>
-              <a:rPr lang="en-US" sz="1350" dirty="0">
-                <a:solidFill>
-                  <a:srgbClr val="5A5F73"/>
-                </a:solidFill>
-                <a:latin typeface="Calibri" pitchFamily="34" charset="0"/>
-                <a:ea typeface="Calibri" pitchFamily="34" charset="-122"/>
-                <a:cs typeface="Calibri" pitchFamily="34" charset="-120"/>
-              </a:rPr>
-              <a:t>componentes hacen falta para explicar el 80% de la varianza</a:t>
-            </a:r>
-            <a:endParaRPr lang="en-US" sz="1350" dirty="0"/>
-          </a:p>
-        </p:txBody>
-      </p:sp>
-      <p:sp>
-        <p:nvSpPr>
-          <p:cNvPr id="7" name="Shape 4"/>
-          <p:cNvSpPr/>
-          <p:nvPr/>
-        </p:nvSpPr>
-        <p:spPr>
-          <a:xfrm>
-            <a:off x="6949440" y="3794760"/>
-            <a:ext cx="4663440" cy="2148840"/>
+              <a:rPr lang="en-US" sz="1100" dirty="0">
+                <a:solidFill>
+                  <a:srgbClr val="CADCFC"/>
+                </a:solidFill>
+                <a:latin typeface="Calibri" pitchFamily="34" charset="0"/>
+                <a:ea typeface="Calibri" pitchFamily="34" charset="-122"/>
+                <a:cs typeface="Calibri" pitchFamily="34" charset="-120"/>
+              </a:rPr>
+              <a:t>Sobre variables cuantitativas.</a:t>
+            </a:r>
+            <a:endParaRPr lang="en-US" sz="1100" dirty="0"/>
+          </a:p>
+          <a:p>
+            <a:pPr marL="0" indent="0">
+              <a:lnSpc>
+                <a:spcPct val="120000"/>
+              </a:lnSpc>
+              <a:buNone/>
+            </a:pPr>
+            <a:r>
+              <a:rPr lang="en-US" sz="1100" dirty="0">
+                <a:solidFill>
+                  <a:srgbClr val="CADCFC"/>
+                </a:solidFill>
+                <a:latin typeface="Calibri" pitchFamily="34" charset="0"/>
+                <a:ea typeface="Calibri" pitchFamily="34" charset="-122"/>
+                <a:cs typeface="Calibri" pitchFamily="34" charset="-120"/>
+              </a:rPr>
+              <a:t>Detecta multicolinealidad:</a:t>
+            </a:r>
+            <a:endParaRPr lang="en-US" sz="1100" dirty="0"/>
+          </a:p>
+          <a:p>
+            <a:pPr marL="0" indent="0">
+              <a:lnSpc>
+                <a:spcPct val="120000"/>
+              </a:lnSpc>
+              <a:buNone/>
+            </a:pPr>
+            <a:r>
+              <a:rPr lang="en-US" sz="1100" dirty="0">
+                <a:solidFill>
+                  <a:srgbClr val="CADCFC"/>
+                </a:solidFill>
+                <a:latin typeface="Calibri" pitchFamily="34" charset="0"/>
+                <a:ea typeface="Calibri" pitchFamily="34" charset="-122"/>
+                <a:cs typeface="Calibri" pitchFamily="34" charset="-120"/>
+              </a:rPr>
+              <a:t>capital vs cuota (r = 0.764)</a:t>
+            </a:r>
+            <a:endParaRPr lang="en-US" sz="1100" dirty="0"/>
+          </a:p>
+        </p:txBody>
+      </p:sp>
+      <p:sp>
+        <p:nvSpPr>
+          <p:cNvPr id="7" name="Shape 5"/>
+          <p:cNvSpPr/>
+          <p:nvPr/>
+        </p:nvSpPr>
+        <p:spPr>
+          <a:xfrm>
+            <a:off x="3438144" y="1965960"/>
+            <a:ext cx="2670048" cy="1920240"/>
           </a:xfrm>
           <a:prstGeom prst="roundRect">
             <a:avLst>
-              <a:gd name="adj" fmla="val 3404"/>
+              <a:gd name="adj" fmla="val 3810"/>
             </a:avLst>
           </a:prstGeom>
           <a:solidFill>
@@ -6121,14 +5750,53 @@
       </p:sp>
       <p:sp>
         <p:nvSpPr>
-          <p:cNvPr id="8" name="Text 5"/>
-          <p:cNvSpPr/>
-          <p:nvPr/>
-        </p:nvSpPr>
-        <p:spPr>
-          <a:xfrm>
-            <a:off x="7178040" y="3931920"/>
-            <a:ext cx="4206240" cy="1874520"/>
+          <p:cNvPr id="8" name="Text 6"/>
+          <p:cNvSpPr/>
+          <p:nvPr/>
+        </p:nvSpPr>
+        <p:spPr>
+          <a:xfrm>
+            <a:off x="3694176" y="2221992"/>
+            <a:ext cx="2157984" cy="685800"/>
+          </a:xfrm>
+          <a:prstGeom prst="rect">
+            <a:avLst/>
+          </a:prstGeom>
+          <a:noFill/>
+          <a:ln/>
+        </p:spPr>
+        <p:txBody>
+          <a:bodyPr wrap="square" lIns="0" tIns="0" rIns="0" bIns="0" rtlCol="0" anchor="t"/>
+          <a:lstStyle/>
+          <a:p>
+            <a:pPr marL="0" indent="0">
+              <a:buNone/>
+            </a:pPr>
+            <a:r>
+              <a:rPr lang="en-US" sz="1400" b="1" dirty="0">
+                <a:solidFill>
+                  <a:srgbClr val="1E2761"/>
+                </a:solidFill>
+                <a:latin typeface="Calibri" pitchFamily="34" charset="0"/>
+                <a:ea typeface="Calibri" pitchFamily="34" charset="-122"/>
+                <a:cs typeface="Calibri" pitchFamily="34" charset="-120"/>
+              </a:rPr>
+              <a:t>Pairplot con hue</a:t>
+            </a:r>
+            <a:endParaRPr lang="en-US" sz="1400" dirty="0"/>
+          </a:p>
+        </p:txBody>
+      </p:sp>
+      <p:sp>
+        <p:nvSpPr>
+          <p:cNvPr id="9" name="Text 7"/>
+          <p:cNvSpPr/>
+          <p:nvPr/>
+        </p:nvSpPr>
+        <p:spPr>
+          <a:xfrm>
+            <a:off x="3694176" y="2880360"/>
+            <a:ext cx="2157984" cy="914400"/>
           </a:xfrm>
           <a:prstGeom prst="rect">
             <a:avLst/>
@@ -6147,18 +5815,17 @@
               <a:buNone/>
             </a:pPr>
             <a:r>
-              <a:rPr lang="en-US" sz="1150" b="1" dirty="0">
-                <a:solidFill>
-                  <a:srgbClr val="1E2761"/>
-                </a:solidFill>
-                <a:latin typeface="Calibri" pitchFamily="34" charset="0"/>
-                <a:ea typeface="Calibri" pitchFamily="34" charset="-122"/>
-                <a:cs typeface="Calibri" pitchFamily="34" charset="-120"/>
-              </a:rPr>
-              <a:t>No hay redundancia aprovechable.
-</a:t>
-            </a:r>
-            <a:endParaRPr lang="en-US" sz="1150" dirty="0"/>
+              <a:rPr lang="en-US" sz="1100" dirty="0">
+                <a:solidFill>
+                  <a:srgbClr val="5A5F73"/>
+                </a:solidFill>
+                <a:latin typeface="Calibri" pitchFamily="34" charset="0"/>
+                <a:ea typeface="Calibri" pitchFamily="34" charset="-122"/>
+                <a:cs typeface="Calibri" pitchFamily="34" charset="-120"/>
+              </a:rPr>
+              <a:t>Muestra de 1.500 registros</a:t>
+            </a:r>
+            <a:endParaRPr lang="en-US" sz="1100" dirty="0"/>
           </a:p>
           <a:p>
             <a:pPr marL="0" indent="0">
@@ -6168,7 +5835,7 @@
               <a:buNone/>
             </a:pPr>
             <a:r>
-              <a:rPr lang="en-US" sz="1150" dirty="0">
+              <a:rPr lang="en-US" sz="1100" dirty="0">
                 <a:solidFill>
                   <a:srgbClr val="5A5F73"/>
                 </a:solidFill>
@@ -6176,11 +5843,100 @@
                 <a:ea typeface="Calibri" pitchFamily="34" charset="-122"/>
                 <a:cs typeface="Calibri" pitchFamily="34" charset="-120"/>
               </a:rPr>
-              <a:t>La proyección sobre PC1-PC2 no separa clientes en mora de los que pagan.
-</a:t>
-            </a:r>
-            <a:endParaRPr lang="en-US" sz="1150" dirty="0"/>
-          </a:p>
+              <a:t>coloreada por resultado de pago</a:t>
+            </a:r>
+            <a:endParaRPr lang="en-US" sz="1100" dirty="0"/>
+          </a:p>
+        </p:txBody>
+      </p:sp>
+      <p:sp>
+        <p:nvSpPr>
+          <p:cNvPr id="10" name="Shape 8"/>
+          <p:cNvSpPr/>
+          <p:nvPr/>
+        </p:nvSpPr>
+        <p:spPr>
+          <a:xfrm>
+            <a:off x="6327648" y="1965960"/>
+            <a:ext cx="2670048" cy="1920240"/>
+          </a:xfrm>
+          <a:prstGeom prst="roundRect">
+            <a:avLst>
+              <a:gd name="adj" fmla="val 3810"/>
+            </a:avLst>
+          </a:prstGeom>
+          <a:solidFill>
+            <a:srgbClr val="F4F7FC"/>
+          </a:solidFill>
+          <a:ln/>
+        </p:spPr>
+        <p:txBody>
+          <a:bodyPr/>
+          <a:lstStyle/>
+          <a:p>
+            <a:endParaRPr lang="es-CO"/>
+          </a:p>
+        </p:txBody>
+      </p:sp>
+      <p:sp>
+        <p:nvSpPr>
+          <p:cNvPr id="11" name="Text 9"/>
+          <p:cNvSpPr/>
+          <p:nvPr/>
+        </p:nvSpPr>
+        <p:spPr>
+          <a:xfrm>
+            <a:off x="6583680" y="2221992"/>
+            <a:ext cx="2157984" cy="685800"/>
+          </a:xfrm>
+          <a:prstGeom prst="rect">
+            <a:avLst/>
+          </a:prstGeom>
+          <a:noFill/>
+          <a:ln/>
+        </p:spPr>
+        <p:txBody>
+          <a:bodyPr wrap="square" lIns="0" tIns="0" rIns="0" bIns="0" rtlCol="0" anchor="t"/>
+          <a:lstStyle/>
+          <a:p>
+            <a:pPr marL="0" indent="0">
+              <a:buNone/>
+            </a:pPr>
+            <a:r>
+              <a:rPr lang="en-US" sz="1400" b="1" dirty="0">
+                <a:solidFill>
+                  <a:srgbClr val="1E2761"/>
+                </a:solidFill>
+                <a:latin typeface="Calibri" pitchFamily="34" charset="0"/>
+                <a:ea typeface="Calibri" pitchFamily="34" charset="-122"/>
+                <a:cs typeface="Calibri" pitchFamily="34" charset="-120"/>
+              </a:rPr>
+              <a:t>Dispersión entre numéricas</a:t>
+            </a:r>
+            <a:endParaRPr lang="en-US" sz="1400" dirty="0"/>
+          </a:p>
+        </p:txBody>
+      </p:sp>
+      <p:sp>
+        <p:nvSpPr>
+          <p:cNvPr id="12" name="Text 10"/>
+          <p:cNvSpPr/>
+          <p:nvPr/>
+        </p:nvSpPr>
+        <p:spPr>
+          <a:xfrm>
+            <a:off x="6583680" y="2880360"/>
+            <a:ext cx="2157984" cy="914400"/>
+          </a:xfrm>
+          <a:prstGeom prst="rect">
+            <a:avLst/>
+          </a:prstGeom>
+          <a:noFill/>
+          <a:ln/>
+        </p:spPr>
+        <p:txBody>
+          <a:bodyPr wrap="square" lIns="0" tIns="0" rIns="0" bIns="0" rtlCol="0" anchor="t"/>
+          <a:lstStyle/>
           <a:p>
             <a:pPr marL="0" indent="0">
               <a:lnSpc>
@@ -6189,18 +5945,7 @@
               <a:buNone/>
             </a:pPr>
             <a:r>
-              <a:rPr lang="en-US" sz="1150" b="1" dirty="0">
-                <a:solidFill>
-                  <a:srgbClr val="B33A3A"/>
-                </a:solidFill>
-                <a:latin typeface="Calibri" pitchFamily="34" charset="0"/>
-                <a:ea typeface="Calibri" pitchFamily="34" charset="-122"/>
-                <a:cs typeface="Calibri" pitchFamily="34" charset="-120"/>
-              </a:rPr>
-              <a:t>Decisión: </a:t>
-            </a:r>
-            <a:r>
-              <a:rPr lang="en-US" sz="1150" dirty="0">
+              <a:rPr lang="en-US" sz="1100" dirty="0">
                 <a:solidFill>
                   <a:srgbClr val="5A5F73"/>
                 </a:solidFill>
@@ -6208,15 +5953,257 @@
                 <a:ea typeface="Calibri" pitchFamily="34" charset="-122"/>
                 <a:cs typeface="Calibri" pitchFamily="34" charset="-120"/>
               </a:rPr>
-              <a:t>no usar PCA en el modelado. Reduciría la interpretabilidad — crítica para explicar por qué se niega un crédito — sin aportar separabilidad.</a:t>
-            </a:r>
-            <a:endParaRPr lang="en-US" sz="1150" dirty="0"/>
-          </a:p>
-        </p:txBody>
-      </p:sp>
-      <p:sp>
-        <p:nvSpPr>
-          <p:cNvPr id="9" name="Text 6"/>
+              <a:t>Cuatro pares clave,</a:t>
+            </a:r>
+            <a:endParaRPr lang="en-US" sz="1100" dirty="0"/>
+          </a:p>
+          <a:p>
+            <a:pPr marL="0" indent="0">
+              <a:lnSpc>
+                <a:spcPct val="120000"/>
+              </a:lnSpc>
+              <a:buNone/>
+            </a:pPr>
+            <a:r>
+              <a:rPr lang="en-US" sz="1100" dirty="0">
+                <a:solidFill>
+                  <a:srgbClr val="5A5F73"/>
+                </a:solidFill>
+                <a:latin typeface="Calibri" pitchFamily="34" charset="0"/>
+                <a:ea typeface="Calibri" pitchFamily="34" charset="-122"/>
+                <a:cs typeface="Calibri" pitchFamily="34" charset="-120"/>
+              </a:rPr>
+              <a:t>diferenciando mora y al día</a:t>
+            </a:r>
+            <a:endParaRPr lang="en-US" sz="1100" dirty="0"/>
+          </a:p>
+        </p:txBody>
+      </p:sp>
+      <p:sp>
+        <p:nvSpPr>
+          <p:cNvPr id="13" name="Shape 11"/>
+          <p:cNvSpPr/>
+          <p:nvPr/>
+        </p:nvSpPr>
+        <p:spPr>
+          <a:xfrm>
+            <a:off x="9217152" y="1965960"/>
+            <a:ext cx="2670048" cy="1920240"/>
+          </a:xfrm>
+          <a:prstGeom prst="roundRect">
+            <a:avLst>
+              <a:gd name="adj" fmla="val 3810"/>
+            </a:avLst>
+          </a:prstGeom>
+          <a:solidFill>
+            <a:srgbClr val="F4F7FC"/>
+          </a:solidFill>
+          <a:ln/>
+        </p:spPr>
+        <p:txBody>
+          <a:bodyPr/>
+          <a:lstStyle/>
+          <a:p>
+            <a:endParaRPr lang="es-CO"/>
+          </a:p>
+        </p:txBody>
+      </p:sp>
+      <p:sp>
+        <p:nvSpPr>
+          <p:cNvPr id="14" name="Text 12"/>
+          <p:cNvSpPr/>
+          <p:nvPr/>
+        </p:nvSpPr>
+        <p:spPr>
+          <a:xfrm>
+            <a:off x="9473184" y="2221992"/>
+            <a:ext cx="2157984" cy="685800"/>
+          </a:xfrm>
+          <a:prstGeom prst="rect">
+            <a:avLst/>
+          </a:prstGeom>
+          <a:noFill/>
+          <a:ln/>
+        </p:spPr>
+        <p:txBody>
+          <a:bodyPr wrap="square" lIns="0" tIns="0" rIns="0" bIns="0" rtlCol="0" anchor="t"/>
+          <a:lstStyle/>
+          <a:p>
+            <a:pPr marL="0" indent="0">
+              <a:buNone/>
+            </a:pPr>
+            <a:r>
+              <a:rPr lang="en-US" sz="1400" b="1" dirty="0">
+                <a:solidFill>
+                  <a:srgbClr val="1E2761"/>
+                </a:solidFill>
+                <a:latin typeface="Calibri" pitchFamily="34" charset="0"/>
+                <a:ea typeface="Calibri" pitchFamily="34" charset="-122"/>
+                <a:cs typeface="Calibri" pitchFamily="34" charset="-120"/>
+              </a:rPr>
+              <a:t>Tablas de contingencia</a:t>
+            </a:r>
+            <a:endParaRPr lang="en-US" sz="1400" dirty="0"/>
+          </a:p>
+        </p:txBody>
+      </p:sp>
+      <p:sp>
+        <p:nvSpPr>
+          <p:cNvPr id="15" name="Text 13"/>
+          <p:cNvSpPr/>
+          <p:nvPr/>
+        </p:nvSpPr>
+        <p:spPr>
+          <a:xfrm>
+            <a:off x="9473184" y="2880360"/>
+            <a:ext cx="2157984" cy="914400"/>
+          </a:xfrm>
+          <a:prstGeom prst="rect">
+            <a:avLst/>
+          </a:prstGeom>
+          <a:noFill/>
+          <a:ln/>
+        </p:spPr>
+        <p:txBody>
+          <a:bodyPr wrap="square" lIns="0" tIns="0" rIns="0" bIns="0" rtlCol="0" anchor="t"/>
+          <a:lstStyle/>
+          <a:p>
+            <a:pPr marL="0" indent="0">
+              <a:lnSpc>
+                <a:spcPct val="120000"/>
+              </a:lnSpc>
+              <a:buNone/>
+            </a:pPr>
+            <a:r>
+              <a:rPr lang="en-US" sz="1100" dirty="0">
+                <a:solidFill>
+                  <a:srgbClr val="5A5F73"/>
+                </a:solidFill>
+                <a:latin typeface="Calibri" pitchFamily="34" charset="0"/>
+                <a:ea typeface="Calibri" pitchFamily="34" charset="-122"/>
+                <a:cs typeface="Calibri" pitchFamily="34" charset="-120"/>
+              </a:rPr>
+              <a:t>Cruces entre variables</a:t>
+            </a:r>
+            <a:endParaRPr lang="en-US" sz="1100" dirty="0"/>
+          </a:p>
+          <a:p>
+            <a:pPr marL="0" indent="0">
+              <a:lnSpc>
+                <a:spcPct val="120000"/>
+              </a:lnSpc>
+              <a:buNone/>
+            </a:pPr>
+            <a:r>
+              <a:rPr lang="en-US" sz="1100" dirty="0">
+                <a:solidFill>
+                  <a:srgbClr val="5A5F73"/>
+                </a:solidFill>
+                <a:latin typeface="Calibri" pitchFamily="34" charset="0"/>
+                <a:ea typeface="Calibri" pitchFamily="34" charset="-122"/>
+                <a:cs typeface="Calibri" pitchFamily="34" charset="-120"/>
+              </a:rPr>
+              <a:t>categóricas y el objetivo</a:t>
+            </a:r>
+            <a:endParaRPr lang="en-US" sz="1100" dirty="0"/>
+          </a:p>
+        </p:txBody>
+      </p:sp>
+      <p:sp>
+        <p:nvSpPr>
+          <p:cNvPr id="16" name="Shape 14"/>
+          <p:cNvSpPr/>
+          <p:nvPr/>
+        </p:nvSpPr>
+        <p:spPr>
+          <a:xfrm>
+            <a:off x="548640" y="4206240"/>
+            <a:ext cx="11064240" cy="1600200"/>
+          </a:xfrm>
+          <a:prstGeom prst="roundRect">
+            <a:avLst>
+              <a:gd name="adj" fmla="val 4571"/>
+            </a:avLst>
+          </a:prstGeom>
+          <a:solidFill>
+            <a:srgbClr val="FBEAEA"/>
+          </a:solidFill>
+          <a:ln/>
+        </p:spPr>
+        <p:txBody>
+          <a:bodyPr/>
+          <a:lstStyle/>
+          <a:p>
+            <a:endParaRPr lang="es-CO"/>
+          </a:p>
+        </p:txBody>
+      </p:sp>
+      <p:sp>
+        <p:nvSpPr>
+          <p:cNvPr id="17" name="Text 15"/>
+          <p:cNvSpPr/>
+          <p:nvPr/>
+        </p:nvSpPr>
+        <p:spPr>
+          <a:xfrm>
+            <a:off x="822960" y="4389120"/>
+            <a:ext cx="10515600" cy="1280160"/>
+          </a:xfrm>
+          <a:prstGeom prst="rect">
+            <a:avLst/>
+          </a:prstGeom>
+          <a:noFill/>
+          <a:ln/>
+        </p:spPr>
+        <p:txBody>
+          <a:bodyPr wrap="square" lIns="0" tIns="0" rIns="0" bIns="0" rtlCol="0" anchor="t"/>
+          <a:lstStyle/>
+          <a:p>
+            <a:pPr marL="0" indent="0">
+              <a:lnSpc>
+                <a:spcPct val="125000"/>
+              </a:lnSpc>
+              <a:buNone/>
+            </a:pPr>
+            <a:r>
+              <a:rPr lang="en-US" sz="1400" b="1" dirty="0">
+                <a:solidFill>
+                  <a:srgbClr val="1E2761"/>
+                </a:solidFill>
+                <a:latin typeface="Calibri" pitchFamily="34" charset="0"/>
+                <a:ea typeface="Calibri" pitchFamily="34" charset="-122"/>
+                <a:cs typeface="Calibri" pitchFamily="34" charset="-120"/>
+              </a:rPr>
+              <a:t>Conclusión del multivariado:
+</a:t>
+            </a:r>
+            <a:endParaRPr lang="en-US" sz="1400" dirty="0"/>
+          </a:p>
+          <a:p>
+            <a:pPr marL="0" indent="0">
+              <a:lnSpc>
+                <a:spcPct val="125000"/>
+              </a:lnSpc>
+              <a:buNone/>
+            </a:pPr>
+            <a:r>
+              <a:rPr lang="en-US" sz="1250" dirty="0">
+                <a:solidFill>
+                  <a:srgbClr val="5A5F73"/>
+                </a:solidFill>
+                <a:latin typeface="Calibri" pitchFamily="34" charset="0"/>
+                <a:ea typeface="Calibri" pitchFamily="34" charset="-122"/>
+                <a:cs typeface="Calibri" pitchFamily="34" charset="-120"/>
+              </a:rPr>
+              <a:t>ninguna combinación de dos variables separa a los clientes en mora. Las nubes de puntos se superponen ampliamente en todos los gráficos. Esto confirma que el riesgo depende de múltiples factores simultáneos y justifica un modelo multivariado en la siguiente fase.</a:t>
+            </a:r>
+            <a:endParaRPr lang="en-US" sz="1400" dirty="0"/>
+          </a:p>
+        </p:txBody>
+      </p:sp>
+      <p:sp>
+        <p:nvSpPr>
+          <p:cNvPr id="18" name="Text 16"/>
           <p:cNvSpPr/>
           <p:nvPr/>
         </p:nvSpPr>
@@ -6255,7 +6242,7 @@
       </p:sp>
       <p:sp>
         <p:nvSpPr>
-          <p:cNvPr id="10" name="Text 7"/>
+          <p:cNvPr id="19" name="Text 17"/>
           <p:cNvSpPr/>
           <p:nvPr/>
         </p:nvSpPr>
@@ -7700,45 +7687,6 @@
       </p:sp>
       <p:sp>
         <p:nvSpPr>
-          <p:cNvPr id="11" name="Text 9"/>
-          <p:cNvSpPr/>
-          <p:nvPr/>
-        </p:nvSpPr>
-        <p:spPr>
-          <a:xfrm>
-            <a:off x="4663440" y="2286000"/>
-            <a:ext cx="548640" cy="548640"/>
-          </a:xfrm>
-          <a:prstGeom prst="rect">
-            <a:avLst/>
-          </a:prstGeom>
-          <a:noFill/>
-          <a:ln/>
-        </p:spPr>
-        <p:txBody>
-          <a:bodyPr wrap="square" lIns="0" tIns="0" rIns="0" bIns="0" rtlCol="0" anchor="ctr"/>
-          <a:lstStyle/>
-          <a:p>
-            <a:pPr marL="0" indent="0" algn="ctr">
-              <a:buNone/>
-            </a:pPr>
-            <a:r>
-              <a:rPr lang="en-US" sz="2000" b="1" dirty="0">
-                <a:solidFill>
-                  <a:srgbClr val="FFFFFF"/>
-                </a:solidFill>
-                <a:latin typeface="Calibri" pitchFamily="34" charset="0"/>
-                <a:ea typeface="Calibri" pitchFamily="34" charset="-122"/>
-                <a:cs typeface="Calibri" pitchFamily="34" charset="-120"/>
-              </a:rPr>
-              <a:t>2</a:t>
-            </a:r>
-            <a:endParaRPr lang="en-US" sz="2000" dirty="0"/>
-          </a:p>
-        </p:txBody>
-      </p:sp>
-      <p:sp>
-        <p:nvSpPr>
           <p:cNvPr id="14" name="Shape 12"/>
           <p:cNvSpPr/>
           <p:nvPr/>
@@ -7789,7 +7737,7 @@
           <a:bodyPr/>
           <a:lstStyle/>
           <a:p>
-            <a:endParaRPr lang="es-CO"/>
+            <a:endParaRPr lang="es-CO" dirty="0"/>
           </a:p>
         </p:txBody>
       </p:sp>
@@ -7826,7 +7774,7 @@
                 <a:ea typeface="Calibri" pitchFamily="34" charset="-122"/>
                 <a:cs typeface="Calibri" pitchFamily="34" charset="-120"/>
               </a:rPr>
-              <a:t>3</a:t>
+              <a:t>2</a:t>
             </a:r>
             <a:endParaRPr lang="en-US" sz="2000" dirty="0"/>
           </a:p>
@@ -8086,8 +8034,9 @@
                 </a:solidFill>
                 <a:latin typeface="Cambria" pitchFamily="34" charset="0"/>
                 <a:ea typeface="Cambria" pitchFamily="34" charset="-122"/>
-              </a:rPr>
-              <a:t>Proyecto </a:t>
+                <a:cs typeface="Cambria" pitchFamily="34" charset="-120"/>
+              </a:rPr>
+              <a:t>Un pipeline a </a:t>
             </a:r>
             <a:r>
               <a:rPr lang="en-US" sz="3000" b="1" dirty="0" err="1">
@@ -8096,8 +8045,9 @@
                 </a:solidFill>
                 <a:latin typeface="Cambria" pitchFamily="34" charset="0"/>
                 <a:ea typeface="Cambria" pitchFamily="34" charset="-122"/>
-              </a:rPr>
-              <a:t>durante</a:t>
+                <a:cs typeface="Cambria" pitchFamily="34" charset="-120"/>
+              </a:rPr>
+              <a:t>desarrollar</a:t>
             </a:r>
             <a:r>
               <a:rPr lang="en-US" sz="3000" b="1" dirty="0">
@@ -8106,8 +8056,9 @@
                 </a:solidFill>
                 <a:latin typeface="Cambria" pitchFamily="34" charset="0"/>
                 <a:ea typeface="Cambria" pitchFamily="34" charset="-122"/>
-              </a:rPr>
-              <a:t> el </a:t>
+                <a:cs typeface="Cambria" pitchFamily="34" charset="-120"/>
+              </a:rPr>
+              <a:t> </a:t>
             </a:r>
             <a:r>
               <a:rPr lang="en-US" sz="3000" b="1" dirty="0" err="1">
@@ -8116,6 +8067,29 @@
                 </a:solidFill>
                 <a:latin typeface="Cambria" pitchFamily="34" charset="0"/>
                 <a:ea typeface="Cambria" pitchFamily="34" charset="-122"/>
+                <a:cs typeface="Cambria" pitchFamily="34" charset="-120"/>
+              </a:rPr>
+              <a:t>durante</a:t>
+            </a:r>
+            <a:r>
+              <a:rPr lang="en-US" sz="3000" b="1" dirty="0">
+                <a:solidFill>
+                  <a:srgbClr val="1E2761"/>
+                </a:solidFill>
+                <a:latin typeface="Cambria" pitchFamily="34" charset="0"/>
+                <a:ea typeface="Cambria" pitchFamily="34" charset="-122"/>
+                <a:cs typeface="Cambria" pitchFamily="34" charset="-120"/>
+              </a:rPr>
+              <a:t> el </a:t>
+            </a:r>
+            <a:r>
+              <a:rPr lang="en-US" sz="3000" b="1" dirty="0" err="1">
+                <a:solidFill>
+                  <a:srgbClr val="1E2761"/>
+                </a:solidFill>
+                <a:latin typeface="Cambria" pitchFamily="34" charset="0"/>
+                <a:ea typeface="Cambria" pitchFamily="34" charset="-122"/>
+                <a:cs typeface="Cambria" pitchFamily="34" charset="-120"/>
               </a:rPr>
               <a:t>semestre</a:t>
             </a:r>
@@ -9458,6 +9432,45 @@
       </p:grpSpPr>
       <p:sp>
         <p:nvSpPr>
+          <p:cNvPr id="2" name="Text 0"/>
+          <p:cNvSpPr/>
+          <p:nvPr/>
+        </p:nvSpPr>
+        <p:spPr>
+          <a:xfrm>
+            <a:off x="548640" y="411480"/>
+            <a:ext cx="9144000" cy="320040"/>
+          </a:xfrm>
+          <a:prstGeom prst="rect">
+            <a:avLst/>
+          </a:prstGeom>
+          <a:noFill/>
+          <a:ln/>
+        </p:spPr>
+        <p:txBody>
+          <a:bodyPr wrap="square" lIns="0" tIns="0" rIns="0" bIns="0" rtlCol="0" anchor="ctr"/>
+          <a:lstStyle/>
+          <a:p>
+            <a:pPr marL="0" indent="0">
+              <a:buNone/>
+            </a:pPr>
+            <a:r>
+              <a:rPr lang="en-US" sz="1300" b="1" kern="0" spc="200" dirty="0">
+                <a:solidFill>
+                  <a:srgbClr val="B33A3A"/>
+                </a:solidFill>
+                <a:latin typeface="Calibri" pitchFamily="34" charset="0"/>
+                <a:ea typeface="Calibri" pitchFamily="34" charset="-122"/>
+                <a:cs typeface="Calibri" pitchFamily="34" charset="-120"/>
+              </a:rPr>
+              <a:t>E</a:t>
+            </a:r>
+            <a:endParaRPr lang="en-US" sz="1300" dirty="0"/>
+          </a:p>
+        </p:txBody>
+      </p:sp>
+      <p:sp>
+        <p:nvSpPr>
           <p:cNvPr id="3" name="Text 1"/>
           <p:cNvSpPr/>
           <p:nvPr/>
@@ -9500,18 +9513,7 @@
                 <a:ea typeface="Cambria" pitchFamily="34" charset="-122"/>
                 <a:cs typeface="Cambria" pitchFamily="34" charset="-120"/>
               </a:rPr>
-              <a:t> </a:t>
-            </a:r>
-            <a:r>
-              <a:rPr lang="en-US" sz="3000" b="1" dirty="0" err="1">
-                <a:solidFill>
-                  <a:srgbClr val="1E2761"/>
-                </a:solidFill>
-                <a:latin typeface="Cambria" pitchFamily="34" charset="0"/>
-                <a:ea typeface="Cambria" pitchFamily="34" charset="-122"/>
-                <a:cs typeface="Cambria" pitchFamily="34" charset="-120"/>
-              </a:rPr>
-              <a:t>Obtenido</a:t>
+              <a:t> general</a:t>
             </a:r>
             <a:endParaRPr lang="en-US" sz="3000" dirty="0"/>
           </a:p>
@@ -10189,7 +10191,7 @@
                 <a:ea typeface="Calibri" pitchFamily="34" charset="-122"/>
                 <a:cs typeface="Calibri" pitchFamily="34" charset="-120"/>
               </a:rPr>
-              <a:t> para la </a:t>
+              <a:t>  para la </a:t>
             </a:r>
             <a:r>
               <a:rPr lang="en-US" sz="1600" dirty="0" err="1">
@@ -10211,16 +10213,19 @@
                 <a:ea typeface="Calibri" pitchFamily="34" charset="-122"/>
                 <a:cs typeface="Calibri" pitchFamily="34" charset="-120"/>
               </a:rPr>
-              <a:t> de decisiones</a:t>
-            </a:r>
-          </a:p>
-          <a:p>
-            <a:pPr marL="0" indent="0">
-              <a:lnSpc>
-                <a:spcPct val="125000"/>
-              </a:lnSpc>
-              <a:buNone/>
-            </a:pPr>
+              <a:t> de </a:t>
+            </a:r>
+            <a:r>
+              <a:rPr lang="en-US" sz="1600" dirty="0" err="1">
+                <a:solidFill>
+                  <a:srgbClr val="5A5F73"/>
+                </a:solidFill>
+                <a:latin typeface="Calibri" pitchFamily="34" charset="0"/>
+                <a:ea typeface="Calibri" pitchFamily="34" charset="-122"/>
+                <a:cs typeface="Calibri" pitchFamily="34" charset="-120"/>
+              </a:rPr>
+              <a:t>decisiones</a:t>
+            </a:r>
             <a:endParaRPr lang="en-US" sz="1600" dirty="0">
               <a:solidFill>
                 <a:srgbClr val="5A5F73"/>
@@ -10237,135 +10242,6 @@
               </a:lnSpc>
               <a:buNone/>
             </a:pPr>
-            <a:r>
-              <a:rPr lang="en-US" sz="1600" dirty="0">
-                <a:solidFill>
-                  <a:srgbClr val="5A5F73"/>
-                </a:solidFill>
-                <a:latin typeface="Calibri" pitchFamily="34" charset="0"/>
-                <a:ea typeface="Calibri" pitchFamily="34" charset="-122"/>
-                <a:cs typeface="Calibri" pitchFamily="34" charset="-120"/>
-              </a:rPr>
-              <a:t>Los </a:t>
-            </a:r>
-            <a:r>
-              <a:rPr lang="en-US" sz="1600" dirty="0" err="1">
-                <a:solidFill>
-                  <a:srgbClr val="5A5F73"/>
-                </a:solidFill>
-                <a:latin typeface="Calibri" pitchFamily="34" charset="0"/>
-                <a:ea typeface="Calibri" pitchFamily="34" charset="-122"/>
-                <a:cs typeface="Calibri" pitchFamily="34" charset="-120"/>
-              </a:rPr>
-              <a:t>datos</a:t>
-            </a:r>
-            <a:r>
-              <a:rPr lang="en-US" sz="1600" dirty="0">
-                <a:solidFill>
-                  <a:srgbClr val="5A5F73"/>
-                </a:solidFill>
-                <a:latin typeface="Calibri" pitchFamily="34" charset="0"/>
-                <a:ea typeface="Calibri" pitchFamily="34" charset="-122"/>
-                <a:cs typeface="Calibri" pitchFamily="34" charset="-120"/>
-              </a:rPr>
-              <a:t> </a:t>
-            </a:r>
-            <a:r>
-              <a:rPr lang="en-US" sz="1600" dirty="0" err="1">
-                <a:solidFill>
-                  <a:srgbClr val="5A5F73"/>
-                </a:solidFill>
-                <a:latin typeface="Calibri" pitchFamily="34" charset="0"/>
-                <a:ea typeface="Calibri" pitchFamily="34" charset="-122"/>
-                <a:cs typeface="Calibri" pitchFamily="34" charset="-120"/>
-              </a:rPr>
-              <a:t>crediticios</a:t>
-            </a:r>
-            <a:r>
-              <a:rPr lang="en-US" sz="1600" dirty="0">
-                <a:solidFill>
-                  <a:srgbClr val="5A5F73"/>
-                </a:solidFill>
-                <a:latin typeface="Calibri" pitchFamily="34" charset="0"/>
-                <a:ea typeface="Calibri" pitchFamily="34" charset="-122"/>
-                <a:cs typeface="Calibri" pitchFamily="34" charset="-120"/>
-              </a:rPr>
-              <a:t> van </a:t>
-            </a:r>
-            <a:r>
-              <a:rPr lang="en-US" sz="1600" dirty="0" err="1">
-                <a:solidFill>
-                  <a:srgbClr val="5A5F73"/>
-                </a:solidFill>
-                <a:latin typeface="Calibri" pitchFamily="34" charset="0"/>
-                <a:ea typeface="Calibri" pitchFamily="34" charset="-122"/>
-                <a:cs typeface="Calibri" pitchFamily="34" charset="-120"/>
-              </a:rPr>
-              <a:t>desde</a:t>
-            </a:r>
-            <a:r>
-              <a:rPr lang="en-US" sz="1600" dirty="0">
-                <a:solidFill>
-                  <a:srgbClr val="5A5F73"/>
-                </a:solidFill>
-                <a:latin typeface="Calibri" pitchFamily="34" charset="0"/>
-                <a:ea typeface="Calibri" pitchFamily="34" charset="-122"/>
-                <a:cs typeface="Calibri" pitchFamily="34" charset="-120"/>
-              </a:rPr>
-              <a:t> </a:t>
-            </a:r>
-            <a:r>
-              <a:rPr lang="en-US" sz="1600" dirty="0" err="1">
-                <a:solidFill>
-                  <a:srgbClr val="5A5F73"/>
-                </a:solidFill>
-                <a:latin typeface="Calibri" pitchFamily="34" charset="0"/>
-                <a:ea typeface="Calibri" pitchFamily="34" charset="-122"/>
-                <a:cs typeface="Calibri" pitchFamily="34" charset="-120"/>
-              </a:rPr>
-              <a:t>noviembre</a:t>
-            </a:r>
-            <a:r>
-              <a:rPr lang="en-US" sz="1600" dirty="0">
-                <a:solidFill>
-                  <a:srgbClr val="5A5F73"/>
-                </a:solidFill>
-                <a:latin typeface="Calibri" pitchFamily="34" charset="0"/>
-                <a:ea typeface="Calibri" pitchFamily="34" charset="-122"/>
-                <a:cs typeface="Calibri" pitchFamily="34" charset="-120"/>
-              </a:rPr>
-              <a:t> del 2024 hasta </a:t>
-            </a:r>
-            <a:r>
-              <a:rPr lang="en-US" sz="1600" dirty="0" err="1">
-                <a:solidFill>
-                  <a:srgbClr val="5A5F73"/>
-                </a:solidFill>
-                <a:latin typeface="Calibri" pitchFamily="34" charset="0"/>
-                <a:ea typeface="Calibri" pitchFamily="34" charset="-122"/>
-                <a:cs typeface="Calibri" pitchFamily="34" charset="-120"/>
-              </a:rPr>
-              <a:t>abril</a:t>
-            </a:r>
-            <a:r>
-              <a:rPr lang="en-US" sz="1600" dirty="0">
-                <a:solidFill>
-                  <a:srgbClr val="5A5F73"/>
-                </a:solidFill>
-                <a:latin typeface="Calibri" pitchFamily="34" charset="0"/>
-                <a:ea typeface="Calibri" pitchFamily="34" charset="-122"/>
-                <a:cs typeface="Calibri" pitchFamily="34" charset="-120"/>
-              </a:rPr>
-              <a:t> 2026</a:t>
-            </a:r>
-          </a:p>
-          <a:p>
-            <a:pPr marL="0" indent="0">
-              <a:lnSpc>
-                <a:spcPct val="125000"/>
-              </a:lnSpc>
-              <a:buNone/>
-            </a:pPr>
             <a:endParaRPr lang="en-US" sz="1600" dirty="0">
               <a:solidFill>
                 <a:srgbClr val="5A5F73"/>
@@ -10383,6 +10259,17 @@
               <a:buNone/>
             </a:pPr>
             <a:r>
+              <a:rPr lang="en-US" sz="1600" dirty="0">
+                <a:solidFill>
+                  <a:srgbClr val="5A5F73"/>
+                </a:solidFill>
+                <a:latin typeface="Calibri" pitchFamily="34" charset="0"/>
+                <a:ea typeface="Calibri" pitchFamily="34" charset="-122"/>
+                <a:cs typeface="Calibri" pitchFamily="34" charset="-120"/>
+              </a:rPr>
+              <a:t>Los </a:t>
+            </a:r>
+            <a:r>
               <a:rPr lang="en-US" sz="1600" dirty="0" err="1">
                 <a:solidFill>
                   <a:srgbClr val="5A5F73"/>
@@ -10391,7 +10278,7 @@
                 <a:ea typeface="Calibri" pitchFamily="34" charset="-122"/>
                 <a:cs typeface="Calibri" pitchFamily="34" charset="-120"/>
               </a:rPr>
-              <a:t>Además</a:t>
+              <a:t>dato</a:t>
             </a:r>
             <a:r>
               <a:rPr lang="en-US" sz="1600" dirty="0">
@@ -10402,7 +10289,7 @@
                 <a:ea typeface="Calibri" pitchFamily="34" charset="-122"/>
                 <a:cs typeface="Calibri" pitchFamily="34" charset="-120"/>
               </a:rPr>
-              <a:t> se propone la </a:t>
+              <a:t> se dan </a:t>
             </a:r>
             <a:r>
               <a:rPr lang="en-US" sz="1600" dirty="0" err="1">
@@ -10413,7 +10300,7 @@
                 <a:ea typeface="Calibri" pitchFamily="34" charset="-122"/>
                 <a:cs typeface="Calibri" pitchFamily="34" charset="-120"/>
               </a:rPr>
-              <a:t>construcción</a:t>
+              <a:t>desde</a:t>
             </a:r>
             <a:r>
               <a:rPr lang="en-US" sz="1600" dirty="0">
@@ -10424,7 +10311,7 @@
                 <a:ea typeface="Calibri" pitchFamily="34" charset="-122"/>
                 <a:cs typeface="Calibri" pitchFamily="34" charset="-120"/>
               </a:rPr>
-              <a:t> de un diccionario de </a:t>
+              <a:t> </a:t>
             </a:r>
             <a:r>
               <a:rPr lang="en-US" sz="1600" dirty="0" err="1">
@@ -10435,40 +10322,41 @@
                 <a:ea typeface="Calibri" pitchFamily="34" charset="-122"/>
                 <a:cs typeface="Calibri" pitchFamily="34" charset="-120"/>
               </a:rPr>
-              <a:t>datos</a:t>
-            </a:r>
-            <a:endParaRPr lang="en-US" sz="1600" dirty="0">
-              <a:solidFill>
-                <a:srgbClr val="5A5F73"/>
-              </a:solidFill>
-              <a:latin typeface="Calibri" pitchFamily="34" charset="0"/>
-              <a:ea typeface="Calibri" pitchFamily="34" charset="-122"/>
-              <a:cs typeface="Calibri" pitchFamily="34" charset="-120"/>
-            </a:endParaRPr>
-          </a:p>
-          <a:p>
-            <a:pPr marL="0" indent="0">
-              <a:lnSpc>
-                <a:spcPct val="125000"/>
-              </a:lnSpc>
-              <a:buNone/>
-            </a:pPr>
-            <a:endParaRPr lang="en-US" sz="1600" dirty="0">
-              <a:solidFill>
-                <a:srgbClr val="5A5F73"/>
-              </a:solidFill>
-              <a:latin typeface="Calibri" pitchFamily="34" charset="0"/>
-              <a:ea typeface="Calibri" pitchFamily="34" charset="-122"/>
-              <a:cs typeface="Calibri" pitchFamily="34" charset="-120"/>
-            </a:endParaRPr>
-          </a:p>
-          <a:p>
-            <a:pPr marL="0" indent="0">
-              <a:lnSpc>
-                <a:spcPct val="125000"/>
-              </a:lnSpc>
-              <a:buNone/>
-            </a:pPr>
+              <a:t>noviembre</a:t>
+            </a:r>
+            <a:r>
+              <a:rPr lang="en-US" sz="1600" dirty="0">
+                <a:solidFill>
+                  <a:srgbClr val="5A5F73"/>
+                </a:solidFill>
+                <a:latin typeface="Calibri" pitchFamily="34" charset="0"/>
+                <a:ea typeface="Calibri" pitchFamily="34" charset="-122"/>
+                <a:cs typeface="Calibri" pitchFamily="34" charset="-120"/>
+              </a:rPr>
+              <a:t> del 2024 hasta </a:t>
+            </a:r>
+            <a:r>
+              <a:rPr lang="en-US" sz="1600" dirty="0" err="1">
+                <a:solidFill>
+                  <a:srgbClr val="5A5F73"/>
+                </a:solidFill>
+                <a:latin typeface="Calibri" pitchFamily="34" charset="0"/>
+                <a:ea typeface="Calibri" pitchFamily="34" charset="-122"/>
+                <a:cs typeface="Calibri" pitchFamily="34" charset="-120"/>
+              </a:rPr>
+              <a:t>abril</a:t>
+            </a:r>
+            <a:r>
+              <a:rPr lang="en-US" sz="1600" dirty="0">
+                <a:solidFill>
+                  <a:srgbClr val="5A5F73"/>
+                </a:solidFill>
+                <a:latin typeface="Calibri" pitchFamily="34" charset="0"/>
+                <a:ea typeface="Calibri" pitchFamily="34" charset="-122"/>
+                <a:cs typeface="Calibri" pitchFamily="34" charset="-120"/>
+              </a:rPr>
+              <a:t> 2026</a:t>
+            </a:r>
             <a:endParaRPr lang="en-US" sz="1600" dirty="0"/>
           </a:p>
         </p:txBody>
@@ -10879,6 +10767,51 @@
               <a:t>3</a:t>
             </a:r>
             <a:endParaRPr lang="en-US" sz="1000" dirty="0"/>
+          </a:p>
+        </p:txBody>
+      </p:sp>
+      <p:sp>
+        <p:nvSpPr>
+          <p:cNvPr id="17" name="Shape 9">
+            <a:extLst>
+              <a:ext uri="{FF2B5EF4-FFF2-40B4-BE49-F238E27FC236}">
+                <a16:creationId xmlns:a16="http://schemas.microsoft.com/office/drawing/2014/main" id="{D525EDD1-6568-B6D4-8B70-CD8A670FC315}"/>
+              </a:ext>
+            </a:extLst>
+          </p:cNvPr>
+          <p:cNvSpPr/>
+          <p:nvPr/>
+        </p:nvSpPr>
+        <p:spPr>
+          <a:xfrm>
+            <a:off x="457200" y="4411980"/>
+            <a:ext cx="4206240" cy="1188720"/>
+          </a:xfrm>
+          <a:prstGeom prst="roundRect">
+            <a:avLst>
+              <a:gd name="adj" fmla="val 6154"/>
+            </a:avLst>
+          </a:prstGeom>
+          <a:solidFill>
+            <a:srgbClr val="F4F7FC"/>
+          </a:solidFill>
+          <a:ln/>
+          <a:effectLst>
+            <a:outerShdw blurRad="76200" dist="25400" dir="5400000" algn="bl" rotWithShape="0">
+              <a:srgbClr val="000000">
+                <a:alpha val="12000"/>
+              </a:srgbClr>
+            </a:outerShdw>
+          </a:effectLst>
+        </p:spPr>
+        <p:txBody>
+          <a:bodyPr/>
+          <a:lstStyle/>
+          <a:p>
+            <a:r>
+              <a:rPr lang="es-CO" dirty="0"/>
+              <a:t>TARGET : Pago a tiempo</a:t>
+            </a:r>
           </a:p>
         </p:txBody>
       </p:sp>
@@ -10915,7 +10848,7 @@
         </p:nvSpPr>
         <p:spPr>
           <a:xfrm>
-            <a:off x="548640" y="402336"/>
+            <a:off x="548640" y="411480"/>
             <a:ext cx="9144000" cy="320040"/>
           </a:xfrm>
           <a:prstGeom prst="rect">
@@ -10940,7 +10873,7 @@
                 <a:ea typeface="Calibri" pitchFamily="34" charset="-122"/>
                 <a:cs typeface="Calibri" pitchFamily="34" charset="-120"/>
               </a:rPr>
-              <a:t>INVESTIGACION SECTOR BANCARIO COLOMBIANO</a:t>
+              <a:t>INVESTIGACIÓN METODOLÓGICA BANCOS EN COLOMBIA</a:t>
             </a:r>
             <a:endParaRPr lang="en-US" sz="1300" dirty="0"/>
           </a:p>
@@ -11018,95 +10951,7 @@
                 <a:ea typeface="Calibri" pitchFamily="34" charset="-122"/>
                 <a:cs typeface="Calibri" pitchFamily="34" charset="-120"/>
               </a:rPr>
-              <a:t>No se </a:t>
-            </a:r>
-            <a:r>
-              <a:rPr lang="en-US" sz="1400" i="1" dirty="0" err="1">
-                <a:solidFill>
-                  <a:srgbClr val="5A5F73"/>
-                </a:solidFill>
-                <a:latin typeface="Calibri" pitchFamily="34" charset="0"/>
-                <a:ea typeface="Calibri" pitchFamily="34" charset="-122"/>
-                <a:cs typeface="Calibri" pitchFamily="34" charset="-120"/>
-              </a:rPr>
-              <a:t>entregó</a:t>
-            </a:r>
-            <a:r>
-              <a:rPr lang="en-US" sz="1400" i="1" dirty="0">
-                <a:solidFill>
-                  <a:srgbClr val="5A5F73"/>
-                </a:solidFill>
-                <a:latin typeface="Calibri" pitchFamily="34" charset="0"/>
-                <a:ea typeface="Calibri" pitchFamily="34" charset="-122"/>
-                <a:cs typeface="Calibri" pitchFamily="34" charset="-120"/>
-              </a:rPr>
-              <a:t> diccionario , </a:t>
-            </a:r>
-            <a:r>
-              <a:rPr lang="en-US" sz="1400" i="1" dirty="0" err="1">
-                <a:solidFill>
-                  <a:srgbClr val="5A5F73"/>
-                </a:solidFill>
-                <a:latin typeface="Calibri" pitchFamily="34" charset="0"/>
-                <a:ea typeface="Calibri" pitchFamily="34" charset="-122"/>
-                <a:cs typeface="Calibri" pitchFamily="34" charset="-120"/>
-              </a:rPr>
-              <a:t>entonces</a:t>
-            </a:r>
-            <a:r>
-              <a:rPr lang="en-US" sz="1400" i="1" dirty="0">
-                <a:solidFill>
-                  <a:srgbClr val="5A5F73"/>
-                </a:solidFill>
-                <a:latin typeface="Calibri" pitchFamily="34" charset="0"/>
-                <a:ea typeface="Calibri" pitchFamily="34" charset="-122"/>
-                <a:cs typeface="Calibri" pitchFamily="34" charset="-120"/>
-              </a:rPr>
-              <a:t> se </a:t>
-            </a:r>
-            <a:r>
-              <a:rPr lang="en-US" sz="1400" i="1" dirty="0" err="1">
-                <a:solidFill>
-                  <a:srgbClr val="5A5F73"/>
-                </a:solidFill>
-                <a:latin typeface="Calibri" pitchFamily="34" charset="0"/>
-                <a:ea typeface="Calibri" pitchFamily="34" charset="-122"/>
-                <a:cs typeface="Calibri" pitchFamily="34" charset="-120"/>
-              </a:rPr>
-              <a:t>implementa</a:t>
-            </a:r>
-            <a:r>
-              <a:rPr lang="en-US" sz="1400" i="1" dirty="0">
-                <a:solidFill>
-                  <a:srgbClr val="5A5F73"/>
-                </a:solidFill>
-                <a:latin typeface="Calibri" pitchFamily="34" charset="0"/>
-                <a:ea typeface="Calibri" pitchFamily="34" charset="-122"/>
-                <a:cs typeface="Calibri" pitchFamily="34" charset="-120"/>
-              </a:rPr>
-              <a:t> un diccionario de </a:t>
-            </a:r>
-            <a:r>
-              <a:rPr lang="en-US" sz="1400" i="1" dirty="0" err="1">
-                <a:solidFill>
-                  <a:srgbClr val="5A5F73"/>
-                </a:solidFill>
-                <a:latin typeface="Calibri" pitchFamily="34" charset="0"/>
-                <a:ea typeface="Calibri" pitchFamily="34" charset="-122"/>
-                <a:cs typeface="Calibri" pitchFamily="34" charset="-120"/>
-              </a:rPr>
-              <a:t>datos</a:t>
-            </a:r>
-            <a:r>
-              <a:rPr lang="en-US" sz="1400" i="1" dirty="0">
-                <a:solidFill>
-                  <a:srgbClr val="5A5F73"/>
-                </a:solidFill>
-                <a:latin typeface="Calibri" pitchFamily="34" charset="0"/>
-                <a:ea typeface="Calibri" pitchFamily="34" charset="-122"/>
-                <a:cs typeface="Calibri" pitchFamily="34" charset="-120"/>
-              </a:rPr>
-              <a:t>.</a:t>
+              <a:t>No se entregó diccionario. Construirlo reveló tres errores metodológicos reales.</a:t>
             </a:r>
             <a:endParaRPr lang="en-US" sz="1400" dirty="0"/>
           </a:p>
@@ -11845,7 +11690,7 @@
         </p:nvSpPr>
         <p:spPr>
           <a:xfrm>
-            <a:off x="548640" y="4640113"/>
+            <a:off x="548640" y="4663440"/>
             <a:ext cx="11064240" cy="1051560"/>
           </a:xfrm>
           <a:prstGeom prst="roundRect">
@@ -11895,9 +11740,6 @@
             </a:pPr>
             <a:r>
               <a:rPr lang="en-US" sz="1200" b="1" dirty="0">
-                <a:solidFill>
-                  <a:srgbClr val="1E2761"/>
-                </a:solidFill>
                 <a:latin typeface="Calibri" pitchFamily="34" charset="0"/>
                 <a:ea typeface="Calibri" pitchFamily="34" charset="-122"/>
                 <a:cs typeface="Calibri" pitchFamily="34" charset="-120"/>
@@ -11910,7 +11752,7 @@
                 <a:ea typeface="Calibri" pitchFamily="34" charset="-122"/>
                 <a:cs typeface="Calibri" pitchFamily="34" charset="-120"/>
               </a:rPr>
-              <a:t>bajo Ley 1266 de 2008 todas las variables son (dato financiero y crediticio). Ninguna es </a:t>
+              <a:t>bajo Ley 1266 de 2008 todas las variables son </a:t>
             </a:r>
             <a:r>
               <a:rPr lang="en-US" sz="1200" b="1" dirty="0">
@@ -11918,6 +11760,22 @@
                 <a:ea typeface="Calibri" pitchFamily="34" charset="-122"/>
                 <a:cs typeface="Calibri" pitchFamily="34" charset="-120"/>
               </a:rPr>
+              <a:t>semiprivadas</a:t>
+            </a:r>
+            <a:r>
+              <a:rPr lang="en-US" sz="1200" dirty="0">
+                <a:latin typeface="Calibri" pitchFamily="34" charset="0"/>
+                <a:ea typeface="Calibri" pitchFamily="34" charset="-122"/>
+                <a:cs typeface="Calibri" pitchFamily="34" charset="-120"/>
+              </a:rPr>
+              <a:t> (dato financiero y crediticio). Ninguna es </a:t>
+            </a:r>
+            <a:r>
+              <a:rPr lang="en-US" sz="1200" b="1" dirty="0">
+                <a:latin typeface="Calibri" pitchFamily="34" charset="0"/>
+                <a:ea typeface="Calibri" pitchFamily="34" charset="-122"/>
+                <a:cs typeface="Calibri" pitchFamily="34" charset="-120"/>
+              </a:rPr>
               <a:t>sensible</a:t>
             </a:r>
             <a:r>
@@ -11926,7 +11784,7 @@
                 <a:ea typeface="Calibri" pitchFamily="34" charset="-122"/>
                 <a:cs typeface="Calibri" pitchFamily="34" charset="-120"/>
               </a:rPr>
-              <a:t> en el sentido de la Ley 1581 art. 5</a:t>
+              <a:t> en el sentido de la Ley 1581 art. 5 (origen racial, salud, biometría).</a:t>
             </a:r>
             <a:endParaRPr lang="en-US" sz="1200" dirty="0"/>
           </a:p>
@@ -12107,7 +11965,7 @@
                 <a:ea typeface="Cambria" pitchFamily="34" charset="-122"/>
                 <a:cs typeface="Cambria" pitchFamily="34" charset="-120"/>
               </a:rPr>
-              <a:t>Tres errores que el diccionario </a:t>
+              <a:t>Tres errores que el </a:t>
             </a:r>
             <a:r>
               <a:rPr lang="en-US" sz="3000" b="1" dirty="0" err="1">
@@ -12118,7 +11976,7 @@
                 <a:ea typeface="Cambria" pitchFamily="34" charset="-122"/>
                 <a:cs typeface="Cambria" pitchFamily="34" charset="-120"/>
               </a:rPr>
-              <a:t>permitió</a:t>
+              <a:t>diccionario</a:t>
             </a:r>
             <a:r>
               <a:rPr lang="en-US" sz="3000" b="1" dirty="0">
@@ -12140,7 +11998,29 @@
                 <a:ea typeface="Cambria" pitchFamily="34" charset="-122"/>
                 <a:cs typeface="Cambria" pitchFamily="34" charset="-120"/>
               </a:rPr>
-              <a:t>conocer</a:t>
+              <a:t>permitió</a:t>
+            </a:r>
+            <a:r>
+              <a:rPr lang="en-US" sz="3000" b="1" dirty="0">
+                <a:solidFill>
+                  <a:srgbClr val="1E2761"/>
+                </a:solidFill>
+                <a:latin typeface="Cambria" pitchFamily="34" charset="0"/>
+                <a:ea typeface="Cambria" pitchFamily="34" charset="-122"/>
+                <a:cs typeface="Cambria" pitchFamily="34" charset="-120"/>
+              </a:rPr>
+              <a:t> </a:t>
+            </a:r>
+            <a:r>
+              <a:rPr lang="en-US" sz="3000" b="1" dirty="0" err="1">
+                <a:solidFill>
+                  <a:srgbClr val="1E2761"/>
+                </a:solidFill>
+                <a:latin typeface="Cambria" pitchFamily="34" charset="0"/>
+                <a:ea typeface="Cambria" pitchFamily="34" charset="-122"/>
+                <a:cs typeface="Cambria" pitchFamily="34" charset="-120"/>
+              </a:rPr>
+              <a:t>revelar</a:t>
             </a:r>
             <a:endParaRPr lang="en-US" sz="3000" dirty="0"/>
           </a:p>
@@ -13877,7 +13757,7 @@
               <a:buNone/>
             </a:pPr>
             <a:r>
-              <a:rPr lang="en-US" sz="3000" b="1" dirty="0">
+              <a:rPr lang="en-US" sz="3000" b="1" dirty="0" err="1">
                 <a:solidFill>
                   <a:srgbClr val="1E2761"/>
                 </a:solidFill>
@@ -13885,7 +13765,40 @@
                 <a:ea typeface="Cambria" pitchFamily="34" charset="-122"/>
                 <a:cs typeface="Cambria" pitchFamily="34" charset="-120"/>
               </a:rPr>
-              <a:t>Lo que encontramos antes de analizar</a:t>
+              <a:t>Información</a:t>
+            </a:r>
+            <a:r>
+              <a:rPr lang="en-US" sz="3000" b="1" dirty="0">
+                <a:solidFill>
+                  <a:srgbClr val="1E2761"/>
+                </a:solidFill>
+                <a:latin typeface="Cambria" pitchFamily="34" charset="0"/>
+                <a:ea typeface="Cambria" pitchFamily="34" charset="-122"/>
+                <a:cs typeface="Cambria" pitchFamily="34" charset="-120"/>
+              </a:rPr>
+              <a:t> </a:t>
+            </a:r>
+            <a:r>
+              <a:rPr lang="en-US" sz="3000" b="1" dirty="0" err="1">
+                <a:solidFill>
+                  <a:srgbClr val="1E2761"/>
+                </a:solidFill>
+                <a:latin typeface="Cambria" pitchFamily="34" charset="0"/>
+                <a:ea typeface="Cambria" pitchFamily="34" charset="-122"/>
+                <a:cs typeface="Cambria" pitchFamily="34" charset="-120"/>
+              </a:rPr>
+              <a:t>encontrada</a:t>
+            </a:r>
+            <a:r>
+              <a:rPr lang="en-US" sz="3000" b="1" dirty="0">
+                <a:solidFill>
+                  <a:srgbClr val="1E2761"/>
+                </a:solidFill>
+                <a:latin typeface="Cambria" pitchFamily="34" charset="0"/>
+                <a:ea typeface="Cambria" pitchFamily="34" charset="-122"/>
+                <a:cs typeface="Cambria" pitchFamily="34" charset="-120"/>
+              </a:rPr>
+              <a:t> antes de analizar</a:t>
             </a:r>
             <a:endParaRPr lang="en-US" sz="3000" dirty="0"/>
           </a:p>
@@ -14614,7 +14527,106 @@
                 <a:ea typeface="Cambria" pitchFamily="34" charset="-122"/>
                 <a:cs typeface="Cambria" pitchFamily="34" charset="-120"/>
               </a:rPr>
-              <a:t>Un desbalance que condiciona todo el análisis</a:t>
+              <a:t>Un </a:t>
+            </a:r>
+            <a:r>
+              <a:rPr lang="en-US" sz="3000" b="1" dirty="0" err="1">
+                <a:solidFill>
+                  <a:srgbClr val="1E2761"/>
+                </a:solidFill>
+                <a:latin typeface="Cambria" pitchFamily="34" charset="0"/>
+                <a:ea typeface="Cambria" pitchFamily="34" charset="-122"/>
+                <a:cs typeface="Cambria" pitchFamily="34" charset="-120"/>
+              </a:rPr>
+              <a:t>desbalance</a:t>
+            </a:r>
+            <a:r>
+              <a:rPr lang="en-US" sz="3000" b="1" dirty="0">
+                <a:solidFill>
+                  <a:srgbClr val="1E2761"/>
+                </a:solidFill>
+                <a:latin typeface="Cambria" pitchFamily="34" charset="0"/>
+                <a:ea typeface="Cambria" pitchFamily="34" charset="-122"/>
+                <a:cs typeface="Cambria" pitchFamily="34" charset="-120"/>
+              </a:rPr>
+              <a:t> </a:t>
+            </a:r>
+            <a:r>
+              <a:rPr lang="en-US" sz="3000" b="1" dirty="0" err="1">
+                <a:solidFill>
+                  <a:srgbClr val="1E2761"/>
+                </a:solidFill>
+                <a:latin typeface="Cambria" pitchFamily="34" charset="0"/>
+                <a:ea typeface="Cambria" pitchFamily="34" charset="-122"/>
+                <a:cs typeface="Cambria" pitchFamily="34" charset="-120"/>
+              </a:rPr>
+              <a:t>importante</a:t>
+            </a:r>
+            <a:r>
+              <a:rPr lang="en-US" sz="3000" b="1" dirty="0">
+                <a:solidFill>
+                  <a:srgbClr val="1E2761"/>
+                </a:solidFill>
+                <a:latin typeface="Cambria" pitchFamily="34" charset="0"/>
+                <a:ea typeface="Cambria" pitchFamily="34" charset="-122"/>
+                <a:cs typeface="Cambria" pitchFamily="34" charset="-120"/>
+              </a:rPr>
+              <a:t> a </a:t>
+            </a:r>
+            <a:r>
+              <a:rPr lang="en-US" sz="3000" b="1" dirty="0" err="1">
+                <a:solidFill>
+                  <a:srgbClr val="1E2761"/>
+                </a:solidFill>
+                <a:latin typeface="Cambria" pitchFamily="34" charset="0"/>
+                <a:ea typeface="Cambria" pitchFamily="34" charset="-122"/>
+                <a:cs typeface="Cambria" pitchFamily="34" charset="-120"/>
+              </a:rPr>
+              <a:t>tener</a:t>
+            </a:r>
+            <a:r>
+              <a:rPr lang="en-US" sz="3000" b="1" dirty="0">
+                <a:solidFill>
+                  <a:srgbClr val="1E2761"/>
+                </a:solidFill>
+                <a:latin typeface="Cambria" pitchFamily="34" charset="0"/>
+                <a:ea typeface="Cambria" pitchFamily="34" charset="-122"/>
+                <a:cs typeface="Cambria" pitchFamily="34" charset="-120"/>
+              </a:rPr>
+              <a:t> </a:t>
+            </a:r>
+            <a:r>
+              <a:rPr lang="en-US" sz="3000" b="1" dirty="0" err="1">
+                <a:solidFill>
+                  <a:srgbClr val="1E2761"/>
+                </a:solidFill>
+                <a:latin typeface="Cambria" pitchFamily="34" charset="0"/>
+                <a:ea typeface="Cambria" pitchFamily="34" charset="-122"/>
+                <a:cs typeface="Cambria" pitchFamily="34" charset="-120"/>
+              </a:rPr>
+              <a:t>en</a:t>
+            </a:r>
+            <a:r>
+              <a:rPr lang="en-US" sz="3000" b="1" dirty="0">
+                <a:solidFill>
+                  <a:srgbClr val="1E2761"/>
+                </a:solidFill>
+                <a:latin typeface="Cambria" pitchFamily="34" charset="0"/>
+                <a:ea typeface="Cambria" pitchFamily="34" charset="-122"/>
+                <a:cs typeface="Cambria" pitchFamily="34" charset="-120"/>
+              </a:rPr>
+              <a:t> </a:t>
+            </a:r>
+            <a:r>
+              <a:rPr lang="en-US" sz="3000" b="1" dirty="0" err="1">
+                <a:solidFill>
+                  <a:srgbClr val="1E2761"/>
+                </a:solidFill>
+                <a:latin typeface="Cambria" pitchFamily="34" charset="0"/>
+                <a:ea typeface="Cambria" pitchFamily="34" charset="-122"/>
+                <a:cs typeface="Cambria" pitchFamily="34" charset="-120"/>
+              </a:rPr>
+              <a:t>cuenta</a:t>
             </a:r>
             <a:endParaRPr lang="en-US" sz="3000" dirty="0"/>
           </a:p>

</xml_diff>

<commit_message>
feat(eda): completa el analisis exploratorio
</commit_message>
<xml_diff>
--- a/PRESENTACION.pptx
+++ b/PRESENTACION.pptx
@@ -5138,7 +5138,7 @@
                 <a:ea typeface="Calibri" pitchFamily="34" charset="-122"/>
                 <a:cs typeface="Calibri" pitchFamily="34" charset="-120"/>
               </a:rPr>
-              <a:t>Todos los valores están por debajo de 0,13 en una escala de 0 a 1: ninguna variable se relaciona de forma lineal fuerte con la mora por sí sola.</a:t>
+              <a:t>Ninguna variable supera 0,13: no hay relación lineal fuerte. Pero la correlación subestima el poder predictivo con un target al 4,75%. Por tramos, el score va de 64% a 2,9% de mora.</a:t>
             </a:r>
             <a:endParaRPr lang="en-US" sz="1150" dirty="0"/>
           </a:p>
@@ -6172,7 +6172,7 @@
                 <a:ea typeface="Calibri" pitchFamily="34" charset="-122"/>
                 <a:cs typeface="Calibri" pitchFamily="34" charset="-120"/>
               </a:rPr>
-              <a:t>Los ratios cuota/ingreso y deuda/ingreso dieron correlación cercana a 0. Causa: dividen por salario_cliente, variable con 250 valores imputados en la limpieza. Deben recalcularse en la Fase 2 excluyendo esos registros.</a:t>
+              <a:t>Los ratios cuota/ingreso y deuda/ingreso dieron correlación cercana a 0. Se comprobó que NO se debe a los salarios imputados: excluirlos no cambia el resultado. La causa es la métrica — por tramos sí muestran señal débil.</a:t>
             </a:r>
             <a:endParaRPr lang="en-US" sz="1200" dirty="0"/>
           </a:p>
@@ -7336,8 +7336,7 @@
                   <a:srgbClr val="1E2761"/>
                 </a:solidFill>
               </a:rPr>
-              <a:t>puntaje_datacredito es bimodal
-</a:t>
+              <a:t>El score discrimina, pero no linealmente</a:t>
             </a:r>
             <a:endParaRPr lang="en-US" sz="1500" dirty="0"/>
           </a:p>
@@ -7354,7 +7353,7 @@
                   <a:srgbClr val="5A5F73"/>
                 </a:solidFill>
               </a:rPr>
-              <a:t>Un grupo pequeño con score cercano a 0 y el resto concentrado entre 700–999: posiblemente dos poblaciones distintas (con y sin historial suficiente en la central de riesgo).</a:t>
+              <a:t>Por bandas, la tasa de mora va de 64,0% por debajo de 600 puntos a 2,9% por encima de 850. Su correlación de Pearson es solo 0,121.</a:t>
             </a:r>
             <a:endParaRPr lang="en-US" sz="1500" dirty="0"/>
           </a:p>
@@ -7904,7 +7903,7 @@
                 <a:ea typeface="Calibri" pitchFamily="34" charset="-122"/>
                 <a:cs typeface="Calibri" pitchFamily="34" charset="-120"/>
               </a:rPr>
-              <a:t>27% de nulos sin causa estructural</a:t>
+              <a:t>Etiqueta no homogénea en el tiempo</a:t>
             </a:r>
             <a:endParaRPr lang="en-US" sz="1350" dirty="0"/>
           </a:p>
@@ -7946,7 +7945,7 @@
                 <a:ea typeface="Calibri" pitchFamily="34" charset="-122"/>
                 <a:cs typeface="Calibri" pitchFamily="34" charset="-120"/>
               </a:rPr>
-              <a:t>En promedio_ingresos_datacredito, sin patrón identificado que justifique imputar con confianza.</a:t>
+              <a:t>El 19,9% de los créditos vence después del corte de datos: su resultado de pago aún no es definitivo (6,40% vs 4,34%).</a:t>
             </a:r>
             <a:endParaRPr lang="en-US" sz="1200" dirty="0"/>
           </a:p>
@@ -10615,7 +10614,7 @@
                 <a:ea typeface="Cambria" pitchFamily="34" charset="-122"/>
                 <a:cs typeface="Cambria" pitchFamily="34" charset="-120"/>
               </a:rPr>
-              <a:t>153</a:t>
+              <a:t>2.930</a:t>
             </a:r>
             <a:endParaRPr lang="en-US" sz="4000" dirty="0"/>
           </a:p>
@@ -10657,7 +10656,7 @@
                 <a:ea typeface="Calibri" pitchFamily="34" charset="-122"/>
                 <a:cs typeface="Calibri" pitchFamily="34" charset="-120"/>
               </a:rPr>
-              <a:t>clientes sin historial crediticio: 6,54% de mora frente a 4,72%</a:t>
+              <a:t>clientes sin reporte de ingresos en el buró: 5,73% de mora frente a 4,38%</a:t>
             </a:r>
             <a:endParaRPr lang="en-US" sz="1300" dirty="0"/>
           </a:p>
@@ -10739,7 +10738,7 @@
                 <a:ea typeface="Calibri" pitchFamily="34" charset="-122"/>
                 <a:cs typeface="Calibri" pitchFamily="34" charset="-120"/>
               </a:rPr>
-              <a:t>al depurar los 153 scores inválidos, la correlación de puntaje_datacredito con la mora pasó de 0,068 a 0,121 (+78%). Aun así ninguna variable individual supera 0,13 en una escala de 0 a 1.</a:t>
+              <a:t>al depurar los 153 scores inválidos, la correlación de puntaje_datacredito con la mora pasó de 0,068 a 0,121 (+78%). Y por bandas de score la tasa de mora va de 64% a 2,9%: la correlación lineal subestima la señal.</a:t>
             </a:r>
             <a:endParaRPr lang="en-US" sz="1300" dirty="0"/>
           </a:p>

</xml_diff>

<commit_message>
Fase 1: EDA terminado completo
</commit_message>
<xml_diff>
--- a/PRESENTACION.pptx
+++ b/PRESENTACION.pptx
@@ -5138,7 +5138,7 @@
                 <a:ea typeface="Calibri" pitchFamily="34" charset="-122"/>
                 <a:cs typeface="Calibri" pitchFamily="34" charset="-120"/>
               </a:rPr>
-              <a:t>Todos los valores están por debajo de 0,13 en una escala de 0 a 1: ninguna variable se relaciona de forma lineal fuerte con la mora por sí sola.</a:t>
+              <a:t>Ninguna variable supera 0,13: no hay relación lineal fuerte. Pero la correlación subestima el poder predictivo con un target al 4,75%. Por tramos, el score va de 64% a 2,9% de mora.</a:t>
             </a:r>
             <a:endParaRPr lang="en-US" sz="1150" dirty="0"/>
           </a:p>
@@ -6172,7 +6172,7 @@
                 <a:ea typeface="Calibri" pitchFamily="34" charset="-122"/>
                 <a:cs typeface="Calibri" pitchFamily="34" charset="-120"/>
               </a:rPr>
-              <a:t>Los ratios cuota/ingreso y deuda/ingreso dieron correlación cercana a 0. Causa: dividen por salario_cliente, variable con 250 valores imputados en la limpieza. Deben recalcularse en la Fase 2 excluyendo esos registros.</a:t>
+              <a:t>Los ratios cuota/ingreso y deuda/ingreso dieron correlación cercana a 0. Se comprobó que NO se debe a los salarios imputados: excluirlos no cambia el resultado. La causa es la métrica — por tramos sí muestran señal débil.</a:t>
             </a:r>
             <a:endParaRPr lang="en-US" sz="1200" dirty="0"/>
           </a:p>
@@ -7336,8 +7336,7 @@
                   <a:srgbClr val="1E2761"/>
                 </a:solidFill>
               </a:rPr>
-              <a:t>puntaje_datacredito es bimodal
-</a:t>
+              <a:t>El score discrimina, pero no linealmente</a:t>
             </a:r>
             <a:endParaRPr lang="en-US" sz="1500" dirty="0"/>
           </a:p>
@@ -7354,7 +7353,7 @@
                   <a:srgbClr val="5A5F73"/>
                 </a:solidFill>
               </a:rPr>
-              <a:t>Un grupo pequeño con score cercano a 0 y el resto concentrado entre 700–999: posiblemente dos poblaciones distintas (con y sin historial suficiente en la central de riesgo).</a:t>
+              <a:t>Por bandas, la tasa de mora va de 64,0% por debajo de 600 puntos a 2,9% por encima de 850. Su correlación de Pearson es solo 0,121.</a:t>
             </a:r>
             <a:endParaRPr lang="en-US" sz="1500" dirty="0"/>
           </a:p>
@@ -7904,7 +7903,7 @@
                 <a:ea typeface="Calibri" pitchFamily="34" charset="-122"/>
                 <a:cs typeface="Calibri" pitchFamily="34" charset="-120"/>
               </a:rPr>
-              <a:t>27% de nulos sin causa estructural</a:t>
+              <a:t>Etiqueta no homogénea en el tiempo</a:t>
             </a:r>
             <a:endParaRPr lang="en-US" sz="1350" dirty="0"/>
           </a:p>
@@ -7946,7 +7945,7 @@
                 <a:ea typeface="Calibri" pitchFamily="34" charset="-122"/>
                 <a:cs typeface="Calibri" pitchFamily="34" charset="-120"/>
               </a:rPr>
-              <a:t>En promedio_ingresos_datacredito, sin patrón identificado que justifique imputar con confianza.</a:t>
+              <a:t>El 19,9% de los créditos vence después del corte de datos: su resultado de pago aún no es definitivo (6,40% vs 4,34%).</a:t>
             </a:r>
             <a:endParaRPr lang="en-US" sz="1200" dirty="0"/>
           </a:p>
@@ -10615,7 +10614,7 @@
                 <a:ea typeface="Cambria" pitchFamily="34" charset="-122"/>
                 <a:cs typeface="Cambria" pitchFamily="34" charset="-120"/>
               </a:rPr>
-              <a:t>153</a:t>
+              <a:t>2.930</a:t>
             </a:r>
             <a:endParaRPr lang="en-US" sz="4000" dirty="0"/>
           </a:p>
@@ -10657,7 +10656,7 @@
                 <a:ea typeface="Calibri" pitchFamily="34" charset="-122"/>
                 <a:cs typeface="Calibri" pitchFamily="34" charset="-120"/>
               </a:rPr>
-              <a:t>clientes sin historial crediticio: 6,54% de mora frente a 4,72%</a:t>
+              <a:t>clientes sin reporte de ingresos en el buró: 5,73% de mora frente a 4,38%</a:t>
             </a:r>
             <a:endParaRPr lang="en-US" sz="1300" dirty="0"/>
           </a:p>
@@ -10739,7 +10738,7 @@
                 <a:ea typeface="Calibri" pitchFamily="34" charset="-122"/>
                 <a:cs typeface="Calibri" pitchFamily="34" charset="-120"/>
               </a:rPr>
-              <a:t>al depurar los 153 scores inválidos, la correlación de puntaje_datacredito con la mora pasó de 0,068 a 0,121 (+78%). Aun así ninguna variable individual supera 0,13 en una escala de 0 a 1.</a:t>
+              <a:t>al depurar los 153 scores inválidos, la correlación de puntaje_datacredito con la mora pasó de 0,068 a 0,121 (+78%). Y por bandas de score la tasa de mora va de 64% a 2,9%: la correlación lineal subestima la señal.</a:t>
             </a:r>
             <a:endParaRPr lang="en-US" sz="1300" dirty="0"/>
           </a:p>

</xml_diff>

<commit_message>
Fase 1: confirmacion de fuga en saldo_mora
</commit_message>
<xml_diff>
--- a/PRESENTACION.pptx
+++ b/PRESENTACION.pptx
@@ -10380,7 +10380,7 @@
                 <a:ea typeface="Cambria" pitchFamily="34" charset="-122"/>
                 <a:cs typeface="Cambria" pitchFamily="34" charset="-120"/>
               </a:rPr>
-              <a:t>8x</a:t>
+              <a:t>3,2x</a:t>
             </a:r>
             <a:endParaRPr lang="en-US" sz="4000" dirty="0"/>
           </a:p>
@@ -10422,7 +10422,7 @@
                 <a:ea typeface="Calibri" pitchFamily="34" charset="-122"/>
                 <a:cs typeface="Calibri" pitchFamily="34" charset="-120"/>
               </a:rPr>
-              <a:t>más riesgo de mora si el cliente ya registraba saldo en mora (36,4% vs 4,6%)</a:t>
+              <a:t>más mora en créditos a 24–36 meses que a 6–12 meses (12,66% vs 3,91%)</a:t>
             </a:r>
             <a:endParaRPr lang="en-US" sz="1300" dirty="0"/>
           </a:p>

</xml_diff>

<commit_message>
feat(eda): confirma la fuga de informacion en saldo_mora
</commit_message>
<xml_diff>
--- a/PRESENTACION.pptx
+++ b/PRESENTACION.pptx
@@ -10380,7 +10380,7 @@
                 <a:ea typeface="Cambria" pitchFamily="34" charset="-122"/>
                 <a:cs typeface="Cambria" pitchFamily="34" charset="-120"/>
               </a:rPr>
-              <a:t>8x</a:t>
+              <a:t>3,2x</a:t>
             </a:r>
             <a:endParaRPr lang="en-US" sz="4000" dirty="0"/>
           </a:p>
@@ -10422,7 +10422,7 @@
                 <a:ea typeface="Calibri" pitchFamily="34" charset="-122"/>
                 <a:cs typeface="Calibri" pitchFamily="34" charset="-120"/>
               </a:rPr>
-              <a:t>más riesgo de mora si el cliente ya registraba saldo en mora (36,4% vs 4,6%)</a:t>
+              <a:t>más mora en créditos a 24–36 meses que a 6–12 meses (12,66% vs 3,91%)</a:t>
             </a:r>
             <a:endParaRPr lang="en-US" sz="1300" dirty="0"/>
           </a:p>

</xml_diff>